<commit_message>
slides: draw page 10 as the target-state agent architecture
The page had only its header. It now carries the three layers the loop is
made of: the objective layer derives the ceiling from the model config and
the hardware spec alone and splits the gap into working point, per step and
inter step; the planning layer answers each term at its own scale, the outer
ring picking the working point and the inner ring closing on the roofline at
that point; the verdict layer keeps the deck's rule, simulation may only
eliminate and real hardware alone may admit. A spine on the left closes the
loop back into the objective layer.
</commit_message>
<xml_diff>
--- a/slides/m100_agent_final_deck.pptx
+++ b/slides/m100_agent_final_deck.pptx
@@ -4659,6 +4659,2982 @@
       <p:sp>
         <p:nvSpPr>
           <p:cNvPr id="5" name="TextBox 4"/>
+          <p:cNvSpPr txBox="1"/>
+          <p:nvPr/>
+        </p:nvSpPr>
+        <p:spPr>
+          <a:xfrm>
+            <a:off x="566928" y="859536"/>
+            <a:ext cx="9592056" cy="310896"/>
+          </a:xfrm>
+          <a:prstGeom prst="rect">
+            <a:avLst/>
+          </a:prstGeom>
+          <a:noFill/>
+        </p:spPr>
+        <p:txBody>
+          <a:bodyPr wrap="square" anchor="ctr" lIns="0" tIns="0" rIns="0" bIns="0">
+            <a:noAutofit/>
+          </a:bodyPr>
+          <a:lstStyle/>
+          <a:p>
+            <a:pPr algn="l" latinLnBrk="0">
+              <a:lnSpc>
+                <a:spcPct val="100000"/>
+              </a:lnSpc>
+              <a:spcBef>
+                <a:spcPts val="0"/>
+              </a:spcBef>
+              <a:spcAft>
+                <a:spcPts val="0"/>
+              </a:spcAft>
+            </a:pPr>
+            <a:r>
+              <a:rPr sz="1250" b="0">
+                <a:solidFill>
+                  <a:srgbClr val="1B4D69"/>
+                </a:solidFill>
+                <a:latin typeface="Microsoft YaHei"/>
+                <a:ea typeface="Microsoft YaHei"/>
+                <a:cs typeface="Microsoft YaHei"/>
+              </a:rPr>
+              <a:t>目标态：算子 · 计算图 · 引擎三层协同；目标由约束推导，判决仍交给真机实测</a:t>
+            </a:r>
+          </a:p>
+        </p:txBody>
+      </p:sp>
+      <p:sp>
+        <p:nvSpPr>
+          <p:cNvPr id="6" name="Rectangle 5"/>
+          <p:cNvSpPr/>
+          <p:nvPr/>
+        </p:nvSpPr>
+        <p:spPr>
+          <a:xfrm>
+            <a:off x="950976" y="1243584"/>
+            <a:ext cx="10692079" cy="914400"/>
+          </a:xfrm>
+          <a:prstGeom prst="rect">
+            <a:avLst/>
+          </a:prstGeom>
+          <a:solidFill>
+            <a:srgbClr val="F2F8FD"/>
+          </a:solidFill>
+          <a:ln>
+            <a:noFill/>
+          </a:ln>
+        </p:spPr>
+        <p:txBody>
+          <a:bodyPr rtlCol="0" anchor="ctr"/>
+          <a:lstStyle/>
+          <a:p>
+            <a:pPr algn="ctr"/>
+          </a:p>
+        </p:txBody>
+      </p:sp>
+      <p:sp>
+        <p:nvSpPr>
+          <p:cNvPr id="7" name="Rectangle 6"/>
+          <p:cNvSpPr/>
+          <p:nvPr/>
+        </p:nvSpPr>
+        <p:spPr>
+          <a:xfrm>
+            <a:off x="950976" y="1243584"/>
+            <a:ext cx="64008" cy="914400"/>
+          </a:xfrm>
+          <a:prstGeom prst="rect">
+            <a:avLst/>
+          </a:prstGeom>
+          <a:solidFill>
+            <a:srgbClr val="0F62CE"/>
+          </a:solidFill>
+          <a:ln>
+            <a:noFill/>
+          </a:ln>
+        </p:spPr>
+        <p:txBody>
+          <a:bodyPr rtlCol="0" anchor="ctr"/>
+          <a:lstStyle/>
+          <a:p>
+            <a:pPr algn="ctr"/>
+          </a:p>
+        </p:txBody>
+      </p:sp>
+      <p:sp>
+        <p:nvSpPr>
+          <p:cNvPr id="8" name="TextBox 7"/>
+          <p:cNvSpPr txBox="1"/>
+          <p:nvPr/>
+        </p:nvSpPr>
+        <p:spPr>
+          <a:xfrm>
+            <a:off x="1170432" y="1316736"/>
+            <a:ext cx="1188720" cy="768096"/>
+          </a:xfrm>
+          <a:prstGeom prst="rect">
+            <a:avLst/>
+          </a:prstGeom>
+          <a:noFill/>
+        </p:spPr>
+        <p:txBody>
+          <a:bodyPr wrap="square" anchor="ctr" lIns="0" tIns="0" rIns="0" bIns="0">
+            <a:noAutofit/>
+          </a:bodyPr>
+          <a:lstStyle/>
+          <a:p>
+            <a:pPr algn="l" latinLnBrk="0">
+              <a:lnSpc>
+                <a:spcPct val="100000"/>
+              </a:lnSpc>
+              <a:spcBef>
+                <a:spcPts val="0"/>
+              </a:spcBef>
+              <a:spcAft>
+                <a:spcPts val="300"/>
+              </a:spcAft>
+            </a:pPr>
+            <a:r>
+              <a:rPr sz="1400" b="1">
+                <a:solidFill>
+                  <a:srgbClr val="0A2B45"/>
+                </a:solidFill>
+                <a:latin typeface="Microsoft YaHei"/>
+                <a:ea typeface="Microsoft YaHei"/>
+                <a:cs typeface="Microsoft YaHei"/>
+              </a:rPr>
+              <a:t>目标层</a:t>
+            </a:r>
+          </a:p>
+          <a:p>
+            <a:pPr algn="l" latinLnBrk="0">
+              <a:lnSpc>
+                <a:spcPct val="100000"/>
+              </a:lnSpc>
+              <a:spcBef>
+                <a:spcPts val="0"/>
+              </a:spcBef>
+              <a:spcAft>
+                <a:spcPts val="0"/>
+              </a:spcAft>
+            </a:pPr>
+            <a:r>
+              <a:rPr sz="900" b="0">
+                <a:solidFill>
+                  <a:srgbClr val="40708B"/>
+                </a:solidFill>
+                <a:latin typeface="Microsoft YaHei"/>
+                <a:ea typeface="Microsoft YaHei"/>
+                <a:cs typeface="Microsoft YaHei"/>
+              </a:rPr>
+              <a:t>定靶子 · 拆差距</a:t>
+            </a:r>
+          </a:p>
+        </p:txBody>
+      </p:sp>
+      <p:sp>
+        <p:nvSpPr>
+          <p:cNvPr id="9" name="Rectangle 8"/>
+          <p:cNvSpPr/>
+          <p:nvPr/>
+        </p:nvSpPr>
+        <p:spPr>
+          <a:xfrm>
+            <a:off x="2578608" y="1335024"/>
+            <a:ext cx="1737360" cy="731520"/>
+          </a:xfrm>
+          <a:prstGeom prst="rect">
+            <a:avLst/>
+          </a:prstGeom>
+          <a:solidFill>
+            <a:srgbClr val="FFFFFF"/>
+          </a:solidFill>
+          <a:ln w="9525">
+            <a:solidFill>
+              <a:srgbClr val="CFE3F0"/>
+            </a:solidFill>
+          </a:ln>
+        </p:spPr>
+        <p:txBody>
+          <a:bodyPr rtlCol="0" anchor="ctr"/>
+          <a:lstStyle/>
+          <a:p>
+            <a:pPr algn="ctr"/>
+          </a:p>
+        </p:txBody>
+      </p:sp>
+      <p:sp>
+        <p:nvSpPr>
+          <p:cNvPr id="10" name="TextBox 9"/>
+          <p:cNvSpPr txBox="1"/>
+          <p:nvPr/>
+        </p:nvSpPr>
+        <p:spPr>
+          <a:xfrm>
+            <a:off x="2779776" y="1389888"/>
+            <a:ext cx="1371600" cy="621792"/>
+          </a:xfrm>
+          <a:prstGeom prst="rect">
+            <a:avLst/>
+          </a:prstGeom>
+          <a:noFill/>
+        </p:spPr>
+        <p:txBody>
+          <a:bodyPr wrap="square" anchor="ctr" lIns="0" tIns="0" rIns="0" bIns="0">
+            <a:noAutofit/>
+          </a:bodyPr>
+          <a:lstStyle/>
+          <a:p>
+            <a:pPr algn="l" latinLnBrk="0">
+              <a:lnSpc>
+                <a:spcPct val="100000"/>
+              </a:lnSpc>
+              <a:spcBef>
+                <a:spcPts val="0"/>
+              </a:spcBef>
+              <a:spcAft>
+                <a:spcPts val="400"/>
+              </a:spcAft>
+            </a:pPr>
+            <a:r>
+              <a:rPr sz="1150" b="1">
+                <a:solidFill>
+                  <a:srgbClr val="0A2B45"/>
+                </a:solidFill>
+                <a:latin typeface="Microsoft YaHei"/>
+                <a:ea typeface="Microsoft YaHei"/>
+                <a:cs typeface="Microsoft YaHei"/>
+              </a:rPr>
+              <a:t>人</a:t>
+            </a:r>
+          </a:p>
+          <a:p>
+            <a:pPr algn="l" latinLnBrk="0">
+              <a:lnSpc>
+                <a:spcPct val="100000"/>
+              </a:lnSpc>
+              <a:spcBef>
+                <a:spcPts val="0"/>
+              </a:spcBef>
+              <a:spcAft>
+                <a:spcPts val="200"/>
+              </a:spcAft>
+            </a:pPr>
+            <a:r>
+              <a:rPr sz="950" b="0">
+                <a:solidFill>
+                  <a:srgbClr val="1B4D69"/>
+                </a:solidFill>
+                <a:latin typeface="Microsoft YaHei"/>
+                <a:ea typeface="Microsoft YaHei"/>
+                <a:cs typeface="Microsoft YaHei"/>
+              </a:rPr>
+              <a:t>流量画像</a:t>
+            </a:r>
+          </a:p>
+          <a:p>
+            <a:pPr algn="l" latinLnBrk="0">
+              <a:lnSpc>
+                <a:spcPct val="100000"/>
+              </a:lnSpc>
+              <a:spcBef>
+                <a:spcPts val="0"/>
+              </a:spcBef>
+              <a:spcAft>
+                <a:spcPts val="200"/>
+              </a:spcAft>
+            </a:pPr>
+            <a:r>
+              <a:rPr sz="950" b="0">
+                <a:solidFill>
+                  <a:srgbClr val="1B4D69"/>
+                </a:solidFill>
+                <a:latin typeface="Microsoft YaHei"/>
+                <a:ea typeface="Microsoft YaHei"/>
+                <a:cs typeface="Microsoft YaHei"/>
+              </a:rPr>
+              <a:t>时延约束</a:t>
+            </a:r>
+          </a:p>
+        </p:txBody>
+      </p:sp>
+      <p:cxnSp>
+        <p:nvCxnSpPr>
+          <p:cNvPr id="11" name="Connector 10"/>
+          <p:cNvCxnSpPr/>
+          <p:nvPr/>
+        </p:nvCxnSpPr>
+        <p:spPr>
+          <a:xfrm>
+            <a:off x="4389120" y="1700784"/>
+            <a:ext cx="237744" cy="0"/>
+          </a:xfrm>
+          <a:prstGeom prst="line">
+            <a:avLst/>
+          </a:prstGeom>
+          <a:ln w="15875">
+            <a:solidFill>
+              <a:srgbClr val="0F62CE"/>
+            </a:solidFill>
+            <a:tailEnd type="triangle" w="med" len="med"/>
+          </a:ln>
+        </p:spPr>
+      </p:cxnSp>
+      <p:sp>
+        <p:nvSpPr>
+          <p:cNvPr id="12" name="Rectangle 11"/>
+          <p:cNvSpPr/>
+          <p:nvPr/>
+        </p:nvSpPr>
+        <p:spPr>
+          <a:xfrm>
+            <a:off x="4681728" y="1335024"/>
+            <a:ext cx="3246120" cy="731520"/>
+          </a:xfrm>
+          <a:prstGeom prst="rect">
+            <a:avLst/>
+          </a:prstGeom>
+          <a:solidFill>
+            <a:srgbClr val="FFFFFF"/>
+          </a:solidFill>
+          <a:ln w="9525">
+            <a:solidFill>
+              <a:srgbClr val="CFE3F0"/>
+            </a:solidFill>
+          </a:ln>
+        </p:spPr>
+        <p:txBody>
+          <a:bodyPr rtlCol="0" anchor="ctr"/>
+          <a:lstStyle/>
+          <a:p>
+            <a:pPr algn="ctr"/>
+          </a:p>
+        </p:txBody>
+      </p:sp>
+      <p:sp>
+        <p:nvSpPr>
+          <p:cNvPr id="13" name="TextBox 12"/>
+          <p:cNvSpPr txBox="1"/>
+          <p:nvPr/>
+        </p:nvSpPr>
+        <p:spPr>
+          <a:xfrm>
+            <a:off x="4882896" y="1389888"/>
+            <a:ext cx="2880360" cy="621792"/>
+          </a:xfrm>
+          <a:prstGeom prst="rect">
+            <a:avLst/>
+          </a:prstGeom>
+          <a:noFill/>
+        </p:spPr>
+        <p:txBody>
+          <a:bodyPr wrap="square" anchor="ctr" lIns="0" tIns="0" rIns="0" bIns="0">
+            <a:noAutofit/>
+          </a:bodyPr>
+          <a:lstStyle/>
+          <a:p>
+            <a:pPr algn="l" latinLnBrk="0">
+              <a:lnSpc>
+                <a:spcPct val="100000"/>
+              </a:lnSpc>
+              <a:spcBef>
+                <a:spcPts val="0"/>
+              </a:spcBef>
+              <a:spcAft>
+                <a:spcPts val="400"/>
+              </a:spcAft>
+            </a:pPr>
+            <a:r>
+              <a:rPr sz="1150" b="1">
+                <a:solidFill>
+                  <a:srgbClr val="0A2B45"/>
+                </a:solidFill>
+                <a:latin typeface="Microsoft YaHei"/>
+                <a:ea typeface="Microsoft YaHei"/>
+                <a:cs typeface="Microsoft YaHei"/>
+              </a:rPr>
+              <a:t>上限核算器 · 无模型</a:t>
+            </a:r>
+          </a:p>
+          <a:p>
+            <a:pPr algn="l" latinLnBrk="0">
+              <a:lnSpc>
+                <a:spcPct val="100000"/>
+              </a:lnSpc>
+              <a:spcBef>
+                <a:spcPts val="0"/>
+              </a:spcBef>
+              <a:spcAft>
+                <a:spcPts val="200"/>
+              </a:spcAft>
+            </a:pPr>
+            <a:r>
+              <a:rPr sz="950" b="0">
+                <a:solidFill>
+                  <a:srgbClr val="1B4D69"/>
+                </a:solidFill>
+                <a:latin typeface="Microsoft YaHei"/>
+                <a:ea typeface="Microsoft YaHei"/>
+                <a:cs typeface="Microsoft YaHei"/>
+              </a:rPr>
+              <a:t>只用模型配置 + 硬件规格</a:t>
+            </a:r>
+          </a:p>
+          <a:p>
+            <a:pPr algn="l" latinLnBrk="0">
+              <a:lnSpc>
+                <a:spcPct val="100000"/>
+              </a:lnSpc>
+              <a:spcBef>
+                <a:spcPts val="0"/>
+              </a:spcBef>
+              <a:spcAft>
+                <a:spcPts val="200"/>
+              </a:spcAft>
+            </a:pPr>
+            <a:r>
+              <a:rPr sz="950" b="0">
+                <a:solidFill>
+                  <a:srgbClr val="1B4D69"/>
+                </a:solidFill>
+                <a:latin typeface="Microsoft YaHei"/>
+                <a:ea typeface="Microsoft YaHei"/>
+                <a:cs typeface="Microsoft YaHei"/>
+              </a:rPr>
+              <a:t>上限不用实测去凑</a:t>
+            </a:r>
+          </a:p>
+        </p:txBody>
+      </p:sp>
+      <p:cxnSp>
+        <p:nvCxnSpPr>
+          <p:cNvPr id="14" name="Connector 13"/>
+          <p:cNvCxnSpPr/>
+          <p:nvPr/>
+        </p:nvCxnSpPr>
+        <p:spPr>
+          <a:xfrm>
+            <a:off x="8001000" y="1700784"/>
+            <a:ext cx="237744" cy="0"/>
+          </a:xfrm>
+          <a:prstGeom prst="line">
+            <a:avLst/>
+          </a:prstGeom>
+          <a:ln w="15875">
+            <a:solidFill>
+              <a:srgbClr val="0F62CE"/>
+            </a:solidFill>
+            <a:tailEnd type="triangle" w="med" len="med"/>
+          </a:ln>
+        </p:spPr>
+      </p:cxnSp>
+      <p:sp>
+        <p:nvSpPr>
+          <p:cNvPr id="15" name="Rectangle 14"/>
+          <p:cNvSpPr/>
+          <p:nvPr/>
+        </p:nvSpPr>
+        <p:spPr>
+          <a:xfrm>
+            <a:off x="8293608" y="1335024"/>
+            <a:ext cx="3346704" cy="731520"/>
+          </a:xfrm>
+          <a:prstGeom prst="rect">
+            <a:avLst/>
+          </a:prstGeom>
+          <a:solidFill>
+            <a:srgbClr val="FFFFFF"/>
+          </a:solidFill>
+          <a:ln w="9525">
+            <a:solidFill>
+              <a:srgbClr val="CFE3F0"/>
+            </a:solidFill>
+          </a:ln>
+        </p:spPr>
+        <p:txBody>
+          <a:bodyPr rtlCol="0" anchor="ctr"/>
+          <a:lstStyle/>
+          <a:p>
+            <a:pPr algn="ctr"/>
+          </a:p>
+        </p:txBody>
+      </p:sp>
+      <p:sp>
+        <p:nvSpPr>
+          <p:cNvPr id="16" name="TextBox 15"/>
+          <p:cNvSpPr txBox="1"/>
+          <p:nvPr/>
+        </p:nvSpPr>
+        <p:spPr>
+          <a:xfrm>
+            <a:off x="8494776" y="1389888"/>
+            <a:ext cx="2980944" cy="621792"/>
+          </a:xfrm>
+          <a:prstGeom prst="rect">
+            <a:avLst/>
+          </a:prstGeom>
+          <a:noFill/>
+        </p:spPr>
+        <p:txBody>
+          <a:bodyPr wrap="square" anchor="ctr" lIns="0" tIns="0" rIns="0" bIns="0">
+            <a:noAutofit/>
+          </a:bodyPr>
+          <a:lstStyle/>
+          <a:p>
+            <a:pPr algn="l" latinLnBrk="0">
+              <a:lnSpc>
+                <a:spcPct val="100000"/>
+              </a:lnSpc>
+              <a:spcBef>
+                <a:spcPts val="0"/>
+              </a:spcBef>
+              <a:spcAft>
+                <a:spcPts val="400"/>
+              </a:spcAft>
+            </a:pPr>
+            <a:r>
+              <a:rPr sz="1150" b="1">
+                <a:solidFill>
+                  <a:srgbClr val="0A2B45"/>
+                </a:solidFill>
+                <a:latin typeface="Microsoft YaHei"/>
+                <a:ea typeface="Microsoft YaHei"/>
+                <a:cs typeface="Microsoft YaHei"/>
+              </a:rPr>
+              <a:t>总差距拆成三项</a:t>
+            </a:r>
+          </a:p>
+          <a:p>
+            <a:pPr algn="l" latinLnBrk="0">
+              <a:lnSpc>
+                <a:spcPct val="100000"/>
+              </a:lnSpc>
+              <a:spcBef>
+                <a:spcPts val="0"/>
+              </a:spcBef>
+              <a:spcAft>
+                <a:spcPts val="200"/>
+              </a:spcAft>
+            </a:pPr>
+            <a:r>
+              <a:rPr sz="950" b="0">
+                <a:solidFill>
+                  <a:srgbClr val="1B4D69"/>
+                </a:solidFill>
+                <a:latin typeface="Microsoft YaHei"/>
+                <a:ea typeface="Microsoft YaHei"/>
+                <a:cs typeface="Microsoft YaHei"/>
+              </a:rPr>
+              <a:t>工作点 × 单步 × 步间</a:t>
+            </a:r>
+          </a:p>
+          <a:p>
+            <a:pPr algn="l" latinLnBrk="0">
+              <a:lnSpc>
+                <a:spcPct val="100000"/>
+              </a:lnSpc>
+              <a:spcBef>
+                <a:spcPts val="0"/>
+              </a:spcBef>
+              <a:spcAft>
+                <a:spcPts val="200"/>
+              </a:spcAft>
+            </a:pPr>
+            <a:r>
+              <a:rPr sz="950" b="0">
+                <a:solidFill>
+                  <a:srgbClr val="1B4D69"/>
+                </a:solidFill>
+                <a:latin typeface="Microsoft YaHei"/>
+                <a:ea typeface="Microsoft YaHei"/>
+                <a:cs typeface="Microsoft YaHei"/>
+              </a:rPr>
+              <a:t>每一项都有明确的主人</a:t>
+            </a:r>
+          </a:p>
+        </p:txBody>
+      </p:sp>
+      <p:cxnSp>
+        <p:nvCxnSpPr>
+          <p:cNvPr id="17" name="Connector 16"/>
+          <p:cNvCxnSpPr/>
+          <p:nvPr/>
+        </p:nvCxnSpPr>
+        <p:spPr>
+          <a:xfrm>
+            <a:off x="2578608" y="2331720"/>
+            <a:ext cx="9064447" cy="0"/>
+          </a:xfrm>
+          <a:prstGeom prst="line">
+            <a:avLst/>
+          </a:prstGeom>
+          <a:ln w="9525">
+            <a:solidFill>
+              <a:srgbClr val="AFCEE1"/>
+            </a:solidFill>
+            <a:prstDash val="dash"/>
+          </a:ln>
+        </p:spPr>
+      </p:cxnSp>
+      <p:sp>
+        <p:nvSpPr>
+          <p:cNvPr id="18" name="Rectangle 17"/>
+          <p:cNvSpPr/>
+          <p:nvPr/>
+        </p:nvSpPr>
+        <p:spPr>
+          <a:xfrm>
+            <a:off x="2578608" y="2212848"/>
+            <a:ext cx="2651760" cy="237744"/>
+          </a:xfrm>
+          <a:prstGeom prst="rect">
+            <a:avLst/>
+          </a:prstGeom>
+          <a:solidFill>
+            <a:srgbClr val="F2F8FD"/>
+          </a:solidFill>
+          <a:ln>
+            <a:noFill/>
+          </a:ln>
+        </p:spPr>
+        <p:txBody>
+          <a:bodyPr rtlCol="0" anchor="ctr"/>
+          <a:lstStyle/>
+          <a:p>
+            <a:pPr algn="ctr"/>
+          </a:p>
+        </p:txBody>
+      </p:sp>
+      <p:sp>
+        <p:nvSpPr>
+          <p:cNvPr id="19" name="TextBox 18"/>
+          <p:cNvSpPr txBox="1"/>
+          <p:nvPr/>
+        </p:nvSpPr>
+        <p:spPr>
+          <a:xfrm>
+            <a:off x="2578608" y="2212848"/>
+            <a:ext cx="2651760" cy="237744"/>
+          </a:xfrm>
+          <a:prstGeom prst="rect">
+            <a:avLst/>
+          </a:prstGeom>
+          <a:noFill/>
+        </p:spPr>
+        <p:txBody>
+          <a:bodyPr wrap="square" anchor="ctr" lIns="0" tIns="0" rIns="0" bIns="0">
+            <a:noAutofit/>
+          </a:bodyPr>
+          <a:lstStyle/>
+          <a:p>
+            <a:pPr algn="ctr" latinLnBrk="0">
+              <a:lnSpc>
+                <a:spcPct val="100000"/>
+              </a:lnSpc>
+              <a:spcBef>
+                <a:spcPts val="0"/>
+              </a:spcBef>
+              <a:spcAft>
+                <a:spcPts val="0"/>
+              </a:spcAft>
+            </a:pPr>
+            <a:r>
+              <a:rPr sz="950" b="0">
+                <a:solidFill>
+                  <a:srgbClr val="40708B"/>
+                </a:solidFill>
+                <a:latin typeface="Microsoft YaHei"/>
+                <a:ea typeface="Microsoft YaHei"/>
+                <a:cs typeface="Microsoft YaHei"/>
+              </a:rPr>
+              <a:t>↓　派单：按差距排序，标明归属尺度</a:t>
+            </a:r>
+          </a:p>
+        </p:txBody>
+      </p:sp>
+      <p:sp>
+        <p:nvSpPr>
+          <p:cNvPr id="20" name="Rectangle 19"/>
+          <p:cNvSpPr/>
+          <p:nvPr/>
+        </p:nvSpPr>
+        <p:spPr>
+          <a:xfrm>
+            <a:off x="950976" y="2505456"/>
+            <a:ext cx="10692079" cy="1993392"/>
+          </a:xfrm>
+          <a:prstGeom prst="rect">
+            <a:avLst/>
+          </a:prstGeom>
+          <a:solidFill>
+            <a:srgbClr val="F2F8FD"/>
+          </a:solidFill>
+          <a:ln>
+            <a:noFill/>
+          </a:ln>
+        </p:spPr>
+        <p:txBody>
+          <a:bodyPr rtlCol="0" anchor="ctr"/>
+          <a:lstStyle/>
+          <a:p>
+            <a:pPr algn="ctr"/>
+          </a:p>
+        </p:txBody>
+      </p:sp>
+      <p:sp>
+        <p:nvSpPr>
+          <p:cNvPr id="21" name="Rectangle 20"/>
+          <p:cNvSpPr/>
+          <p:nvPr/>
+        </p:nvSpPr>
+        <p:spPr>
+          <a:xfrm>
+            <a:off x="950976" y="2505456"/>
+            <a:ext cx="64008" cy="1993392"/>
+          </a:xfrm>
+          <a:prstGeom prst="rect">
+            <a:avLst/>
+          </a:prstGeom>
+          <a:solidFill>
+            <a:srgbClr val="D2690C"/>
+          </a:solidFill>
+          <a:ln>
+            <a:noFill/>
+          </a:ln>
+        </p:spPr>
+        <p:txBody>
+          <a:bodyPr rtlCol="0" anchor="ctr"/>
+          <a:lstStyle/>
+          <a:p>
+            <a:pPr algn="ctr"/>
+          </a:p>
+        </p:txBody>
+      </p:sp>
+      <p:sp>
+        <p:nvSpPr>
+          <p:cNvPr id="22" name="TextBox 21"/>
+          <p:cNvSpPr txBox="1"/>
+          <p:nvPr/>
+        </p:nvSpPr>
+        <p:spPr>
+          <a:xfrm>
+            <a:off x="1170432" y="2578608"/>
+            <a:ext cx="1188720" cy="1847088"/>
+          </a:xfrm>
+          <a:prstGeom prst="rect">
+            <a:avLst/>
+          </a:prstGeom>
+          <a:noFill/>
+        </p:spPr>
+        <p:txBody>
+          <a:bodyPr wrap="square" anchor="ctr" lIns="0" tIns="0" rIns="0" bIns="0">
+            <a:noAutofit/>
+          </a:bodyPr>
+          <a:lstStyle/>
+          <a:p>
+            <a:pPr algn="l" latinLnBrk="0">
+              <a:lnSpc>
+                <a:spcPct val="100000"/>
+              </a:lnSpc>
+              <a:spcBef>
+                <a:spcPts val="0"/>
+              </a:spcBef>
+              <a:spcAft>
+                <a:spcPts val="300"/>
+              </a:spcAft>
+            </a:pPr>
+            <a:r>
+              <a:rPr sz="1400" b="1">
+                <a:solidFill>
+                  <a:srgbClr val="0A2B45"/>
+                </a:solidFill>
+                <a:latin typeface="Microsoft YaHei"/>
+                <a:ea typeface="Microsoft YaHei"/>
+                <a:cs typeface="Microsoft YaHei"/>
+              </a:rPr>
+              <a:t>规划层</a:t>
+            </a:r>
+          </a:p>
+          <a:p>
+            <a:pPr algn="l" latinLnBrk="0">
+              <a:lnSpc>
+                <a:spcPct val="100000"/>
+              </a:lnSpc>
+              <a:spcBef>
+                <a:spcPts val="0"/>
+              </a:spcBef>
+              <a:spcAft>
+                <a:spcPts val="0"/>
+              </a:spcAft>
+            </a:pPr>
+            <a:r>
+              <a:rPr sz="900" b="0">
+                <a:solidFill>
+                  <a:srgbClr val="40708B"/>
+                </a:solidFill>
+                <a:latin typeface="Microsoft YaHei"/>
+                <a:ea typeface="Microsoft YaHei"/>
+                <a:cs typeface="Microsoft YaHei"/>
+              </a:rPr>
+              <a:t>外环定工作点 · 内环逼近屋顶</a:t>
+            </a:r>
+          </a:p>
+        </p:txBody>
+      </p:sp>
+      <p:sp>
+        <p:nvSpPr>
+          <p:cNvPr id="23" name="Rectangle 22"/>
+          <p:cNvSpPr/>
+          <p:nvPr/>
+        </p:nvSpPr>
+        <p:spPr>
+          <a:xfrm>
+            <a:off x="2578608" y="2578608"/>
+            <a:ext cx="9064447" cy="676656"/>
+          </a:xfrm>
+          <a:prstGeom prst="rect">
+            <a:avLst/>
+          </a:prstGeom>
+          <a:solidFill>
+            <a:srgbClr val="FFFFFF"/>
+          </a:solidFill>
+          <a:ln w="9525">
+            <a:solidFill>
+              <a:srgbClr val="CFE3F0"/>
+            </a:solidFill>
+          </a:ln>
+        </p:spPr>
+        <p:txBody>
+          <a:bodyPr rtlCol="0" anchor="ctr"/>
+          <a:lstStyle/>
+          <a:p>
+            <a:pPr algn="ctr"/>
+          </a:p>
+        </p:txBody>
+      </p:sp>
+      <p:sp>
+        <p:nvSpPr>
+          <p:cNvPr id="24" name="TextBox 23"/>
+          <p:cNvSpPr txBox="1"/>
+          <p:nvPr/>
+        </p:nvSpPr>
+        <p:spPr>
+          <a:xfrm>
+            <a:off x="2779776" y="2615184"/>
+            <a:ext cx="1828800" cy="237744"/>
+          </a:xfrm>
+          <a:prstGeom prst="rect">
+            <a:avLst/>
+          </a:prstGeom>
+          <a:noFill/>
+        </p:spPr>
+        <p:txBody>
+          <a:bodyPr wrap="square" anchor="ctr" lIns="0" tIns="0" rIns="0" bIns="0">
+            <a:noAutofit/>
+          </a:bodyPr>
+          <a:lstStyle/>
+          <a:p>
+            <a:pPr algn="l" latinLnBrk="0">
+              <a:lnSpc>
+                <a:spcPct val="100000"/>
+              </a:lnSpc>
+              <a:spcBef>
+                <a:spcPts val="0"/>
+              </a:spcBef>
+              <a:spcAft>
+                <a:spcPts val="0"/>
+              </a:spcAft>
+            </a:pPr>
+            <a:r>
+              <a:rPr sz="1100" b="1">
+                <a:solidFill>
+                  <a:srgbClr val="0A2B45"/>
+                </a:solidFill>
+                <a:latin typeface="Microsoft YaHei"/>
+                <a:ea typeface="Microsoft YaHei"/>
+                <a:cs typeface="Microsoft YaHei"/>
+              </a:rPr>
+              <a:t>外环 · 引擎</a:t>
+            </a:r>
+          </a:p>
+        </p:txBody>
+      </p:sp>
+      <p:sp>
+        <p:nvSpPr>
+          <p:cNvPr id="25" name="Rounded Rectangle 24"/>
+          <p:cNvSpPr/>
+          <p:nvPr/>
+        </p:nvSpPr>
+        <p:spPr>
+          <a:xfrm>
+            <a:off x="4645152" y="2633472"/>
+            <a:ext cx="658368" cy="201168"/>
+          </a:xfrm>
+          <a:prstGeom prst="roundRect">
+            <a:avLst>
+              <a:gd name="adj" fmla="val 50000"/>
+            </a:avLst>
+          </a:prstGeom>
+          <a:solidFill>
+            <a:srgbClr val="FBE6D4"/>
+          </a:solidFill>
+          <a:ln>
+            <a:noFill/>
+          </a:ln>
+        </p:spPr>
+        <p:txBody>
+          <a:bodyPr rtlCol="0" anchor="ctr" wrap="square" lIns="18288" tIns="0" rIns="18288" bIns="0">
+            <a:noAutofit/>
+          </a:bodyPr>
+          <a:lstStyle/>
+          <a:p>
+            <a:pPr algn="ctr" latinLnBrk="0">
+              <a:lnSpc>
+                <a:spcPct val="100000"/>
+              </a:lnSpc>
+              <a:spcBef>
+                <a:spcPts val="0"/>
+              </a:spcBef>
+              <a:spcAft>
+                <a:spcPts val="0"/>
+              </a:spcAft>
+            </a:pPr>
+            <a:r>
+              <a:rPr sz="850" b="1">
+                <a:solidFill>
+                  <a:srgbClr val="C2570A"/>
+                </a:solidFill>
+                <a:latin typeface="Microsoft YaHei"/>
+                <a:ea typeface="Microsoft YaHei"/>
+                <a:cs typeface="Microsoft YaHei"/>
+              </a:rPr>
+              <a:t>种子</a:t>
+            </a:r>
+          </a:p>
+        </p:txBody>
+      </p:sp>
+      <p:sp>
+        <p:nvSpPr>
+          <p:cNvPr id="26" name="TextBox 25"/>
+          <p:cNvSpPr txBox="1"/>
+          <p:nvPr/>
+        </p:nvSpPr>
+        <p:spPr>
+          <a:xfrm>
+            <a:off x="2779776" y="2871216"/>
+            <a:ext cx="7875727" cy="201168"/>
+          </a:xfrm>
+          <a:prstGeom prst="rect">
+            <a:avLst/>
+          </a:prstGeom>
+          <a:noFill/>
+        </p:spPr>
+        <p:txBody>
+          <a:bodyPr wrap="square" anchor="ctr" lIns="0" tIns="0" rIns="0" bIns="0">
+            <a:noAutofit/>
+          </a:bodyPr>
+          <a:lstStyle/>
+          <a:p>
+            <a:pPr algn="l" latinLnBrk="0">
+              <a:lnSpc>
+                <a:spcPct val="100000"/>
+              </a:lnSpc>
+              <a:spcBef>
+                <a:spcPts val="0"/>
+              </a:spcBef>
+              <a:spcAft>
+                <a:spcPts val="0"/>
+              </a:spcAft>
+            </a:pPr>
+            <a:r>
+              <a:rPr sz="950" b="1">
+                <a:solidFill>
+                  <a:srgbClr val="C2570A"/>
+                </a:solidFill>
+                <a:latin typeface="Microsoft YaHei"/>
+                <a:ea typeface="Microsoft YaHei"/>
+                <a:cs typeface="Microsoft YaHei"/>
+              </a:rPr>
+              <a:t>工作点：</a:t>
+            </a:r>
+            <a:r>
+              <a:rPr sz="950" b="0">
+                <a:solidFill>
+                  <a:srgbClr val="1B4D69"/>
+                </a:solidFill>
+                <a:latin typeface="Microsoft YaHei"/>
+                <a:ea typeface="Microsoft YaHei"/>
+                <a:cs typeface="Microsoft YaHei"/>
+              </a:rPr>
+              <a:t>显存切分 · 每步请求数 · 投机解码</a:t>
+            </a:r>
+          </a:p>
+        </p:txBody>
+      </p:sp>
+      <p:sp>
+        <p:nvSpPr>
+          <p:cNvPr id="27" name="Rounded Rectangle 26"/>
+          <p:cNvSpPr/>
+          <p:nvPr/>
+        </p:nvSpPr>
+        <p:spPr>
+          <a:xfrm>
+            <a:off x="10783519" y="2880360"/>
+            <a:ext cx="658368" cy="182880"/>
+          </a:xfrm>
+          <a:prstGeom prst="roundRect">
+            <a:avLst>
+              <a:gd name="adj" fmla="val 50000"/>
+            </a:avLst>
+          </a:prstGeom>
+          <a:solidFill>
+            <a:srgbClr val="E6F0FC"/>
+          </a:solidFill>
+          <a:ln>
+            <a:noFill/>
+          </a:ln>
+        </p:spPr>
+        <p:txBody>
+          <a:bodyPr rtlCol="0" anchor="ctr" wrap="square" lIns="18288" tIns="0" rIns="18288" bIns="0">
+            <a:noAutofit/>
+          </a:bodyPr>
+          <a:lstStyle/>
+          <a:p>
+            <a:pPr algn="ctr" latinLnBrk="0">
+              <a:lnSpc>
+                <a:spcPct val="100000"/>
+              </a:lnSpc>
+              <a:spcBef>
+                <a:spcPts val="0"/>
+              </a:spcBef>
+              <a:spcAft>
+                <a:spcPts val="0"/>
+              </a:spcAft>
+            </a:pPr>
+            <a:r>
+              <a:rPr sz="900" b="1">
+                <a:solidFill>
+                  <a:srgbClr val="0F62CE"/>
+                </a:solidFill>
+                <a:latin typeface="Microsoft YaHei"/>
+                <a:ea typeface="Microsoft YaHei"/>
+                <a:cs typeface="Microsoft YaHei"/>
+              </a:rPr>
+              <a:t>工作点</a:t>
+            </a:r>
+          </a:p>
+        </p:txBody>
+      </p:sp>
+      <p:sp>
+        <p:nvSpPr>
+          <p:cNvPr id="28" name="TextBox 27"/>
+          <p:cNvSpPr txBox="1"/>
+          <p:nvPr/>
+        </p:nvSpPr>
+        <p:spPr>
+          <a:xfrm>
+            <a:off x="2779776" y="3072384"/>
+            <a:ext cx="7875727" cy="201168"/>
+          </a:xfrm>
+          <a:prstGeom prst="rect">
+            <a:avLst/>
+          </a:prstGeom>
+          <a:noFill/>
+        </p:spPr>
+        <p:txBody>
+          <a:bodyPr wrap="square" anchor="ctr" lIns="0" tIns="0" rIns="0" bIns="0">
+            <a:noAutofit/>
+          </a:bodyPr>
+          <a:lstStyle/>
+          <a:p>
+            <a:pPr algn="l" latinLnBrk="0">
+              <a:lnSpc>
+                <a:spcPct val="100000"/>
+              </a:lnSpc>
+              <a:spcBef>
+                <a:spcPts val="0"/>
+              </a:spcBef>
+              <a:spcAft>
+                <a:spcPts val="0"/>
+              </a:spcAft>
+            </a:pPr>
+            <a:r>
+              <a:rPr sz="950" b="1">
+                <a:solidFill>
+                  <a:srgbClr val="C2570A"/>
+                </a:solidFill>
+                <a:latin typeface="Microsoft YaHei"/>
+                <a:ea typeface="Microsoft YaHei"/>
+                <a:cs typeface="Microsoft YaHei"/>
+              </a:rPr>
+              <a:t>步间：</a:t>
+            </a:r>
+            <a:r>
+              <a:rPr sz="950" b="0">
+                <a:solidFill>
+                  <a:srgbClr val="1B4D69"/>
+                </a:solidFill>
+                <a:latin typeface="Microsoft YaHei"/>
+                <a:ea typeface="Microsoft YaHei"/>
+                <a:cs typeface="Microsoft YaHei"/>
+              </a:rPr>
+              <a:t>overlap 调度 · chunk 与混跑 · 前缀缓存 · PD</a:t>
+            </a:r>
+          </a:p>
+        </p:txBody>
+      </p:sp>
+      <p:sp>
+        <p:nvSpPr>
+          <p:cNvPr id="29" name="Rounded Rectangle 28"/>
+          <p:cNvSpPr/>
+          <p:nvPr/>
+        </p:nvSpPr>
+        <p:spPr>
+          <a:xfrm>
+            <a:off x="10783519" y="3081528"/>
+            <a:ext cx="658368" cy="182880"/>
+          </a:xfrm>
+          <a:prstGeom prst="roundRect">
+            <a:avLst>
+              <a:gd name="adj" fmla="val 50000"/>
+            </a:avLst>
+          </a:prstGeom>
+          <a:solidFill>
+            <a:srgbClr val="E6F0FC"/>
+          </a:solidFill>
+          <a:ln>
+            <a:noFill/>
+          </a:ln>
+        </p:spPr>
+        <p:txBody>
+          <a:bodyPr rtlCol="0" anchor="ctr" wrap="square" lIns="18288" tIns="0" rIns="18288" bIns="0">
+            <a:noAutofit/>
+          </a:bodyPr>
+          <a:lstStyle/>
+          <a:p>
+            <a:pPr algn="ctr" latinLnBrk="0">
+              <a:lnSpc>
+                <a:spcPct val="100000"/>
+              </a:lnSpc>
+              <a:spcBef>
+                <a:spcPts val="0"/>
+              </a:spcBef>
+              <a:spcAft>
+                <a:spcPts val="0"/>
+              </a:spcAft>
+            </a:pPr>
+            <a:r>
+              <a:rPr sz="900" b="1">
+                <a:solidFill>
+                  <a:srgbClr val="0F62CE"/>
+                </a:solidFill>
+                <a:latin typeface="Microsoft YaHei"/>
+                <a:ea typeface="Microsoft YaHei"/>
+                <a:cs typeface="Microsoft YaHei"/>
+              </a:rPr>
+              <a:t>步间</a:t>
+            </a:r>
+          </a:p>
+        </p:txBody>
+      </p:sp>
+      <p:sp>
+        <p:nvSpPr>
+          <p:cNvPr id="30" name="TextBox 29"/>
+          <p:cNvSpPr txBox="1"/>
+          <p:nvPr/>
+        </p:nvSpPr>
+        <p:spPr>
+          <a:xfrm>
+            <a:off x="2779776" y="3273552"/>
+            <a:ext cx="2834640" cy="201168"/>
+          </a:xfrm>
+          <a:prstGeom prst="rect">
+            <a:avLst/>
+          </a:prstGeom>
+          <a:noFill/>
+        </p:spPr>
+        <p:txBody>
+          <a:bodyPr wrap="square" anchor="ctr" lIns="0" tIns="0" rIns="0" bIns="0">
+            <a:noAutofit/>
+          </a:bodyPr>
+          <a:lstStyle/>
+          <a:p>
+            <a:pPr algn="l" latinLnBrk="0">
+              <a:lnSpc>
+                <a:spcPct val="100000"/>
+              </a:lnSpc>
+              <a:spcBef>
+                <a:spcPts val="0"/>
+              </a:spcBef>
+              <a:spcAft>
+                <a:spcPts val="0"/>
+              </a:spcAft>
+            </a:pPr>
+            <a:r>
+              <a:rPr sz="900" b="0">
+                <a:solidFill>
+                  <a:srgbClr val="40708B"/>
+                </a:solidFill>
+                <a:latin typeface="Microsoft YaHei"/>
+                <a:ea typeface="Microsoft YaHei"/>
+                <a:cs typeface="Microsoft YaHei"/>
+              </a:rPr>
+              <a:t>↓　形状分布 + 新算子需求</a:t>
+            </a:r>
+          </a:p>
+        </p:txBody>
+      </p:sp>
+      <p:sp>
+        <p:nvSpPr>
+          <p:cNvPr id="31" name="TextBox 30"/>
+          <p:cNvSpPr txBox="1"/>
+          <p:nvPr/>
+        </p:nvSpPr>
+        <p:spPr>
+          <a:xfrm>
+            <a:off x="5797296" y="3273552"/>
+            <a:ext cx="2834640" cy="201168"/>
+          </a:xfrm>
+          <a:prstGeom prst="rect">
+            <a:avLst/>
+          </a:prstGeom>
+          <a:noFill/>
+        </p:spPr>
+        <p:txBody>
+          <a:bodyPr wrap="square" anchor="ctr" lIns="0" tIns="0" rIns="0" bIns="0">
+            <a:noAutofit/>
+          </a:bodyPr>
+          <a:lstStyle/>
+          <a:p>
+            <a:pPr algn="l" latinLnBrk="0">
+              <a:lnSpc>
+                <a:spcPct val="100000"/>
+              </a:lnSpc>
+              <a:spcBef>
+                <a:spcPts val="0"/>
+              </a:spcBef>
+              <a:spcAft>
+                <a:spcPts val="0"/>
+              </a:spcAft>
+            </a:pPr>
+            <a:r>
+              <a:rPr sz="900" b="0">
+                <a:solidFill>
+                  <a:srgbClr val="40708B"/>
+                </a:solidFill>
+                <a:latin typeface="Microsoft YaHei"/>
+                <a:ea typeface="Microsoft YaHei"/>
+                <a:cs typeface="Microsoft YaHei"/>
+              </a:rPr>
+              <a:t>↑　单步代价曲线 + 时延余量</a:t>
+            </a:r>
+          </a:p>
+        </p:txBody>
+      </p:sp>
+      <p:sp>
+        <p:nvSpPr>
+          <p:cNvPr id="32" name="Rectangle 31"/>
+          <p:cNvSpPr/>
+          <p:nvPr/>
+        </p:nvSpPr>
+        <p:spPr>
+          <a:xfrm>
+            <a:off x="2578608" y="3493008"/>
+            <a:ext cx="9064447" cy="932688"/>
+          </a:xfrm>
+          <a:prstGeom prst="rect">
+            <a:avLst/>
+          </a:prstGeom>
+          <a:solidFill>
+            <a:srgbClr val="FFFFFF"/>
+          </a:solidFill>
+          <a:ln w="15875">
+            <a:solidFill>
+              <a:srgbClr val="D2690C"/>
+            </a:solidFill>
+          </a:ln>
+        </p:spPr>
+        <p:txBody>
+          <a:bodyPr rtlCol="0" anchor="ctr"/>
+          <a:lstStyle/>
+          <a:p>
+            <a:pPr algn="ctr"/>
+          </a:p>
+        </p:txBody>
+      </p:sp>
+      <p:sp>
+        <p:nvSpPr>
+          <p:cNvPr id="33" name="TextBox 32"/>
+          <p:cNvSpPr txBox="1"/>
+          <p:nvPr/>
+        </p:nvSpPr>
+        <p:spPr>
+          <a:xfrm>
+            <a:off x="2779776" y="3529584"/>
+            <a:ext cx="4206240" cy="237744"/>
+          </a:xfrm>
+          <a:prstGeom prst="rect">
+            <a:avLst/>
+          </a:prstGeom>
+          <a:noFill/>
+        </p:spPr>
+        <p:txBody>
+          <a:bodyPr wrap="square" anchor="ctr" lIns="0" tIns="0" rIns="0" bIns="0">
+            <a:noAutofit/>
+          </a:bodyPr>
+          <a:lstStyle/>
+          <a:p>
+            <a:pPr algn="l" latinLnBrk="0">
+              <a:lnSpc>
+                <a:spcPct val="100000"/>
+              </a:lnSpc>
+              <a:spcBef>
+                <a:spcPts val="0"/>
+              </a:spcBef>
+              <a:spcAft>
+                <a:spcPts val="0"/>
+              </a:spcAft>
+            </a:pPr>
+            <a:r>
+              <a:rPr sz="1100" b="1">
+                <a:solidFill>
+                  <a:srgbClr val="0A2B45"/>
+                </a:solidFill>
+                <a:latin typeface="Microsoft YaHei"/>
+                <a:ea typeface="Microsoft YaHei"/>
+                <a:cs typeface="Microsoft YaHei"/>
+              </a:rPr>
+              <a:t>内环 · 图 + 算子：在工作点上逼近屋顶</a:t>
+            </a:r>
+          </a:p>
+        </p:txBody>
+      </p:sp>
+      <p:sp>
+        <p:nvSpPr>
+          <p:cNvPr id="34" name="Rounded Rectangle 33"/>
+          <p:cNvSpPr/>
+          <p:nvPr/>
+        </p:nvSpPr>
+        <p:spPr>
+          <a:xfrm>
+            <a:off x="10783519" y="3557016"/>
+            <a:ext cx="658368" cy="182880"/>
+          </a:xfrm>
+          <a:prstGeom prst="roundRect">
+            <a:avLst>
+              <a:gd name="adj" fmla="val 50000"/>
+            </a:avLst>
+          </a:prstGeom>
+          <a:solidFill>
+            <a:srgbClr val="E6F0FC"/>
+          </a:solidFill>
+          <a:ln>
+            <a:noFill/>
+          </a:ln>
+        </p:spPr>
+        <p:txBody>
+          <a:bodyPr rtlCol="0" anchor="ctr" wrap="square" lIns="18288" tIns="0" rIns="18288" bIns="0">
+            <a:noAutofit/>
+          </a:bodyPr>
+          <a:lstStyle/>
+          <a:p>
+            <a:pPr algn="ctr" latinLnBrk="0">
+              <a:lnSpc>
+                <a:spcPct val="100000"/>
+              </a:lnSpc>
+              <a:spcBef>
+                <a:spcPts val="0"/>
+              </a:spcBef>
+              <a:spcAft>
+                <a:spcPts val="0"/>
+              </a:spcAft>
+            </a:pPr>
+            <a:r>
+              <a:rPr sz="900" b="1">
+                <a:solidFill>
+                  <a:srgbClr val="0F62CE"/>
+                </a:solidFill>
+                <a:latin typeface="Microsoft YaHei"/>
+                <a:ea typeface="Microsoft YaHei"/>
+                <a:cs typeface="Microsoft YaHei"/>
+              </a:rPr>
+              <a:t>单步</a:t>
+            </a:r>
+          </a:p>
+        </p:txBody>
+      </p:sp>
+      <p:sp>
+        <p:nvSpPr>
+          <p:cNvPr id="35" name="TextBox 34"/>
+          <p:cNvSpPr txBox="1"/>
+          <p:nvPr/>
+        </p:nvSpPr>
+        <p:spPr>
+          <a:xfrm>
+            <a:off x="2779776" y="3785616"/>
+            <a:ext cx="548640" cy="201168"/>
+          </a:xfrm>
+          <a:prstGeom prst="rect">
+            <a:avLst/>
+          </a:prstGeom>
+          <a:noFill/>
+        </p:spPr>
+        <p:txBody>
+          <a:bodyPr wrap="square" anchor="ctr" lIns="0" tIns="0" rIns="0" bIns="0">
+            <a:noAutofit/>
+          </a:bodyPr>
+          <a:lstStyle/>
+          <a:p>
+            <a:pPr algn="l" latinLnBrk="0">
+              <a:lnSpc>
+                <a:spcPct val="100000"/>
+              </a:lnSpc>
+              <a:spcBef>
+                <a:spcPts val="0"/>
+              </a:spcBef>
+              <a:spcAft>
+                <a:spcPts val="0"/>
+              </a:spcAft>
+            </a:pPr>
+            <a:r>
+              <a:rPr sz="950" b="1">
+                <a:solidFill>
+                  <a:srgbClr val="C2570A"/>
+                </a:solidFill>
+                <a:latin typeface="Microsoft YaHei"/>
+                <a:ea typeface="Microsoft YaHei"/>
+                <a:cs typeface="Microsoft YaHei"/>
+              </a:rPr>
+              <a:t>图</a:t>
+            </a:r>
+          </a:p>
+        </p:txBody>
+      </p:sp>
+      <p:sp>
+        <p:nvSpPr>
+          <p:cNvPr id="36" name="Rounded Rectangle 35"/>
+          <p:cNvSpPr/>
+          <p:nvPr/>
+        </p:nvSpPr>
+        <p:spPr>
+          <a:xfrm>
+            <a:off x="3346704" y="3794760"/>
+            <a:ext cx="786384" cy="182880"/>
+          </a:xfrm>
+          <a:prstGeom prst="roundRect">
+            <a:avLst>
+              <a:gd name="adj" fmla="val 50000"/>
+            </a:avLst>
+          </a:prstGeom>
+          <a:solidFill>
+            <a:srgbClr val="DEEDFA"/>
+          </a:solidFill>
+          <a:ln>
+            <a:noFill/>
+          </a:ln>
+        </p:spPr>
+        <p:txBody>
+          <a:bodyPr rtlCol="0" anchor="ctr" wrap="square" lIns="18288" tIns="0" rIns="18288" bIns="0">
+            <a:noAutofit/>
+          </a:bodyPr>
+          <a:lstStyle/>
+          <a:p>
+            <a:pPr algn="ctr" latinLnBrk="0">
+              <a:lnSpc>
+                <a:spcPct val="100000"/>
+              </a:lnSpc>
+              <a:spcBef>
+                <a:spcPts val="0"/>
+              </a:spcBef>
+              <a:spcAft>
+                <a:spcPts val="0"/>
+              </a:spcAft>
+            </a:pPr>
+            <a:r>
+              <a:rPr sz="850" b="1">
+                <a:solidFill>
+                  <a:srgbClr val="40708B"/>
+                </a:solidFill>
+                <a:latin typeface="Microsoft YaHei"/>
+                <a:ea typeface="Microsoft YaHei"/>
+                <a:cs typeface="Microsoft YaHei"/>
+              </a:rPr>
+              <a:t>部分已有</a:t>
+            </a:r>
+          </a:p>
+        </p:txBody>
+      </p:sp>
+      <p:sp>
+        <p:nvSpPr>
+          <p:cNvPr id="37" name="TextBox 36"/>
+          <p:cNvSpPr txBox="1"/>
+          <p:nvPr/>
+        </p:nvSpPr>
+        <p:spPr>
+          <a:xfrm>
+            <a:off x="4242816" y="3785616"/>
+            <a:ext cx="6412687" cy="201168"/>
+          </a:xfrm>
+          <a:prstGeom prst="rect">
+            <a:avLst/>
+          </a:prstGeom>
+          <a:noFill/>
+        </p:spPr>
+        <p:txBody>
+          <a:bodyPr wrap="square" anchor="ctr" lIns="0" tIns="0" rIns="0" bIns="0">
+            <a:noAutofit/>
+          </a:bodyPr>
+          <a:lstStyle/>
+          <a:p>
+            <a:pPr algn="l" latinLnBrk="0">
+              <a:lnSpc>
+                <a:spcPct val="100000"/>
+              </a:lnSpc>
+              <a:spcBef>
+                <a:spcPts val="0"/>
+              </a:spcBef>
+              <a:spcAft>
+                <a:spcPts val="0"/>
+              </a:spcAft>
+            </a:pPr>
+            <a:r>
+              <a:rPr sz="950" b="0">
+                <a:solidFill>
+                  <a:srgbClr val="1B4D69"/>
+                </a:solidFill>
+                <a:latin typeface="Microsoft YaHei"/>
+                <a:ea typeface="Microsoft YaHei"/>
+                <a:cs typeface="Microsoft YaHei"/>
+              </a:rPr>
+              <a:t>融合 · 多流并发 · 通信窗口预取</a:t>
+            </a:r>
+          </a:p>
+        </p:txBody>
+      </p:sp>
+      <p:sp>
+        <p:nvSpPr>
+          <p:cNvPr id="38" name="TextBox 37"/>
+          <p:cNvSpPr txBox="1"/>
+          <p:nvPr/>
+        </p:nvSpPr>
+        <p:spPr>
+          <a:xfrm>
+            <a:off x="2779776" y="4206240"/>
+            <a:ext cx="548640" cy="201168"/>
+          </a:xfrm>
+          <a:prstGeom prst="rect">
+            <a:avLst/>
+          </a:prstGeom>
+          <a:noFill/>
+        </p:spPr>
+        <p:txBody>
+          <a:bodyPr wrap="square" anchor="ctr" lIns="0" tIns="0" rIns="0" bIns="0">
+            <a:noAutofit/>
+          </a:bodyPr>
+          <a:lstStyle/>
+          <a:p>
+            <a:pPr algn="l" latinLnBrk="0">
+              <a:lnSpc>
+                <a:spcPct val="100000"/>
+              </a:lnSpc>
+              <a:spcBef>
+                <a:spcPts val="0"/>
+              </a:spcBef>
+              <a:spcAft>
+                <a:spcPts val="0"/>
+              </a:spcAft>
+            </a:pPr>
+            <a:r>
+              <a:rPr sz="950" b="1">
+                <a:solidFill>
+                  <a:srgbClr val="C2570A"/>
+                </a:solidFill>
+                <a:latin typeface="Microsoft YaHei"/>
+                <a:ea typeface="Microsoft YaHei"/>
+                <a:cs typeface="Microsoft YaHei"/>
+              </a:rPr>
+              <a:t>算子</a:t>
+            </a:r>
+          </a:p>
+        </p:txBody>
+      </p:sp>
+      <p:sp>
+        <p:nvSpPr>
+          <p:cNvPr id="39" name="Rounded Rectangle 38"/>
+          <p:cNvSpPr/>
+          <p:nvPr/>
+        </p:nvSpPr>
+        <p:spPr>
+          <a:xfrm>
+            <a:off x="3346704" y="4215384"/>
+            <a:ext cx="786384" cy="182880"/>
+          </a:xfrm>
+          <a:prstGeom prst="roundRect">
+            <a:avLst>
+              <a:gd name="adj" fmla="val 50000"/>
+            </a:avLst>
+          </a:prstGeom>
+          <a:solidFill>
+            <a:srgbClr val="DEEDFA"/>
+          </a:solidFill>
+          <a:ln>
+            <a:noFill/>
+          </a:ln>
+        </p:spPr>
+        <p:txBody>
+          <a:bodyPr rtlCol="0" anchor="ctr" wrap="square" lIns="18288" tIns="0" rIns="18288" bIns="0">
+            <a:noAutofit/>
+          </a:bodyPr>
+          <a:lstStyle/>
+          <a:p>
+            <a:pPr algn="ctr" latinLnBrk="0">
+              <a:lnSpc>
+                <a:spcPct val="100000"/>
+              </a:lnSpc>
+              <a:spcBef>
+                <a:spcPts val="0"/>
+              </a:spcBef>
+              <a:spcAft>
+                <a:spcPts val="0"/>
+              </a:spcAft>
+            </a:pPr>
+            <a:r>
+              <a:rPr sz="850" b="1">
+                <a:solidFill>
+                  <a:srgbClr val="40708B"/>
+                </a:solidFill>
+                <a:latin typeface="Microsoft YaHei"/>
+                <a:ea typeface="Microsoft YaHei"/>
+                <a:cs typeface="Microsoft YaHei"/>
+              </a:rPr>
+              <a:t>已有</a:t>
+            </a:r>
+          </a:p>
+        </p:txBody>
+      </p:sp>
+      <p:sp>
+        <p:nvSpPr>
+          <p:cNvPr id="40" name="TextBox 39"/>
+          <p:cNvSpPr txBox="1"/>
+          <p:nvPr/>
+        </p:nvSpPr>
+        <p:spPr>
+          <a:xfrm>
+            <a:off x="4242816" y="4206240"/>
+            <a:ext cx="6412687" cy="201168"/>
+          </a:xfrm>
+          <a:prstGeom prst="rect">
+            <a:avLst/>
+          </a:prstGeom>
+          <a:noFill/>
+        </p:spPr>
+        <p:txBody>
+          <a:bodyPr wrap="square" anchor="ctr" lIns="0" tIns="0" rIns="0" bIns="0">
+            <a:noAutofit/>
+          </a:bodyPr>
+          <a:lstStyle/>
+          <a:p>
+            <a:pPr algn="l" latinLnBrk="0">
+              <a:lnSpc>
+                <a:spcPct val="100000"/>
+              </a:lnSpc>
+              <a:spcBef>
+                <a:spcPts val="0"/>
+              </a:spcBef>
+              <a:spcAft>
+                <a:spcPts val="0"/>
+              </a:spcAft>
+            </a:pPr>
+            <a:r>
+              <a:rPr sz="950" b="0">
+                <a:solidFill>
+                  <a:srgbClr val="1B4D69"/>
+                </a:solidFill>
+                <a:latin typeface="Microsoft YaHei"/>
+                <a:ea typeface="Microsoft YaHei"/>
+                <a:cs typeface="Microsoft YaHei"/>
+              </a:rPr>
+              <a:t>一个 kernel 怎么写</a:t>
+            </a:r>
+          </a:p>
+        </p:txBody>
+      </p:sp>
+      <p:sp>
+        <p:nvSpPr>
+          <p:cNvPr id="41" name="TextBox 40"/>
+          <p:cNvSpPr txBox="1"/>
+          <p:nvPr/>
+        </p:nvSpPr>
+        <p:spPr>
+          <a:xfrm>
+            <a:off x="4242816" y="4005072"/>
+            <a:ext cx="1920240" cy="182880"/>
+          </a:xfrm>
+          <a:prstGeom prst="rect">
+            <a:avLst/>
+          </a:prstGeom>
+          <a:noFill/>
+        </p:spPr>
+        <p:txBody>
+          <a:bodyPr wrap="square" anchor="ctr" lIns="0" tIns="0" rIns="0" bIns="0">
+            <a:noAutofit/>
+          </a:bodyPr>
+          <a:lstStyle/>
+          <a:p>
+            <a:pPr algn="l" latinLnBrk="0">
+              <a:lnSpc>
+                <a:spcPct val="100000"/>
+              </a:lnSpc>
+              <a:spcBef>
+                <a:spcPts val="0"/>
+              </a:spcBef>
+              <a:spcAft>
+                <a:spcPts val="0"/>
+              </a:spcAft>
+            </a:pPr>
+            <a:r>
+              <a:rPr sz="850" b="0">
+                <a:solidFill>
+                  <a:srgbClr val="40708B"/>
+                </a:solidFill>
+                <a:latin typeface="Microsoft YaHei"/>
+                <a:ea typeface="Microsoft YaHei"/>
+                <a:cs typeface="Microsoft YaHei"/>
+              </a:rPr>
+              <a:t>↓　融合契约</a:t>
+            </a:r>
+          </a:p>
+        </p:txBody>
+      </p:sp>
+      <p:sp>
+        <p:nvSpPr>
+          <p:cNvPr id="42" name="TextBox 41"/>
+          <p:cNvSpPr txBox="1"/>
+          <p:nvPr/>
+        </p:nvSpPr>
+        <p:spPr>
+          <a:xfrm>
+            <a:off x="6254496" y="4005072"/>
+            <a:ext cx="1920240" cy="182880"/>
+          </a:xfrm>
+          <a:prstGeom prst="rect">
+            <a:avLst/>
+          </a:prstGeom>
+          <a:noFill/>
+        </p:spPr>
+        <p:txBody>
+          <a:bodyPr wrap="square" anchor="ctr" lIns="0" tIns="0" rIns="0" bIns="0">
+            <a:noAutofit/>
+          </a:bodyPr>
+          <a:lstStyle/>
+          <a:p>
+            <a:pPr algn="l" latinLnBrk="0">
+              <a:lnSpc>
+                <a:spcPct val="100000"/>
+              </a:lnSpc>
+              <a:spcBef>
+                <a:spcPts val="0"/>
+              </a:spcBef>
+              <a:spcAft>
+                <a:spcPts val="0"/>
+              </a:spcAft>
+            </a:pPr>
+            <a:r>
+              <a:rPr sz="850" b="0">
+                <a:solidFill>
+                  <a:srgbClr val="40708B"/>
+                </a:solidFill>
+                <a:latin typeface="Microsoft YaHei"/>
+                <a:ea typeface="Microsoft YaHei"/>
+                <a:cs typeface="Microsoft YaHei"/>
+              </a:rPr>
+              <a:t>↑　新内核 + 实测代价</a:t>
+            </a:r>
+          </a:p>
+        </p:txBody>
+      </p:sp>
+      <p:cxnSp>
+        <p:nvCxnSpPr>
+          <p:cNvPr id="43" name="Connector 42"/>
+          <p:cNvCxnSpPr/>
+          <p:nvPr/>
+        </p:nvCxnSpPr>
+        <p:spPr>
+          <a:xfrm>
+            <a:off x="2578608" y="4654296"/>
+            <a:ext cx="9064447" cy="0"/>
+          </a:xfrm>
+          <a:prstGeom prst="line">
+            <a:avLst/>
+          </a:prstGeom>
+          <a:ln w="9525">
+            <a:solidFill>
+              <a:srgbClr val="AFCEE1"/>
+            </a:solidFill>
+            <a:prstDash val="dash"/>
+          </a:ln>
+        </p:spPr>
+      </p:cxnSp>
+      <p:sp>
+        <p:nvSpPr>
+          <p:cNvPr id="44" name="Rectangle 43"/>
+          <p:cNvSpPr/>
+          <p:nvPr/>
+        </p:nvSpPr>
+        <p:spPr>
+          <a:xfrm>
+            <a:off x="2578608" y="4535424"/>
+            <a:ext cx="2651760" cy="237744"/>
+          </a:xfrm>
+          <a:prstGeom prst="rect">
+            <a:avLst/>
+          </a:prstGeom>
+          <a:solidFill>
+            <a:srgbClr val="F2F8FD"/>
+          </a:solidFill>
+          <a:ln>
+            <a:noFill/>
+          </a:ln>
+        </p:spPr>
+        <p:txBody>
+          <a:bodyPr rtlCol="0" anchor="ctr"/>
+          <a:lstStyle/>
+          <a:p>
+            <a:pPr algn="ctr"/>
+          </a:p>
+        </p:txBody>
+      </p:sp>
+      <p:sp>
+        <p:nvSpPr>
+          <p:cNvPr id="45" name="TextBox 44"/>
+          <p:cNvSpPr txBox="1"/>
+          <p:nvPr/>
+        </p:nvSpPr>
+        <p:spPr>
+          <a:xfrm>
+            <a:off x="2578608" y="4535424"/>
+            <a:ext cx="2651760" cy="237744"/>
+          </a:xfrm>
+          <a:prstGeom prst="rect">
+            <a:avLst/>
+          </a:prstGeom>
+          <a:noFill/>
+        </p:spPr>
+        <p:txBody>
+          <a:bodyPr wrap="square" anchor="ctr" lIns="0" tIns="0" rIns="0" bIns="0">
+            <a:noAutofit/>
+          </a:bodyPr>
+          <a:lstStyle/>
+          <a:p>
+            <a:pPr algn="ctr" latinLnBrk="0">
+              <a:lnSpc>
+                <a:spcPct val="100000"/>
+              </a:lnSpc>
+              <a:spcBef>
+                <a:spcPts val="0"/>
+              </a:spcBef>
+              <a:spcAft>
+                <a:spcPts val="0"/>
+              </a:spcAft>
+            </a:pPr>
+            <a:r>
+              <a:rPr sz="950" b="0">
+                <a:solidFill>
+                  <a:srgbClr val="40708B"/>
+                </a:solidFill>
+                <a:latin typeface="Microsoft YaHei"/>
+                <a:ea typeface="Microsoft YaHei"/>
+                <a:cs typeface="Microsoft YaHei"/>
+              </a:rPr>
+              <a:t>↓　候选（带尺度标签）</a:t>
+            </a:r>
+          </a:p>
+        </p:txBody>
+      </p:sp>
+      <p:sp>
+        <p:nvSpPr>
+          <p:cNvPr id="46" name="Rectangle 45"/>
+          <p:cNvSpPr/>
+          <p:nvPr/>
+        </p:nvSpPr>
+        <p:spPr>
+          <a:xfrm>
+            <a:off x="5596128" y="4535424"/>
+            <a:ext cx="2651760" cy="237744"/>
+          </a:xfrm>
+          <a:prstGeom prst="rect">
+            <a:avLst/>
+          </a:prstGeom>
+          <a:solidFill>
+            <a:srgbClr val="F2F8FD"/>
+          </a:solidFill>
+          <a:ln>
+            <a:noFill/>
+          </a:ln>
+        </p:spPr>
+        <p:txBody>
+          <a:bodyPr rtlCol="0" anchor="ctr"/>
+          <a:lstStyle/>
+          <a:p>
+            <a:pPr algn="ctr"/>
+          </a:p>
+        </p:txBody>
+      </p:sp>
+      <p:sp>
+        <p:nvSpPr>
+          <p:cNvPr id="47" name="TextBox 46"/>
+          <p:cNvSpPr txBox="1"/>
+          <p:nvPr/>
+        </p:nvSpPr>
+        <p:spPr>
+          <a:xfrm>
+            <a:off x="5596128" y="4535424"/>
+            <a:ext cx="2651760" cy="237744"/>
+          </a:xfrm>
+          <a:prstGeom prst="rect">
+            <a:avLst/>
+          </a:prstGeom>
+          <a:noFill/>
+        </p:spPr>
+        <p:txBody>
+          <a:bodyPr wrap="square" anchor="ctr" lIns="0" tIns="0" rIns="0" bIns="0">
+            <a:noAutofit/>
+          </a:bodyPr>
+          <a:lstStyle/>
+          <a:p>
+            <a:pPr algn="ctr" latinLnBrk="0">
+              <a:lnSpc>
+                <a:spcPct val="100000"/>
+              </a:lnSpc>
+              <a:spcBef>
+                <a:spcPts val="0"/>
+              </a:spcBef>
+              <a:spcAft>
+                <a:spcPts val="0"/>
+              </a:spcAft>
+            </a:pPr>
+            <a:r>
+              <a:rPr sz="950" b="0">
+                <a:solidFill>
+                  <a:srgbClr val="40708B"/>
+                </a:solidFill>
+                <a:latin typeface="Microsoft YaHei"/>
+                <a:ea typeface="Microsoft YaHei"/>
+                <a:cs typeface="Microsoft YaHei"/>
+              </a:rPr>
+              <a:t>↑　淘汰：带原因退回</a:t>
+            </a:r>
+          </a:p>
+        </p:txBody>
+      </p:sp>
+      <p:sp>
+        <p:nvSpPr>
+          <p:cNvPr id="48" name="Rectangle 47"/>
+          <p:cNvSpPr/>
+          <p:nvPr/>
+        </p:nvSpPr>
+        <p:spPr>
+          <a:xfrm>
+            <a:off x="950976" y="4809744"/>
+            <a:ext cx="10692079" cy="1207008"/>
+          </a:xfrm>
+          <a:prstGeom prst="rect">
+            <a:avLst/>
+          </a:prstGeom>
+          <a:solidFill>
+            <a:srgbClr val="F2F8FD"/>
+          </a:solidFill>
+          <a:ln>
+            <a:noFill/>
+          </a:ln>
+        </p:spPr>
+        <p:txBody>
+          <a:bodyPr rtlCol="0" anchor="ctr"/>
+          <a:lstStyle/>
+          <a:p>
+            <a:pPr algn="ctr"/>
+          </a:p>
+        </p:txBody>
+      </p:sp>
+      <p:sp>
+        <p:nvSpPr>
+          <p:cNvPr id="49" name="Rectangle 48"/>
+          <p:cNvSpPr/>
+          <p:nvPr/>
+        </p:nvSpPr>
+        <p:spPr>
+          <a:xfrm>
+            <a:off x="950976" y="4809744"/>
+            <a:ext cx="64008" cy="1207008"/>
+          </a:xfrm>
+          <a:prstGeom prst="rect">
+            <a:avLst/>
+          </a:prstGeom>
+          <a:solidFill>
+            <a:srgbClr val="0F62CE"/>
+          </a:solidFill>
+          <a:ln>
+            <a:noFill/>
+          </a:ln>
+        </p:spPr>
+        <p:txBody>
+          <a:bodyPr rtlCol="0" anchor="ctr"/>
+          <a:lstStyle/>
+          <a:p>
+            <a:pPr algn="ctr"/>
+          </a:p>
+        </p:txBody>
+      </p:sp>
+      <p:sp>
+        <p:nvSpPr>
+          <p:cNvPr id="50" name="TextBox 49"/>
+          <p:cNvSpPr txBox="1"/>
+          <p:nvPr/>
+        </p:nvSpPr>
+        <p:spPr>
+          <a:xfrm>
+            <a:off x="1170432" y="4882896"/>
+            <a:ext cx="1188720" cy="1060704"/>
+          </a:xfrm>
+          <a:prstGeom prst="rect">
+            <a:avLst/>
+          </a:prstGeom>
+          <a:noFill/>
+        </p:spPr>
+        <p:txBody>
+          <a:bodyPr wrap="square" anchor="ctr" lIns="0" tIns="0" rIns="0" bIns="0">
+            <a:noAutofit/>
+          </a:bodyPr>
+          <a:lstStyle/>
+          <a:p>
+            <a:pPr algn="l" latinLnBrk="0">
+              <a:lnSpc>
+                <a:spcPct val="100000"/>
+              </a:lnSpc>
+              <a:spcBef>
+                <a:spcPts val="0"/>
+              </a:spcBef>
+              <a:spcAft>
+                <a:spcPts val="300"/>
+              </a:spcAft>
+            </a:pPr>
+            <a:r>
+              <a:rPr sz="1400" b="1">
+                <a:solidFill>
+                  <a:srgbClr val="0A2B45"/>
+                </a:solidFill>
+                <a:latin typeface="Microsoft YaHei"/>
+                <a:ea typeface="Microsoft YaHei"/>
+                <a:cs typeface="Microsoft YaHei"/>
+              </a:rPr>
+              <a:t>判决层</a:t>
+            </a:r>
+          </a:p>
+          <a:p>
+            <a:pPr algn="l" latinLnBrk="0">
+              <a:lnSpc>
+                <a:spcPct val="100000"/>
+              </a:lnSpc>
+              <a:spcBef>
+                <a:spcPts val="0"/>
+              </a:spcBef>
+              <a:spcAft>
+                <a:spcPts val="0"/>
+              </a:spcAft>
+            </a:pPr>
+            <a:r>
+              <a:rPr sz="900" b="0">
+                <a:solidFill>
+                  <a:srgbClr val="40708B"/>
+                </a:solidFill>
+                <a:latin typeface="Microsoft YaHei"/>
+                <a:ea typeface="Microsoft YaHei"/>
+                <a:cs typeface="Microsoft YaHei"/>
+              </a:rPr>
+              <a:t>不含模型 · 真机实测</a:t>
+            </a:r>
+          </a:p>
+        </p:txBody>
+      </p:sp>
+      <p:sp>
+        <p:nvSpPr>
+          <p:cNvPr id="51" name="Rectangle 50"/>
+          <p:cNvSpPr/>
+          <p:nvPr/>
+        </p:nvSpPr>
+        <p:spPr>
+          <a:xfrm>
+            <a:off x="2578608" y="4901183"/>
+            <a:ext cx="2377440" cy="1024128"/>
+          </a:xfrm>
+          <a:prstGeom prst="rect">
+            <a:avLst/>
+          </a:prstGeom>
+          <a:solidFill>
+            <a:srgbClr val="FFFFFF"/>
+          </a:solidFill>
+          <a:ln w="9525">
+            <a:solidFill>
+              <a:srgbClr val="CFE3F0"/>
+            </a:solidFill>
+          </a:ln>
+        </p:spPr>
+        <p:txBody>
+          <a:bodyPr rtlCol="0" anchor="ctr"/>
+          <a:lstStyle/>
+          <a:p>
+            <a:pPr algn="ctr"/>
+          </a:p>
+        </p:txBody>
+      </p:sp>
+      <p:sp>
+        <p:nvSpPr>
+          <p:cNvPr id="52" name="TextBox 51"/>
+          <p:cNvSpPr txBox="1"/>
+          <p:nvPr/>
+        </p:nvSpPr>
+        <p:spPr>
+          <a:xfrm>
+            <a:off x="2761488" y="4956047"/>
+            <a:ext cx="2048256" cy="914400"/>
+          </a:xfrm>
+          <a:prstGeom prst="rect">
+            <a:avLst/>
+          </a:prstGeom>
+          <a:noFill/>
+        </p:spPr>
+        <p:txBody>
+          <a:bodyPr wrap="square" anchor="ctr" lIns="0" tIns="0" rIns="0" bIns="0">
+            <a:noAutofit/>
+          </a:bodyPr>
+          <a:lstStyle/>
+          <a:p>
+            <a:pPr algn="l" latinLnBrk="0">
+              <a:lnSpc>
+                <a:spcPct val="100000"/>
+              </a:lnSpc>
+              <a:spcBef>
+                <a:spcPts val="0"/>
+              </a:spcBef>
+              <a:spcAft>
+                <a:spcPts val="400"/>
+              </a:spcAft>
+            </a:pPr>
+            <a:r>
+              <a:rPr sz="1050" b="1">
+                <a:solidFill>
+                  <a:srgbClr val="0A2B45"/>
+                </a:solidFill>
+                <a:latin typeface="Microsoft YaHei"/>
+                <a:ea typeface="Microsoft YaHei"/>
+                <a:cs typeface="Microsoft YaHei"/>
+              </a:rPr>
+              <a:t>仿真 · 只淘汰不放行</a:t>
+            </a:r>
+          </a:p>
+          <a:p>
+            <a:pPr algn="l" latinLnBrk="0">
+              <a:lnSpc>
+                <a:spcPct val="100000"/>
+              </a:lnSpc>
+              <a:spcBef>
+                <a:spcPts val="0"/>
+              </a:spcBef>
+              <a:spcAft>
+                <a:spcPts val="200"/>
+              </a:spcAft>
+            </a:pPr>
+            <a:r>
+              <a:rPr sz="900" b="0">
+                <a:solidFill>
+                  <a:srgbClr val="1B4D69"/>
+                </a:solidFill>
+                <a:latin typeface="Microsoft YaHei"/>
+                <a:ea typeface="Microsoft YaHei"/>
+                <a:cs typeface="Microsoft YaHei"/>
+              </a:rPr>
+              <a:t>筛掉明显差的候选</a:t>
+            </a:r>
+          </a:p>
+          <a:p>
+            <a:pPr algn="l" latinLnBrk="0">
+              <a:lnSpc>
+                <a:spcPct val="100000"/>
+              </a:lnSpc>
+              <a:spcBef>
+                <a:spcPts val="0"/>
+              </a:spcBef>
+              <a:spcAft>
+                <a:spcPts val="200"/>
+              </a:spcAft>
+            </a:pPr>
+            <a:r>
+              <a:rPr sz="900" b="0">
+                <a:solidFill>
+                  <a:srgbClr val="1B4D69"/>
+                </a:solidFill>
+                <a:latin typeface="Microsoft YaHei"/>
+                <a:ea typeface="Microsoft YaHei"/>
+                <a:cs typeface="Microsoft YaHei"/>
+              </a:rPr>
+              <a:t>（主要用于引擎候选）</a:t>
+            </a:r>
+          </a:p>
+        </p:txBody>
+      </p:sp>
+      <p:sp>
+        <p:nvSpPr>
+          <p:cNvPr id="53" name="TextBox 52"/>
+          <p:cNvSpPr txBox="1"/>
+          <p:nvPr/>
+        </p:nvSpPr>
+        <p:spPr>
+          <a:xfrm>
+            <a:off x="4956048" y="5193792"/>
+            <a:ext cx="768096" cy="219456"/>
+          </a:xfrm>
+          <a:prstGeom prst="rect">
+            <a:avLst/>
+          </a:prstGeom>
+          <a:noFill/>
+        </p:spPr>
+        <p:txBody>
+          <a:bodyPr wrap="square" anchor="ctr" lIns="0" tIns="0" rIns="0" bIns="0">
+            <a:noAutofit/>
+          </a:bodyPr>
+          <a:lstStyle/>
+          <a:p>
+            <a:pPr algn="ctr" latinLnBrk="0">
+              <a:lnSpc>
+                <a:spcPct val="100000"/>
+              </a:lnSpc>
+              <a:spcBef>
+                <a:spcPts val="0"/>
+              </a:spcBef>
+              <a:spcAft>
+                <a:spcPts val="0"/>
+              </a:spcAft>
+            </a:pPr>
+            <a:r>
+              <a:rPr sz="850" b="0">
+                <a:solidFill>
+                  <a:srgbClr val="40708B"/>
+                </a:solidFill>
+                <a:latin typeface="Microsoft YaHei"/>
+                <a:ea typeface="Microsoft YaHei"/>
+                <a:cs typeface="Microsoft YaHei"/>
+              </a:rPr>
+              <a:t>──→　送测</a:t>
+            </a:r>
+          </a:p>
+        </p:txBody>
+      </p:sp>
+      <p:sp>
+        <p:nvSpPr>
+          <p:cNvPr id="54" name="TextBox 53"/>
+          <p:cNvSpPr txBox="1"/>
+          <p:nvPr/>
+        </p:nvSpPr>
+        <p:spPr>
+          <a:xfrm>
+            <a:off x="4956048" y="5431536"/>
+            <a:ext cx="768096" cy="219456"/>
+          </a:xfrm>
+          <a:prstGeom prst="rect">
+            <a:avLst/>
+          </a:prstGeom>
+          <a:noFill/>
+        </p:spPr>
+        <p:txBody>
+          <a:bodyPr wrap="square" anchor="ctr" lIns="0" tIns="0" rIns="0" bIns="0">
+            <a:noAutofit/>
+          </a:bodyPr>
+          <a:lstStyle/>
+          <a:p>
+            <a:pPr algn="ctr" latinLnBrk="0">
+              <a:lnSpc>
+                <a:spcPct val="100000"/>
+              </a:lnSpc>
+              <a:spcBef>
+                <a:spcPts val="0"/>
+              </a:spcBef>
+              <a:spcAft>
+                <a:spcPts val="0"/>
+              </a:spcAft>
+            </a:pPr>
+            <a:r>
+              <a:rPr sz="850" b="0">
+                <a:solidFill>
+                  <a:srgbClr val="40708B"/>
+                </a:solidFill>
+                <a:latin typeface="Microsoft YaHei"/>
+                <a:ea typeface="Microsoft YaHei"/>
+                <a:cs typeface="Microsoft YaHei"/>
+              </a:rPr>
+              <a:t>←──　校准</a:t>
+            </a:r>
+          </a:p>
+        </p:txBody>
+      </p:sp>
+      <p:sp>
+        <p:nvSpPr>
+          <p:cNvPr id="55" name="Rectangle 54"/>
+          <p:cNvSpPr/>
+          <p:nvPr/>
+        </p:nvSpPr>
+        <p:spPr>
+          <a:xfrm>
+            <a:off x="5724144" y="4901183"/>
+            <a:ext cx="5918911" cy="1024128"/>
+          </a:xfrm>
+          <a:prstGeom prst="rect">
+            <a:avLst/>
+          </a:prstGeom>
+          <a:solidFill>
+            <a:srgbClr val="FFFFFF"/>
+          </a:solidFill>
+          <a:ln w="15875">
+            <a:solidFill>
+              <a:srgbClr val="0F62CE"/>
+            </a:solidFill>
+          </a:ln>
+        </p:spPr>
+        <p:txBody>
+          <a:bodyPr rtlCol="0" anchor="ctr"/>
+          <a:lstStyle/>
+          <a:p>
+            <a:pPr algn="ctr"/>
+          </a:p>
+        </p:txBody>
+      </p:sp>
+      <p:sp>
+        <p:nvSpPr>
+          <p:cNvPr id="56" name="TextBox 55"/>
+          <p:cNvSpPr txBox="1"/>
+          <p:nvPr/>
+        </p:nvSpPr>
+        <p:spPr>
+          <a:xfrm>
+            <a:off x="5925312" y="4937759"/>
+            <a:ext cx="5553151" cy="219456"/>
+          </a:xfrm>
+          <a:prstGeom prst="rect">
+            <a:avLst/>
+          </a:prstGeom>
+          <a:noFill/>
+        </p:spPr>
+        <p:txBody>
+          <a:bodyPr wrap="square" anchor="ctr" lIns="0" tIns="0" rIns="0" bIns="0">
+            <a:noAutofit/>
+          </a:bodyPr>
+          <a:lstStyle/>
+          <a:p>
+            <a:pPr algn="l" latinLnBrk="0">
+              <a:lnSpc>
+                <a:spcPct val="100000"/>
+              </a:lnSpc>
+              <a:spcBef>
+                <a:spcPts val="0"/>
+              </a:spcBef>
+              <a:spcAft>
+                <a:spcPts val="0"/>
+              </a:spcAft>
+            </a:pPr>
+            <a:r>
+              <a:rPr sz="1050" b="1">
+                <a:solidFill>
+                  <a:srgbClr val="0A2B45"/>
+                </a:solidFill>
+                <a:latin typeface="Microsoft YaHei"/>
+                <a:ea typeface="Microsoft YaHei"/>
+                <a:cs typeface="Microsoft YaHei"/>
+              </a:rPr>
+              <a:t>真机 · 唯一的判决</a:t>
+            </a:r>
+          </a:p>
+        </p:txBody>
+      </p:sp>
+      <p:sp>
+        <p:nvSpPr>
+          <p:cNvPr id="57" name="TextBox 56"/>
+          <p:cNvSpPr txBox="1"/>
+          <p:nvPr/>
+        </p:nvSpPr>
+        <p:spPr>
+          <a:xfrm>
+            <a:off x="5925312" y="5175503"/>
+            <a:ext cx="713232" cy="201168"/>
+          </a:xfrm>
+          <a:prstGeom prst="rect">
+            <a:avLst/>
+          </a:prstGeom>
+          <a:noFill/>
+        </p:spPr>
+        <p:txBody>
+          <a:bodyPr wrap="square" anchor="ctr" lIns="0" tIns="0" rIns="0" bIns="0">
+            <a:noAutofit/>
+          </a:bodyPr>
+          <a:lstStyle/>
+          <a:p>
+            <a:pPr algn="l" latinLnBrk="0">
+              <a:lnSpc>
+                <a:spcPct val="100000"/>
+              </a:lnSpc>
+              <a:spcBef>
+                <a:spcPts val="0"/>
+              </a:spcBef>
+              <a:spcAft>
+                <a:spcPts val="0"/>
+              </a:spcAft>
+            </a:pPr>
+            <a:r>
+              <a:rPr sz="900" b="1">
+                <a:solidFill>
+                  <a:srgbClr val="0F62CE"/>
+                </a:solidFill>
+                <a:latin typeface="Consolas"/>
+                <a:ea typeface="Microsoft YaHei"/>
+                <a:cs typeface="Microsoft YaHei"/>
+              </a:rPr>
+              <a:t>算子</a:t>
+            </a:r>
+          </a:p>
+        </p:txBody>
+      </p:sp>
+      <p:sp>
+        <p:nvSpPr>
+          <p:cNvPr id="58" name="TextBox 57"/>
+          <p:cNvSpPr txBox="1"/>
+          <p:nvPr/>
+        </p:nvSpPr>
+        <p:spPr>
+          <a:xfrm>
+            <a:off x="6638544" y="5175503"/>
+            <a:ext cx="4803343" cy="201168"/>
+          </a:xfrm>
+          <a:prstGeom prst="rect">
+            <a:avLst/>
+          </a:prstGeom>
+          <a:noFill/>
+        </p:spPr>
+        <p:txBody>
+          <a:bodyPr wrap="square" anchor="ctr" lIns="0" tIns="0" rIns="0" bIns="0">
+            <a:noAutofit/>
+          </a:bodyPr>
+          <a:lstStyle/>
+          <a:p>
+            <a:pPr algn="l" latinLnBrk="0">
+              <a:lnSpc>
+                <a:spcPct val="100000"/>
+              </a:lnSpc>
+              <a:spcBef>
+                <a:spcPts val="0"/>
+              </a:spcBef>
+              <a:spcAft>
+                <a:spcPts val="0"/>
+              </a:spcAft>
+            </a:pPr>
+            <a:r>
+              <a:rPr sz="900" b="0">
+                <a:solidFill>
+                  <a:srgbClr val="1B4D69"/>
+                </a:solidFill>
+                <a:latin typeface="Microsoft YaHei"/>
+                <a:ea typeface="Microsoft YaHei"/>
+                <a:cs typeface="Microsoft YaHei"/>
+              </a:rPr>
+              <a:t>L0 / L1 / Bench，按引擎给的形状测</a:t>
+            </a:r>
+          </a:p>
+        </p:txBody>
+      </p:sp>
+      <p:sp>
+        <p:nvSpPr>
+          <p:cNvPr id="59" name="TextBox 58"/>
+          <p:cNvSpPr txBox="1"/>
+          <p:nvPr/>
+        </p:nvSpPr>
+        <p:spPr>
+          <a:xfrm>
+            <a:off x="5925312" y="5358383"/>
+            <a:ext cx="713232" cy="201168"/>
+          </a:xfrm>
+          <a:prstGeom prst="rect">
+            <a:avLst/>
+          </a:prstGeom>
+          <a:noFill/>
+        </p:spPr>
+        <p:txBody>
+          <a:bodyPr wrap="square" anchor="ctr" lIns="0" tIns="0" rIns="0" bIns="0">
+            <a:noAutofit/>
+          </a:bodyPr>
+          <a:lstStyle/>
+          <a:p>
+            <a:pPr algn="l" latinLnBrk="0">
+              <a:lnSpc>
+                <a:spcPct val="100000"/>
+              </a:lnSpc>
+              <a:spcBef>
+                <a:spcPts val="0"/>
+              </a:spcBef>
+              <a:spcAft>
+                <a:spcPts val="0"/>
+              </a:spcAft>
+            </a:pPr>
+            <a:r>
+              <a:rPr sz="900" b="1">
+                <a:solidFill>
+                  <a:srgbClr val="0F62CE"/>
+                </a:solidFill>
+                <a:latin typeface="Consolas"/>
+                <a:ea typeface="Microsoft YaHei"/>
+                <a:cs typeface="Microsoft YaHei"/>
+              </a:rPr>
+              <a:t>图</a:t>
+            </a:r>
+          </a:p>
+        </p:txBody>
+      </p:sp>
+      <p:sp>
+        <p:nvSpPr>
+          <p:cNvPr id="60" name="TextBox 59"/>
+          <p:cNvSpPr txBox="1"/>
+          <p:nvPr/>
+        </p:nvSpPr>
+        <p:spPr>
+          <a:xfrm>
+            <a:off x="6638544" y="5358383"/>
+            <a:ext cx="4803343" cy="201168"/>
+          </a:xfrm>
+          <a:prstGeom prst="rect">
+            <a:avLst/>
+          </a:prstGeom>
+          <a:noFill/>
+        </p:spPr>
+        <p:txBody>
+          <a:bodyPr wrap="square" anchor="ctr" lIns="0" tIns="0" rIns="0" bIns="0">
+            <a:noAutofit/>
+          </a:bodyPr>
+          <a:lstStyle/>
+          <a:p>
+            <a:pPr algn="l" latinLnBrk="0">
+              <a:lnSpc>
+                <a:spcPct val="100000"/>
+              </a:lnSpc>
+              <a:spcBef>
+                <a:spcPts val="0"/>
+              </a:spcBef>
+              <a:spcAft>
+                <a:spcPts val="0"/>
+              </a:spcAft>
+            </a:pPr>
+            <a:r>
+              <a:rPr sz="900" b="0">
+                <a:solidFill>
+                  <a:srgbClr val="1B4D69"/>
+                </a:solidFill>
+                <a:latin typeface="Microsoft YaHei"/>
+                <a:ea typeface="Microsoft YaHei"/>
+                <a:cs typeface="Microsoft YaHei"/>
+              </a:rPr>
+              <a:t>整模型 A/B + 质量评测</a:t>
+            </a:r>
+          </a:p>
+        </p:txBody>
+      </p:sp>
+      <p:sp>
+        <p:nvSpPr>
+          <p:cNvPr id="61" name="TextBox 60"/>
+          <p:cNvSpPr txBox="1"/>
+          <p:nvPr/>
+        </p:nvSpPr>
+        <p:spPr>
+          <a:xfrm>
+            <a:off x="5925312" y="5541264"/>
+            <a:ext cx="713232" cy="201168"/>
+          </a:xfrm>
+          <a:prstGeom prst="rect">
+            <a:avLst/>
+          </a:prstGeom>
+          <a:noFill/>
+        </p:spPr>
+        <p:txBody>
+          <a:bodyPr wrap="square" anchor="ctr" lIns="0" tIns="0" rIns="0" bIns="0">
+            <a:noAutofit/>
+          </a:bodyPr>
+          <a:lstStyle/>
+          <a:p>
+            <a:pPr algn="l" latinLnBrk="0">
+              <a:lnSpc>
+                <a:spcPct val="100000"/>
+              </a:lnSpc>
+              <a:spcBef>
+                <a:spcPts val="0"/>
+              </a:spcBef>
+              <a:spcAft>
+                <a:spcPts val="0"/>
+              </a:spcAft>
+            </a:pPr>
+            <a:r>
+              <a:rPr sz="900" b="1">
+                <a:solidFill>
+                  <a:srgbClr val="0F62CE"/>
+                </a:solidFill>
+                <a:latin typeface="Consolas"/>
+                <a:ea typeface="Microsoft YaHei"/>
+                <a:cs typeface="Microsoft YaHei"/>
+              </a:rPr>
+              <a:t>引擎</a:t>
+            </a:r>
+          </a:p>
+        </p:txBody>
+      </p:sp>
+      <p:sp>
+        <p:nvSpPr>
+          <p:cNvPr id="62" name="TextBox 61"/>
+          <p:cNvSpPr txBox="1"/>
+          <p:nvPr/>
+        </p:nvSpPr>
+        <p:spPr>
+          <a:xfrm>
+            <a:off x="6638544" y="5541264"/>
+            <a:ext cx="4803343" cy="201168"/>
+          </a:xfrm>
+          <a:prstGeom prst="rect">
+            <a:avLst/>
+          </a:prstGeom>
+          <a:noFill/>
+        </p:spPr>
+        <p:txBody>
+          <a:bodyPr wrap="square" anchor="ctr" lIns="0" tIns="0" rIns="0" bIns="0">
+            <a:noAutofit/>
+          </a:bodyPr>
+          <a:lstStyle/>
+          <a:p>
+            <a:pPr algn="l" latinLnBrk="0">
+              <a:lnSpc>
+                <a:spcPct val="100000"/>
+              </a:lnSpc>
+              <a:spcBef>
+                <a:spcPts val="0"/>
+              </a:spcBef>
+              <a:spcAft>
+                <a:spcPts val="0"/>
+              </a:spcAft>
+            </a:pPr>
+            <a:r>
+              <a:rPr sz="900" b="0">
+                <a:solidFill>
+                  <a:srgbClr val="1B4D69"/>
+                </a:solidFill>
+                <a:latin typeface="Microsoft YaHei"/>
+                <a:ea typeface="Microsoft YaHei"/>
+                <a:cs typeface="Microsoft YaHei"/>
+              </a:rPr>
+              <a:t>流量回放 · 约束下吞吐与 p99 · 实测接受长度 · OOM 与抢占 · 长稳 · 多画像不退化</a:t>
+            </a:r>
+          </a:p>
+        </p:txBody>
+      </p:sp>
+      <p:sp>
+        <p:nvSpPr>
+          <p:cNvPr id="63" name="TextBox 62"/>
+          <p:cNvSpPr txBox="1"/>
+          <p:nvPr/>
+        </p:nvSpPr>
+        <p:spPr>
+          <a:xfrm>
+            <a:off x="5925312" y="5724144"/>
+            <a:ext cx="713232" cy="201168"/>
+          </a:xfrm>
+          <a:prstGeom prst="rect">
+            <a:avLst/>
+          </a:prstGeom>
+          <a:noFill/>
+        </p:spPr>
+        <p:txBody>
+          <a:bodyPr wrap="square" anchor="ctr" lIns="0" tIns="0" rIns="0" bIns="0">
+            <a:noAutofit/>
+          </a:bodyPr>
+          <a:lstStyle/>
+          <a:p>
+            <a:pPr algn="l" latinLnBrk="0">
+              <a:lnSpc>
+                <a:spcPct val="100000"/>
+              </a:lnSpc>
+              <a:spcBef>
+                <a:spcPts val="0"/>
+              </a:spcBef>
+              <a:spcAft>
+                <a:spcPts val="0"/>
+              </a:spcAft>
+            </a:pPr>
+            <a:r>
+              <a:rPr sz="900" b="1">
+                <a:solidFill>
+                  <a:srgbClr val="0F62CE"/>
+                </a:solidFill>
+                <a:latin typeface="Consolas"/>
+                <a:ea typeface="Microsoft YaHei"/>
+                <a:cs typeface="Microsoft YaHei"/>
+              </a:rPr>
+              <a:t>overlap</a:t>
+            </a:r>
+          </a:p>
+        </p:txBody>
+      </p:sp>
+      <p:sp>
+        <p:nvSpPr>
+          <p:cNvPr id="64" name="TextBox 63"/>
+          <p:cNvSpPr txBox="1"/>
+          <p:nvPr/>
+        </p:nvSpPr>
+        <p:spPr>
+          <a:xfrm>
+            <a:off x="6638544" y="5724144"/>
+            <a:ext cx="4803343" cy="201168"/>
+          </a:xfrm>
+          <a:prstGeom prst="rect">
+            <a:avLst/>
+          </a:prstGeom>
+          <a:noFill/>
+        </p:spPr>
+        <p:txBody>
+          <a:bodyPr wrap="square" anchor="ctr" lIns="0" tIns="0" rIns="0" bIns="0">
+            <a:noAutofit/>
+          </a:bodyPr>
+          <a:lstStyle/>
+          <a:p>
+            <a:pPr algn="l" latinLnBrk="0">
+              <a:lnSpc>
+                <a:spcPct val="100000"/>
+              </a:lnSpc>
+              <a:spcBef>
+                <a:spcPts val="0"/>
+              </a:spcBef>
+              <a:spcAft>
+                <a:spcPts val="0"/>
+              </a:spcAft>
+            </a:pPr>
+            <a:r>
+              <a:rPr sz="900" b="0">
+                <a:solidFill>
+                  <a:srgbClr val="1B4D69"/>
+                </a:solidFill>
+                <a:latin typeface="Microsoft YaHei"/>
+                <a:ea typeface="Microsoft YaHei"/>
+                <a:cs typeface="Microsoft YaHei"/>
+              </a:rPr>
+              <a:t>与关闭时输出一致 · 长压测抓竞态</a:t>
+            </a:r>
+          </a:p>
+        </p:txBody>
+      </p:sp>
+      <p:sp>
+        <p:nvSpPr>
+          <p:cNvPr id="65" name="Rectangle 64"/>
+          <p:cNvSpPr/>
+          <p:nvPr/>
+        </p:nvSpPr>
+        <p:spPr>
+          <a:xfrm>
+            <a:off x="950976" y="6071616"/>
+            <a:ext cx="10692079" cy="329184"/>
+          </a:xfrm>
+          <a:prstGeom prst="rect">
+            <a:avLst/>
+          </a:prstGeom>
+          <a:solidFill>
+            <a:srgbClr val="E6F0FC"/>
+          </a:solidFill>
+          <a:ln>
+            <a:noFill/>
+          </a:ln>
+        </p:spPr>
+        <p:txBody>
+          <a:bodyPr rtlCol="0" anchor="ctr"/>
+          <a:lstStyle/>
+          <a:p>
+            <a:pPr algn="ctr"/>
+          </a:p>
+        </p:txBody>
+      </p:sp>
+      <p:sp>
+        <p:nvSpPr>
+          <p:cNvPr id="66" name="TextBox 65"/>
+          <p:cNvSpPr txBox="1"/>
+          <p:nvPr/>
+        </p:nvSpPr>
+        <p:spPr>
+          <a:xfrm>
+            <a:off x="1225296" y="6071616"/>
+            <a:ext cx="10234879" cy="329184"/>
+          </a:xfrm>
+          <a:prstGeom prst="rect">
+            <a:avLst/>
+          </a:prstGeom>
+          <a:noFill/>
+        </p:spPr>
+        <p:txBody>
+          <a:bodyPr wrap="square" anchor="ctr" lIns="0" tIns="0" rIns="0" bIns="0">
+            <a:noAutofit/>
+          </a:bodyPr>
+          <a:lstStyle/>
+          <a:p>
+            <a:pPr algn="l" latinLnBrk="0">
+              <a:lnSpc>
+                <a:spcPct val="100000"/>
+              </a:lnSpc>
+              <a:spcBef>
+                <a:spcPts val="0"/>
+              </a:spcBef>
+              <a:spcAft>
+                <a:spcPts val="0"/>
+              </a:spcAft>
+            </a:pPr>
+            <a:r>
+              <a:rPr sz="1100" b="1">
+                <a:solidFill>
+                  <a:srgbClr val="0F62CE"/>
+                </a:solidFill>
+                <a:latin typeface="Microsoft YaHei"/>
+                <a:ea typeface="Microsoft YaHei"/>
+                <a:cs typeface="Microsoft YaHei"/>
+              </a:rPr>
+              <a:t>通</a:t>
+            </a:r>
+            <a:r>
+              <a:rPr sz="1100" b="1">
+                <a:solidFill>
+                  <a:srgbClr val="0A2B45"/>
+                </a:solidFill>
+                <a:latin typeface="Microsoft YaHei"/>
+                <a:ea typeface="Microsoft YaHei"/>
+                <a:cs typeface="Microsoft YaHei"/>
+              </a:rPr>
+              <a:t>过：成为新基线，回目标层重算差距　·　提不出跨过噪声门槛的候选即收敛</a:t>
+            </a:r>
+          </a:p>
+        </p:txBody>
+      </p:sp>
+      <p:sp>
+        <p:nvSpPr>
+          <p:cNvPr id="67" name="Freeform 66"/>
+          <p:cNvSpPr/>
+          <p:nvPr/>
+        </p:nvSpPr>
+        <p:spPr>
+          <a:xfrm>
+            <a:off x="640080" y="1645920"/>
+            <a:ext cx="310896" cy="4590287"/>
+          </a:xfrm>
+          <a:custGeom>
+            <a:avLst/>
+            <a:gdLst/>
+            <a:ahLst/>
+            <a:cxnLst/>
+            <a:rect l="l" t="t" r="r" b="b"/>
+            <a:pathLst>
+              <a:path w="310896" h="4590287">
+                <a:moveTo>
+                  <a:pt x="310896" y="4590287"/>
+                </a:moveTo>
+                <a:lnTo>
+                  <a:pt x="0" y="4590287"/>
+                </a:lnTo>
+                <a:lnTo>
+                  <a:pt x="0" y="0"/>
+                </a:lnTo>
+              </a:path>
+            </a:pathLst>
+          </a:custGeom>
+          <a:noFill/>
+          <a:ln w="19050">
+            <a:solidFill>
+              <a:srgbClr val="0F62CE"/>
+            </a:solidFill>
+          </a:ln>
+        </p:spPr>
+        <p:txBody>
+          <a:bodyPr rtlCol="0" anchor="ctr"/>
+          <a:lstStyle/>
+          <a:p>
+            <a:pPr algn="ctr"/>
+          </a:p>
+        </p:txBody>
+      </p:sp>
+      <p:cxnSp>
+        <p:nvCxnSpPr>
+          <p:cNvPr id="68" name="Connector 67"/>
+          <p:cNvCxnSpPr/>
+          <p:nvPr/>
+        </p:nvCxnSpPr>
+        <p:spPr>
+          <a:xfrm>
+            <a:off x="640080" y="1645920"/>
+            <a:ext cx="292608" cy="0"/>
+          </a:xfrm>
+          <a:prstGeom prst="line">
+            <a:avLst/>
+          </a:prstGeom>
+          <a:ln w="19050">
+            <a:solidFill>
+              <a:srgbClr val="0F62CE"/>
+            </a:solidFill>
+            <a:tailEnd type="triangle" w="med" len="med"/>
+          </a:ln>
+        </p:spPr>
+      </p:cxnSp>
+      <p:sp>
+        <p:nvSpPr>
+          <p:cNvPr id="69" name="TextBox 68"/>
+          <p:cNvSpPr txBox="1"/>
+          <p:nvPr/>
+        </p:nvSpPr>
+        <p:spPr>
+          <a:xfrm>
+            <a:off x="548640" y="6455664"/>
+            <a:ext cx="8595360" cy="256032"/>
+          </a:xfrm>
+          <a:prstGeom prst="rect">
+            <a:avLst/>
+          </a:prstGeom>
+          <a:noFill/>
+        </p:spPr>
+        <p:txBody>
+          <a:bodyPr wrap="square" anchor="ctr" lIns="0" tIns="0" rIns="0" bIns="0">
+            <a:noAutofit/>
+          </a:bodyPr>
+          <a:lstStyle/>
+          <a:p>
+            <a:pPr algn="l" latinLnBrk="0">
+              <a:lnSpc>
+                <a:spcPct val="100000"/>
+              </a:lnSpc>
+              <a:spcBef>
+                <a:spcPts val="0"/>
+              </a:spcBef>
+              <a:spcAft>
+                <a:spcPts val="0"/>
+              </a:spcAft>
+            </a:pPr>
+            <a:r>
+              <a:rPr sz="900" b="0">
+                <a:solidFill>
+                  <a:srgbClr val="40708B"/>
+                </a:solidFill>
+                <a:latin typeface="Microsoft YaHei"/>
+                <a:ea typeface="Microsoft YaHei"/>
+                <a:cs typeface="Microsoft YaHei"/>
+              </a:rPr>
+              <a:t>第 7 页是单步口径（ms/步），本页是服务口径（约束下的吞吐），两页的数不能直接对齐</a:t>
+            </a:r>
+          </a:p>
+        </p:txBody>
+      </p:sp>
+      <p:sp>
+        <p:nvSpPr>
+          <p:cNvPr id="70" name="TextBox 69"/>
           <p:cNvSpPr txBox="1"/>
           <p:nvPr/>
         </p:nvSpPr>

</xml_diff>

<commit_message>
slides: lay the overall-plan page out as a stage matrix
The two layers used to be two self-contained rows, so the reader had to
notice on their own that both rows run the same four stages. They are now
columns with a header: task input, the generation side that is the only
place a model appears, the rule-driven verdict side, and the admission
exit. The generation and verdict headers carry the orange and blue the
deck already uses for those roles, so one glance down a column says which
side a cell belongs to, and the cross-layer exchange sits between the rows
with each arrow under the column it leaves from and returns to.
</commit_message>
<xml_diff>
--- a/slides/m100_agent_final_deck.pptx
+++ b/slides/m100_agent_final_deck.pptx
@@ -13006,7 +13006,7 @@
                 <a:ea typeface="Microsoft YaHei"/>
                 <a:cs typeface="Microsoft YaHei"/>
               </a:rPr>
-              <a:t>M100 Agent： 总体方案</a:t>
+              <a:t>M100 Agent： 总体方案（写判分离 · 双层同构 · 跨层闭环）</a:t>
             </a:r>
           </a:p>
         </p:txBody>
@@ -13066,8 +13066,691 @@
         </p:nvSpPr>
         <p:spPr>
           <a:xfrm>
-            <a:off x="548640" y="1335024"/>
-            <a:ext cx="11094415" cy="2011680"/>
+            <a:off x="548640" y="1225296"/>
+            <a:ext cx="1554480" cy="475488"/>
+          </a:xfrm>
+          <a:prstGeom prst="rect">
+            <a:avLst/>
+          </a:prstGeom>
+          <a:solidFill>
+            <a:srgbClr val="F2F8FD"/>
+          </a:solidFill>
+          <a:ln>
+            <a:noFill/>
+          </a:ln>
+        </p:spPr>
+        <p:txBody>
+          <a:bodyPr rtlCol="0" anchor="ctr"/>
+          <a:lstStyle/>
+          <a:p>
+            <a:pPr algn="ctr"/>
+          </a:p>
+        </p:txBody>
+      </p:sp>
+      <p:sp>
+        <p:nvSpPr>
+          <p:cNvPr id="7" name="TextBox 6"/>
+          <p:cNvSpPr txBox="1"/>
+          <p:nvPr/>
+        </p:nvSpPr>
+        <p:spPr>
+          <a:xfrm>
+            <a:off x="694944" y="1261872"/>
+            <a:ext cx="1280160" cy="402336"/>
+          </a:xfrm>
+          <a:prstGeom prst="rect">
+            <a:avLst/>
+          </a:prstGeom>
+          <a:noFill/>
+        </p:spPr>
+        <p:txBody>
+          <a:bodyPr wrap="square" anchor="ctr" lIns="0" tIns="0" rIns="0" bIns="0">
+            <a:noAutofit/>
+          </a:bodyPr>
+          <a:lstStyle/>
+          <a:p>
+            <a:pPr algn="ctr" latinLnBrk="0">
+              <a:lnSpc>
+                <a:spcPct val="100000"/>
+              </a:lnSpc>
+              <a:spcBef>
+                <a:spcPts val="0"/>
+              </a:spcBef>
+              <a:spcAft>
+                <a:spcPts val="200"/>
+              </a:spcAft>
+            </a:pPr>
+            <a:r>
+              <a:rPr sz="1100" b="1">
+                <a:solidFill>
+                  <a:srgbClr val="0A2B45"/>
+                </a:solidFill>
+                <a:latin typeface="Microsoft YaHei"/>
+                <a:ea typeface="Microsoft YaHei"/>
+                <a:cs typeface="Microsoft YaHei"/>
+              </a:rPr>
+              <a:t>层级定位</a:t>
+            </a:r>
+          </a:p>
+        </p:txBody>
+      </p:sp>
+      <p:sp>
+        <p:nvSpPr>
+          <p:cNvPr id="8" name="Rectangle 7"/>
+          <p:cNvSpPr/>
+          <p:nvPr/>
+        </p:nvSpPr>
+        <p:spPr>
+          <a:xfrm>
+            <a:off x="2212848" y="1225296"/>
+            <a:ext cx="1792224" cy="475488"/>
+          </a:xfrm>
+          <a:prstGeom prst="rect">
+            <a:avLst/>
+          </a:prstGeom>
+          <a:solidFill>
+            <a:srgbClr val="F2F8FD"/>
+          </a:solidFill>
+          <a:ln>
+            <a:noFill/>
+          </a:ln>
+        </p:spPr>
+        <p:txBody>
+          <a:bodyPr rtlCol="0" anchor="ctr"/>
+          <a:lstStyle/>
+          <a:p>
+            <a:pPr algn="ctr"/>
+          </a:p>
+        </p:txBody>
+      </p:sp>
+      <p:sp>
+        <p:nvSpPr>
+          <p:cNvPr id="9" name="TextBox 8"/>
+          <p:cNvSpPr txBox="1"/>
+          <p:nvPr/>
+        </p:nvSpPr>
+        <p:spPr>
+          <a:xfrm>
+            <a:off x="2359152" y="1261872"/>
+            <a:ext cx="1517904" cy="402336"/>
+          </a:xfrm>
+          <a:prstGeom prst="rect">
+            <a:avLst/>
+          </a:prstGeom>
+          <a:noFill/>
+        </p:spPr>
+        <p:txBody>
+          <a:bodyPr wrap="square" anchor="ctr" lIns="0" tIns="0" rIns="0" bIns="0">
+            <a:noAutofit/>
+          </a:bodyPr>
+          <a:lstStyle/>
+          <a:p>
+            <a:pPr algn="ctr" latinLnBrk="0">
+              <a:lnSpc>
+                <a:spcPct val="100000"/>
+              </a:lnSpc>
+              <a:spcBef>
+                <a:spcPts val="0"/>
+              </a:spcBef>
+              <a:spcAft>
+                <a:spcPts val="200"/>
+              </a:spcAft>
+            </a:pPr>
+            <a:r>
+              <a:rPr sz="1100" b="1">
+                <a:solidFill>
+                  <a:srgbClr val="1B4D69"/>
+                </a:solidFill>
+                <a:latin typeface="Microsoft YaHei"/>
+                <a:ea typeface="Microsoft YaHei"/>
+                <a:cs typeface="Microsoft YaHei"/>
+              </a:rPr>
+              <a:t>① </a:t>
+            </a:r>
+            <a:r>
+              <a:rPr sz="1100" b="1">
+                <a:solidFill>
+                  <a:srgbClr val="0A2B45"/>
+                </a:solidFill>
+                <a:latin typeface="Microsoft YaHei"/>
+                <a:ea typeface="Microsoft YaHei"/>
+                <a:cs typeface="Microsoft YaHei"/>
+              </a:rPr>
+              <a:t>任务输入</a:t>
+            </a:r>
+          </a:p>
+        </p:txBody>
+      </p:sp>
+      <p:sp>
+        <p:nvSpPr>
+          <p:cNvPr id="10" name="Rectangle 9"/>
+          <p:cNvSpPr/>
+          <p:nvPr/>
+        </p:nvSpPr>
+        <p:spPr>
+          <a:xfrm>
+            <a:off x="4242816" y="1225296"/>
+            <a:ext cx="2670048" cy="475488"/>
+          </a:xfrm>
+          <a:prstGeom prst="rect">
+            <a:avLst/>
+          </a:prstGeom>
+          <a:solidFill>
+            <a:srgbClr val="FBE6D4"/>
+          </a:solidFill>
+          <a:ln>
+            <a:noFill/>
+          </a:ln>
+        </p:spPr>
+        <p:txBody>
+          <a:bodyPr rtlCol="0" anchor="ctr"/>
+          <a:lstStyle/>
+          <a:p>
+            <a:pPr algn="ctr"/>
+          </a:p>
+        </p:txBody>
+      </p:sp>
+      <p:sp>
+        <p:nvSpPr>
+          <p:cNvPr id="11" name="Rectangle 10"/>
+          <p:cNvSpPr/>
+          <p:nvPr/>
+        </p:nvSpPr>
+        <p:spPr>
+          <a:xfrm>
+            <a:off x="4242816" y="1225296"/>
+            <a:ext cx="2670048" cy="45720"/>
+          </a:xfrm>
+          <a:prstGeom prst="rect">
+            <a:avLst/>
+          </a:prstGeom>
+          <a:solidFill>
+            <a:srgbClr val="C2570A"/>
+          </a:solidFill>
+          <a:ln>
+            <a:noFill/>
+          </a:ln>
+        </p:spPr>
+        <p:txBody>
+          <a:bodyPr rtlCol="0" anchor="ctr"/>
+          <a:lstStyle/>
+          <a:p>
+            <a:pPr algn="ctr"/>
+          </a:p>
+        </p:txBody>
+      </p:sp>
+      <p:sp>
+        <p:nvSpPr>
+          <p:cNvPr id="12" name="TextBox 11"/>
+          <p:cNvSpPr txBox="1"/>
+          <p:nvPr/>
+        </p:nvSpPr>
+        <p:spPr>
+          <a:xfrm>
+            <a:off x="4389120" y="1261872"/>
+            <a:ext cx="2395728" cy="402336"/>
+          </a:xfrm>
+          <a:prstGeom prst="rect">
+            <a:avLst/>
+          </a:prstGeom>
+          <a:noFill/>
+        </p:spPr>
+        <p:txBody>
+          <a:bodyPr wrap="square" anchor="ctr" lIns="0" tIns="0" rIns="0" bIns="0">
+            <a:noAutofit/>
+          </a:bodyPr>
+          <a:lstStyle/>
+          <a:p>
+            <a:pPr algn="ctr" latinLnBrk="0">
+              <a:lnSpc>
+                <a:spcPct val="100000"/>
+              </a:lnSpc>
+              <a:spcBef>
+                <a:spcPts val="0"/>
+              </a:spcBef>
+              <a:spcAft>
+                <a:spcPts val="200"/>
+              </a:spcAft>
+            </a:pPr>
+            <a:r>
+              <a:rPr sz="1100" b="1">
+                <a:solidFill>
+                  <a:srgbClr val="C2570A"/>
+                </a:solidFill>
+                <a:latin typeface="Microsoft YaHei"/>
+                <a:ea typeface="Microsoft YaHei"/>
+                <a:cs typeface="Microsoft YaHei"/>
+              </a:rPr>
+              <a:t>② </a:t>
+            </a:r>
+            <a:r>
+              <a:rPr sz="1100" b="1">
+                <a:solidFill>
+                  <a:srgbClr val="0A2B45"/>
+                </a:solidFill>
+                <a:latin typeface="Microsoft YaHei"/>
+                <a:ea typeface="Microsoft YaHei"/>
+                <a:cs typeface="Microsoft YaHei"/>
+              </a:rPr>
+              <a:t>AI 生成侧（写）</a:t>
+            </a:r>
+          </a:p>
+          <a:p>
+            <a:pPr algn="ctr" latinLnBrk="0">
+              <a:lnSpc>
+                <a:spcPct val="100000"/>
+              </a:lnSpc>
+              <a:spcBef>
+                <a:spcPts val="0"/>
+              </a:spcBef>
+              <a:spcAft>
+                <a:spcPts val="0"/>
+              </a:spcAft>
+            </a:pPr>
+            <a:r>
+              <a:rPr sz="900" b="0">
+                <a:solidFill>
+                  <a:srgbClr val="C2570A"/>
+                </a:solidFill>
+                <a:latin typeface="Microsoft YaHei"/>
+                <a:ea typeface="Microsoft YaHei"/>
+                <a:cs typeface="Microsoft YaHei"/>
+              </a:rPr>
+              <a:t>唯一引入大模型的位置</a:t>
+            </a:r>
+          </a:p>
+        </p:txBody>
+      </p:sp>
+      <p:sp>
+        <p:nvSpPr>
+          <p:cNvPr id="13" name="Rectangle 12"/>
+          <p:cNvSpPr/>
+          <p:nvPr/>
+        </p:nvSpPr>
+        <p:spPr>
+          <a:xfrm>
+            <a:off x="7150608" y="1225296"/>
+            <a:ext cx="2852928" cy="475488"/>
+          </a:xfrm>
+          <a:prstGeom prst="rect">
+            <a:avLst/>
+          </a:prstGeom>
+          <a:solidFill>
+            <a:srgbClr val="E6F0FC"/>
+          </a:solidFill>
+          <a:ln>
+            <a:noFill/>
+          </a:ln>
+        </p:spPr>
+        <p:txBody>
+          <a:bodyPr rtlCol="0" anchor="ctr"/>
+          <a:lstStyle/>
+          <a:p>
+            <a:pPr algn="ctr"/>
+          </a:p>
+        </p:txBody>
+      </p:sp>
+      <p:sp>
+        <p:nvSpPr>
+          <p:cNvPr id="14" name="Rectangle 13"/>
+          <p:cNvSpPr/>
+          <p:nvPr/>
+        </p:nvSpPr>
+        <p:spPr>
+          <a:xfrm>
+            <a:off x="7150608" y="1225296"/>
+            <a:ext cx="2852928" cy="45720"/>
+          </a:xfrm>
+          <a:prstGeom prst="rect">
+            <a:avLst/>
+          </a:prstGeom>
+          <a:solidFill>
+            <a:srgbClr val="0F62CE"/>
+          </a:solidFill>
+          <a:ln>
+            <a:noFill/>
+          </a:ln>
+        </p:spPr>
+        <p:txBody>
+          <a:bodyPr rtlCol="0" anchor="ctr"/>
+          <a:lstStyle/>
+          <a:p>
+            <a:pPr algn="ctr"/>
+          </a:p>
+        </p:txBody>
+      </p:sp>
+      <p:sp>
+        <p:nvSpPr>
+          <p:cNvPr id="15" name="TextBox 14"/>
+          <p:cNvSpPr txBox="1"/>
+          <p:nvPr/>
+        </p:nvSpPr>
+        <p:spPr>
+          <a:xfrm>
+            <a:off x="7296912" y="1261872"/>
+            <a:ext cx="2578608" cy="402336"/>
+          </a:xfrm>
+          <a:prstGeom prst="rect">
+            <a:avLst/>
+          </a:prstGeom>
+          <a:noFill/>
+        </p:spPr>
+        <p:txBody>
+          <a:bodyPr wrap="square" anchor="ctr" lIns="0" tIns="0" rIns="0" bIns="0">
+            <a:noAutofit/>
+          </a:bodyPr>
+          <a:lstStyle/>
+          <a:p>
+            <a:pPr algn="ctr" latinLnBrk="0">
+              <a:lnSpc>
+                <a:spcPct val="100000"/>
+              </a:lnSpc>
+              <a:spcBef>
+                <a:spcPts val="0"/>
+              </a:spcBef>
+              <a:spcAft>
+                <a:spcPts val="200"/>
+              </a:spcAft>
+            </a:pPr>
+            <a:r>
+              <a:rPr sz="1100" b="1">
+                <a:solidFill>
+                  <a:srgbClr val="0F62CE"/>
+                </a:solidFill>
+                <a:latin typeface="Microsoft YaHei"/>
+                <a:ea typeface="Microsoft YaHei"/>
+                <a:cs typeface="Microsoft YaHei"/>
+              </a:rPr>
+              <a:t>③ </a:t>
+            </a:r>
+            <a:r>
+              <a:rPr sz="1100" b="1">
+                <a:solidFill>
+                  <a:srgbClr val="0A2B45"/>
+                </a:solidFill>
+                <a:latin typeface="Microsoft YaHei"/>
+                <a:ea typeface="Microsoft YaHei"/>
+                <a:cs typeface="Microsoft YaHei"/>
+              </a:rPr>
+              <a:t>确定性验证侧（判）</a:t>
+            </a:r>
+          </a:p>
+          <a:p>
+            <a:pPr algn="ctr" latinLnBrk="0">
+              <a:lnSpc>
+                <a:spcPct val="100000"/>
+              </a:lnSpc>
+              <a:spcBef>
+                <a:spcPts val="0"/>
+              </a:spcBef>
+              <a:spcAft>
+                <a:spcPts val="0"/>
+              </a:spcAft>
+            </a:pPr>
+            <a:r>
+              <a:rPr sz="900" b="0">
+                <a:solidFill>
+                  <a:srgbClr val="0F62CE"/>
+                </a:solidFill>
+                <a:latin typeface="Microsoft YaHei"/>
+                <a:ea typeface="Microsoft YaHei"/>
+                <a:cs typeface="Microsoft YaHei"/>
+              </a:rPr>
+              <a:t>纯规则驱动 · 真机实测</a:t>
+            </a:r>
+          </a:p>
+        </p:txBody>
+      </p:sp>
+      <p:sp>
+        <p:nvSpPr>
+          <p:cNvPr id="16" name="Rectangle 15"/>
+          <p:cNvSpPr/>
+          <p:nvPr/>
+        </p:nvSpPr>
+        <p:spPr>
+          <a:xfrm>
+            <a:off x="10241280" y="1225296"/>
+            <a:ext cx="1389888" cy="475488"/>
+          </a:xfrm>
+          <a:prstGeom prst="rect">
+            <a:avLst/>
+          </a:prstGeom>
+          <a:solidFill>
+            <a:srgbClr val="F2F8FD"/>
+          </a:solidFill>
+          <a:ln>
+            <a:noFill/>
+          </a:ln>
+        </p:spPr>
+        <p:txBody>
+          <a:bodyPr rtlCol="0" anchor="ctr"/>
+          <a:lstStyle/>
+          <a:p>
+            <a:pPr algn="ctr"/>
+          </a:p>
+        </p:txBody>
+      </p:sp>
+      <p:sp>
+        <p:nvSpPr>
+          <p:cNvPr id="17" name="TextBox 16"/>
+          <p:cNvSpPr txBox="1"/>
+          <p:nvPr/>
+        </p:nvSpPr>
+        <p:spPr>
+          <a:xfrm>
+            <a:off x="10387584" y="1261872"/>
+            <a:ext cx="1115568" cy="402336"/>
+          </a:xfrm>
+          <a:prstGeom prst="rect">
+            <a:avLst/>
+          </a:prstGeom>
+          <a:noFill/>
+        </p:spPr>
+        <p:txBody>
+          <a:bodyPr wrap="square" anchor="ctr" lIns="0" tIns="0" rIns="0" bIns="0">
+            <a:noAutofit/>
+          </a:bodyPr>
+          <a:lstStyle/>
+          <a:p>
+            <a:pPr algn="ctr" latinLnBrk="0">
+              <a:lnSpc>
+                <a:spcPct val="100000"/>
+              </a:lnSpc>
+              <a:spcBef>
+                <a:spcPts val="0"/>
+              </a:spcBef>
+              <a:spcAft>
+                <a:spcPts val="200"/>
+              </a:spcAft>
+            </a:pPr>
+            <a:r>
+              <a:rPr sz="1100" b="1">
+                <a:solidFill>
+                  <a:srgbClr val="1B4D69"/>
+                </a:solidFill>
+                <a:latin typeface="Microsoft YaHei"/>
+                <a:ea typeface="Microsoft YaHei"/>
+                <a:cs typeface="Microsoft YaHei"/>
+              </a:rPr>
+              <a:t>④ </a:t>
+            </a:r>
+            <a:r>
+              <a:rPr sz="1100" b="1">
+                <a:solidFill>
+                  <a:srgbClr val="0A2B45"/>
+                </a:solidFill>
+                <a:latin typeface="Microsoft YaHei"/>
+                <a:ea typeface="Microsoft YaHei"/>
+                <a:cs typeface="Microsoft YaHei"/>
+              </a:rPr>
+              <a:t>准入出口</a:t>
+            </a:r>
+          </a:p>
+        </p:txBody>
+      </p:sp>
+      <p:sp>
+        <p:nvSpPr>
+          <p:cNvPr id="18" name="Rectangle 17"/>
+          <p:cNvSpPr/>
+          <p:nvPr/>
+        </p:nvSpPr>
+        <p:spPr>
+          <a:xfrm>
+            <a:off x="548640" y="1755648"/>
+            <a:ext cx="11094415" cy="1481328"/>
+          </a:xfrm>
+          <a:prstGeom prst="rect">
+            <a:avLst/>
+          </a:prstGeom>
+          <a:solidFill>
+            <a:srgbClr val="F2F8FD"/>
+          </a:solidFill>
+          <a:ln>
+            <a:noFill/>
+          </a:ln>
+        </p:spPr>
+        <p:txBody>
+          <a:bodyPr rtlCol="0" anchor="ctr"/>
+          <a:lstStyle/>
+          <a:p>
+            <a:pPr algn="ctr"/>
+          </a:p>
+        </p:txBody>
+      </p:sp>
+      <p:sp>
+        <p:nvSpPr>
+          <p:cNvPr id="19" name="Rectangle 18"/>
+          <p:cNvSpPr/>
+          <p:nvPr/>
+        </p:nvSpPr>
+        <p:spPr>
+          <a:xfrm>
+            <a:off x="548640" y="1755648"/>
+            <a:ext cx="64008" cy="1481328"/>
+          </a:xfrm>
+          <a:prstGeom prst="rect">
+            <a:avLst/>
+          </a:prstGeom>
+          <a:solidFill>
+            <a:srgbClr val="D2690C"/>
+          </a:solidFill>
+          <a:ln>
+            <a:noFill/>
+          </a:ln>
+        </p:spPr>
+        <p:txBody>
+          <a:bodyPr rtlCol="0" anchor="ctr"/>
+          <a:lstStyle/>
+          <a:p>
+            <a:pPr algn="ctr"/>
+          </a:p>
+        </p:txBody>
+      </p:sp>
+      <p:sp>
+        <p:nvSpPr>
+          <p:cNvPr id="20" name="TextBox 19"/>
+          <p:cNvSpPr txBox="1"/>
+          <p:nvPr/>
+        </p:nvSpPr>
+        <p:spPr>
+          <a:xfrm>
+            <a:off x="749808" y="2029967"/>
+            <a:ext cx="1225295" cy="932688"/>
+          </a:xfrm>
+          <a:prstGeom prst="rect">
+            <a:avLst/>
+          </a:prstGeom>
+          <a:noFill/>
+        </p:spPr>
+        <p:txBody>
+          <a:bodyPr wrap="square" anchor="t" lIns="0" tIns="0" rIns="0" bIns="0">
+            <a:noAutofit/>
+          </a:bodyPr>
+          <a:lstStyle/>
+          <a:p>
+            <a:pPr algn="l" latinLnBrk="0">
+              <a:lnSpc>
+                <a:spcPct val="100000"/>
+              </a:lnSpc>
+              <a:spcBef>
+                <a:spcPts val="0"/>
+              </a:spcBef>
+              <a:spcAft>
+                <a:spcPts val="300"/>
+              </a:spcAft>
+            </a:pPr>
+            <a:r>
+              <a:rPr sz="1300" b="1">
+                <a:solidFill>
+                  <a:srgbClr val="0A2B45"/>
+                </a:solidFill>
+                <a:latin typeface="Microsoft YaHei"/>
+                <a:ea typeface="Microsoft YaHei"/>
+                <a:cs typeface="Microsoft YaHei"/>
+              </a:rPr>
+              <a:t>【模型层】</a:t>
+            </a:r>
+          </a:p>
+          <a:p>
+            <a:pPr algn="l" latinLnBrk="0">
+              <a:lnSpc>
+                <a:spcPct val="100000"/>
+              </a:lnSpc>
+              <a:spcBef>
+                <a:spcPts val="0"/>
+              </a:spcBef>
+              <a:spcAft>
+                <a:spcPts val="400"/>
+              </a:spcAft>
+            </a:pPr>
+            <a:r>
+              <a:rPr sz="1000" b="1">
+                <a:solidFill>
+                  <a:srgbClr val="C2570A"/>
+                </a:solidFill>
+                <a:latin typeface="Consolas"/>
+                <a:ea typeface="Microsoft YaHei"/>
+                <a:cs typeface="Microsoft YaHei"/>
+              </a:rPr>
+              <a:t>model-agent</a:t>
+            </a:r>
+          </a:p>
+          <a:p>
+            <a:pPr algn="l" latinLnBrk="0">
+              <a:lnSpc>
+                <a:spcPct val="100000"/>
+              </a:lnSpc>
+              <a:spcBef>
+                <a:spcPts val="0"/>
+              </a:spcBef>
+              <a:spcAft>
+                <a:spcPts val="0"/>
+              </a:spcAft>
+            </a:pPr>
+            <a:r>
+              <a:rPr sz="800" b="0">
+                <a:solidFill>
+                  <a:srgbClr val="40708B"/>
+                </a:solidFill>
+                <a:latin typeface="Microsoft YaHei"/>
+                <a:ea typeface="Microsoft YaHei"/>
+                <a:cs typeface="Microsoft YaHei"/>
+              </a:rPr>
+              <a:t>模型接入与性能调优</a:t>
+            </a:r>
+          </a:p>
+        </p:txBody>
+      </p:sp>
+      <p:sp>
+        <p:nvSpPr>
+          <p:cNvPr id="21" name="Rectangle 20"/>
+          <p:cNvSpPr/>
+          <p:nvPr/>
+        </p:nvSpPr>
+        <p:spPr>
+          <a:xfrm>
+            <a:off x="2212848" y="2103120"/>
+            <a:ext cx="1792224" cy="1060704"/>
           </a:xfrm>
           <a:prstGeom prst="rect">
             <a:avLst/>
@@ -13091,225 +13774,107 @@
       </p:sp>
       <p:sp>
         <p:nvSpPr>
-          <p:cNvPr id="7" name="Rectangle 6"/>
+          <p:cNvPr id="22" name="TextBox 21"/>
+          <p:cNvSpPr txBox="1"/>
+          <p:nvPr/>
+        </p:nvSpPr>
+        <p:spPr>
+          <a:xfrm>
+            <a:off x="2359152" y="2157984"/>
+            <a:ext cx="1426464" cy="950976"/>
+          </a:xfrm>
+          <a:prstGeom prst="rect">
+            <a:avLst/>
+          </a:prstGeom>
+          <a:noFill/>
+        </p:spPr>
+        <p:txBody>
+          <a:bodyPr wrap="square" anchor="ctr" lIns="0" tIns="0" rIns="0" bIns="0">
+            <a:noAutofit/>
+          </a:bodyPr>
+          <a:lstStyle/>
+          <a:p>
+            <a:pPr algn="l" latinLnBrk="0">
+              <a:lnSpc>
+                <a:spcPct val="100000"/>
+              </a:lnSpc>
+              <a:spcBef>
+                <a:spcPts val="0"/>
+              </a:spcBef>
+              <a:spcAft>
+                <a:spcPts val="400"/>
+              </a:spcAft>
+            </a:pPr>
+            <a:r>
+              <a:rPr sz="1100" b="1">
+                <a:solidFill>
+                  <a:srgbClr val="0A2B45"/>
+                </a:solidFill>
+                <a:latin typeface="Microsoft YaHei"/>
+                <a:ea typeface="Microsoft YaHei"/>
+                <a:cs typeface="Microsoft YaHei"/>
+              </a:rPr>
+              <a:t>人：定目标与边界</a:t>
+            </a:r>
+          </a:p>
+          <a:p>
+            <a:pPr algn="l" latinLnBrk="0">
+              <a:lnSpc>
+                <a:spcPct val="100000"/>
+              </a:lnSpc>
+              <a:spcBef>
+                <a:spcPts val="0"/>
+              </a:spcBef>
+              <a:spcAft>
+                <a:spcPts val="0"/>
+              </a:spcAft>
+            </a:pPr>
+            <a:r>
+              <a:rPr sz="900" b="0">
+                <a:solidFill>
+                  <a:srgbClr val="1B4D69"/>
+                </a:solidFill>
+                <a:latin typeface="Microsoft YaHei"/>
+                <a:ea typeface="Microsoft YaHei"/>
+                <a:cs typeface="Microsoft YaHei"/>
+              </a:rPr>
+              <a:t>负载 / 精度 / 预算</a:t>
+            </a:r>
+          </a:p>
+        </p:txBody>
+      </p:sp>
+      <p:cxnSp>
+        <p:nvCxnSpPr>
+          <p:cNvPr id="23" name="Connector 22"/>
+          <p:cNvCxnSpPr/>
+          <p:nvPr/>
+        </p:nvCxnSpPr>
+        <p:spPr>
+          <a:xfrm>
+            <a:off x="4050791" y="2633472"/>
+            <a:ext cx="146305" cy="0"/>
+          </a:xfrm>
+          <a:prstGeom prst="line">
+            <a:avLst/>
+          </a:prstGeom>
+          <a:ln w="19050">
+            <a:solidFill>
+              <a:srgbClr val="40708B"/>
+            </a:solidFill>
+            <a:tailEnd type="triangle" w="med" len="med"/>
+          </a:ln>
+        </p:spPr>
+      </p:cxnSp>
+      <p:sp>
+        <p:nvSpPr>
+          <p:cNvPr id="24" name="Rectangle 23"/>
           <p:cNvSpPr/>
           <p:nvPr/>
         </p:nvSpPr>
         <p:spPr>
           <a:xfrm>
-            <a:off x="548640" y="1335024"/>
-            <a:ext cx="11094415" cy="45720"/>
-          </a:xfrm>
-          <a:prstGeom prst="rect">
-            <a:avLst/>
-          </a:prstGeom>
-          <a:solidFill>
-            <a:srgbClr val="D2690C"/>
-          </a:solidFill>
-          <a:ln>
-            <a:noFill/>
-          </a:ln>
-        </p:spPr>
-        <p:txBody>
-          <a:bodyPr rtlCol="0" anchor="ctr"/>
-          <a:lstStyle/>
-          <a:p>
-            <a:pPr algn="ctr"/>
-          </a:p>
-        </p:txBody>
-      </p:sp>
-      <p:sp>
-        <p:nvSpPr>
-          <p:cNvPr id="8" name="TextBox 7"/>
-          <p:cNvSpPr txBox="1"/>
-          <p:nvPr/>
-        </p:nvSpPr>
-        <p:spPr>
-          <a:xfrm>
-            <a:off x="749808" y="1426464"/>
-            <a:ext cx="10692079" cy="292608"/>
-          </a:xfrm>
-          <a:prstGeom prst="rect">
-            <a:avLst/>
-          </a:prstGeom>
-          <a:noFill/>
-        </p:spPr>
-        <p:txBody>
-          <a:bodyPr wrap="square" anchor="ctr" lIns="0" tIns="0" rIns="0" bIns="0">
-            <a:noAutofit/>
-          </a:bodyPr>
-          <a:lstStyle/>
-          <a:p>
-            <a:pPr algn="l" latinLnBrk="0">
-              <a:lnSpc>
-                <a:spcPct val="100000"/>
-              </a:lnSpc>
-              <a:spcBef>
-                <a:spcPts val="0"/>
-              </a:spcBef>
-              <a:spcAft>
-                <a:spcPts val="0"/>
-              </a:spcAft>
-            </a:pPr>
-            <a:r>
-              <a:rPr sz="1100" b="1">
-                <a:solidFill>
-                  <a:srgbClr val="C2570A"/>
-                </a:solidFill>
-                <a:latin typeface="Consolas"/>
-                <a:ea typeface="Microsoft YaHei"/>
-                <a:cs typeface="Microsoft YaHei"/>
-              </a:rPr>
-              <a:t>model-agent</a:t>
-            </a:r>
-            <a:r>
-              <a:rPr sz="1100" b="0">
-                <a:solidFill>
-                  <a:srgbClr val="AFCEE1"/>
-                </a:solidFill>
-                <a:latin typeface="Microsoft YaHei"/>
-                <a:ea typeface="Microsoft YaHei"/>
-                <a:cs typeface="Microsoft YaHei"/>
-              </a:rPr>
-              <a:t>　｜　</a:t>
-            </a:r>
-            <a:r>
-              <a:rPr sz="1300" b="1">
-                <a:solidFill>
-                  <a:srgbClr val="0A2B45"/>
-                </a:solidFill>
-                <a:latin typeface="Microsoft YaHei"/>
-                <a:ea typeface="Microsoft YaHei"/>
-                <a:cs typeface="Microsoft YaHei"/>
-              </a:rPr>
-              <a:t>模型层</a:t>
-            </a:r>
-            <a:r>
-              <a:rPr sz="1050" b="0">
-                <a:solidFill>
-                  <a:srgbClr val="40708B"/>
-                </a:solidFill>
-                <a:latin typeface="Microsoft YaHei"/>
-                <a:ea typeface="Microsoft YaHei"/>
-                <a:cs typeface="Microsoft YaHei"/>
-              </a:rPr>
-              <a:t>　模型接入与性能调优</a:t>
-            </a:r>
-          </a:p>
-        </p:txBody>
-      </p:sp>
-      <p:sp>
-        <p:nvSpPr>
-          <p:cNvPr id="9" name="Rectangle 8"/>
-          <p:cNvSpPr/>
-          <p:nvPr/>
-        </p:nvSpPr>
-        <p:spPr>
-          <a:xfrm>
-            <a:off x="731520" y="2066543"/>
-            <a:ext cx="1463040" cy="987552"/>
-          </a:xfrm>
-          <a:prstGeom prst="rect">
-            <a:avLst/>
-          </a:prstGeom>
-          <a:solidFill>
-            <a:srgbClr val="F2F8FD"/>
-          </a:solidFill>
-          <a:ln w="9525">
-            <a:solidFill>
-              <a:srgbClr val="CFE3F0"/>
-            </a:solidFill>
-          </a:ln>
-        </p:spPr>
-        <p:txBody>
-          <a:bodyPr rtlCol="0" anchor="ctr"/>
-          <a:lstStyle/>
-          <a:p>
-            <a:pPr algn="ctr"/>
-          </a:p>
-        </p:txBody>
-      </p:sp>
-      <p:sp>
-        <p:nvSpPr>
-          <p:cNvPr id="10" name="TextBox 9"/>
-          <p:cNvSpPr txBox="1"/>
-          <p:nvPr/>
-        </p:nvSpPr>
-        <p:spPr>
-          <a:xfrm>
-            <a:off x="822960" y="2066543"/>
-            <a:ext cx="1280160" cy="987552"/>
-          </a:xfrm>
-          <a:prstGeom prst="rect">
-            <a:avLst/>
-          </a:prstGeom>
-          <a:noFill/>
-        </p:spPr>
-        <p:txBody>
-          <a:bodyPr wrap="square" anchor="ctr" lIns="0" tIns="0" rIns="0" bIns="0">
-            <a:noAutofit/>
-          </a:bodyPr>
-          <a:lstStyle/>
-          <a:p>
-            <a:pPr algn="ctr" latinLnBrk="0">
-              <a:lnSpc>
-                <a:spcPct val="100000"/>
-              </a:lnSpc>
-              <a:spcBef>
-                <a:spcPts val="0"/>
-              </a:spcBef>
-              <a:spcAft>
-                <a:spcPts val="200"/>
-              </a:spcAft>
-            </a:pPr>
-            <a:r>
-              <a:rPr sz="1300" b="1">
-                <a:solidFill>
-                  <a:srgbClr val="0A2B45"/>
-                </a:solidFill>
-                <a:latin typeface="Microsoft YaHei"/>
-                <a:ea typeface="Microsoft YaHei"/>
-                <a:cs typeface="Microsoft YaHei"/>
-              </a:rPr>
-              <a:t>人</a:t>
-            </a:r>
-          </a:p>
-          <a:p>
-            <a:pPr algn="ctr" latinLnBrk="0">
-              <a:lnSpc>
-                <a:spcPct val="100000"/>
-              </a:lnSpc>
-              <a:spcBef>
-                <a:spcPts val="0"/>
-              </a:spcBef>
-              <a:spcAft>
-                <a:spcPts val="0"/>
-              </a:spcAft>
-            </a:pPr>
-            <a:r>
-              <a:rPr sz="950" b="0">
-                <a:solidFill>
-                  <a:srgbClr val="40708B"/>
-                </a:solidFill>
-                <a:latin typeface="Microsoft YaHei"/>
-                <a:ea typeface="Microsoft YaHei"/>
-                <a:cs typeface="Microsoft YaHei"/>
-              </a:rPr>
-              <a:t>定目标与边界</a:t>
-            </a:r>
-          </a:p>
-        </p:txBody>
-      </p:sp>
-      <p:sp>
-        <p:nvSpPr>
-          <p:cNvPr id="11" name="Rectangle 10"/>
-          <p:cNvSpPr/>
-          <p:nvPr/>
-        </p:nvSpPr>
-        <p:spPr>
-          <a:xfrm>
-            <a:off x="2560320" y="2066543"/>
-            <a:ext cx="3200400" cy="987552"/>
+            <a:off x="4242816" y="2103120"/>
+            <a:ext cx="2670048" cy="1060704"/>
           </a:xfrm>
           <a:prstGeom prst="rect">
             <a:avLst/>
@@ -13333,14 +13898,14 @@
       </p:sp>
       <p:sp>
         <p:nvSpPr>
-          <p:cNvPr id="12" name="Rectangle 11"/>
+          <p:cNvPr id="25" name="Rectangle 24"/>
           <p:cNvSpPr/>
           <p:nvPr/>
         </p:nvSpPr>
         <p:spPr>
           <a:xfrm>
-            <a:off x="2560320" y="2066543"/>
-            <a:ext cx="64008" cy="987552"/>
+            <a:off x="4242816" y="2103120"/>
+            <a:ext cx="64008" cy="1060704"/>
           </a:xfrm>
           <a:prstGeom prst="rect">
             <a:avLst/>
@@ -13362,14 +13927,14 @@
       </p:sp>
       <p:sp>
         <p:nvSpPr>
-          <p:cNvPr id="13" name="TextBox 12"/>
-          <p:cNvSpPr txBox="1"/>
-          <p:nvPr/>
-        </p:nvSpPr>
-        <p:spPr>
-          <a:xfrm>
-            <a:off x="2779776" y="2103120"/>
-            <a:ext cx="2834640" cy="914400"/>
+          <p:cNvPr id="26" name="TextBox 25"/>
+          <p:cNvSpPr txBox="1"/>
+          <p:nvPr/>
+        </p:nvSpPr>
+        <p:spPr>
+          <a:xfrm>
+            <a:off x="4462272" y="2157984"/>
+            <a:ext cx="2304288" cy="950976"/>
           </a:xfrm>
           <a:prstGeom prst="rect">
             <a:avLst/>
@@ -13390,11 +13955,11 @@
                 <a:spcPts val="0"/>
               </a:spcBef>
               <a:spcAft>
-                <a:spcPts val="300"/>
-              </a:spcAft>
-            </a:pPr>
-            <a:r>
-              <a:rPr sz="1300" b="1">
+                <a:spcPts val="400"/>
+              </a:spcAft>
+            </a:pPr>
+            <a:r>
+              <a:rPr sz="1100" b="1">
                 <a:solidFill>
                   <a:srgbClr val="0A2B45"/>
                 </a:solidFill>
@@ -13405,18 +13970,64 @@
               <a:t>Agent 生成接入、优化方案</a:t>
             </a:r>
           </a:p>
-        </p:txBody>
-      </p:sp>
-      <p:sp>
-        <p:nvSpPr>
-          <p:cNvPr id="14" name="Rectangle 13"/>
+          <a:p>
+            <a:pPr algn="l" latinLnBrk="0">
+              <a:lnSpc>
+                <a:spcPct val="100000"/>
+              </a:lnSpc>
+              <a:spcBef>
+                <a:spcPts val="0"/>
+              </a:spcBef>
+              <a:spcAft>
+                <a:spcPts val="0"/>
+              </a:spcAft>
+            </a:pPr>
+            <a:r>
+              <a:rPr sz="900" b="0">
+                <a:solidFill>
+                  <a:srgbClr val="1B4D69"/>
+                </a:solidFill>
+                <a:latin typeface="Microsoft YaHei"/>
+                <a:ea typeface="Microsoft YaHei"/>
+                <a:cs typeface="Microsoft YaHei"/>
+              </a:rPr>
+              <a:t>服务配置与图融合补丁</a:t>
+            </a:r>
+          </a:p>
+        </p:txBody>
+      </p:sp>
+      <p:cxnSp>
+        <p:nvCxnSpPr>
+          <p:cNvPr id="27" name="Connector 26"/>
+          <p:cNvCxnSpPr/>
+          <p:nvPr/>
+        </p:nvCxnSpPr>
+        <p:spPr>
+          <a:xfrm>
+            <a:off x="6958583" y="2633472"/>
+            <a:ext cx="146305" cy="0"/>
+          </a:xfrm>
+          <a:prstGeom prst="line">
+            <a:avLst/>
+          </a:prstGeom>
+          <a:ln w="19050">
+            <a:solidFill>
+              <a:srgbClr val="40708B"/>
+            </a:solidFill>
+            <a:tailEnd type="triangle" w="med" len="med"/>
+          </a:ln>
+        </p:spPr>
+      </p:cxnSp>
+      <p:sp>
+        <p:nvSpPr>
+          <p:cNvPr id="28" name="Rectangle 27"/>
           <p:cNvSpPr/>
           <p:nvPr/>
         </p:nvSpPr>
         <p:spPr>
           <a:xfrm>
-            <a:off x="6217920" y="2066543"/>
-            <a:ext cx="3749039" cy="987552"/>
+            <a:off x="7150608" y="2103120"/>
+            <a:ext cx="2852928" cy="1060704"/>
           </a:xfrm>
           <a:prstGeom prst="rect">
             <a:avLst/>
@@ -13440,14 +14051,14 @@
       </p:sp>
       <p:sp>
         <p:nvSpPr>
-          <p:cNvPr id="15" name="Rectangle 14"/>
+          <p:cNvPr id="29" name="Rectangle 28"/>
           <p:cNvSpPr/>
           <p:nvPr/>
         </p:nvSpPr>
         <p:spPr>
           <a:xfrm>
-            <a:off x="6217920" y="2066543"/>
-            <a:ext cx="64008" cy="987552"/>
+            <a:off x="7150608" y="2103120"/>
+            <a:ext cx="64008" cy="1060704"/>
           </a:xfrm>
           <a:prstGeom prst="rect">
             <a:avLst/>
@@ -13469,14 +14080,14 @@
       </p:sp>
       <p:sp>
         <p:nvSpPr>
-          <p:cNvPr id="16" name="TextBox 15"/>
-          <p:cNvSpPr txBox="1"/>
-          <p:nvPr/>
-        </p:nvSpPr>
-        <p:spPr>
-          <a:xfrm>
-            <a:off x="6437376" y="2103120"/>
-            <a:ext cx="3383279" cy="914400"/>
+          <p:cNvPr id="30" name="TextBox 29"/>
+          <p:cNvSpPr txBox="1"/>
+          <p:nvPr/>
+        </p:nvSpPr>
+        <p:spPr>
+          <a:xfrm>
+            <a:off x="7370064" y="2157984"/>
+            <a:ext cx="2487168" cy="950976"/>
           </a:xfrm>
           <a:prstGeom prst="rect">
             <a:avLst/>
@@ -13497,11 +14108,11 @@
                 <a:spcPts val="0"/>
               </a:spcBef>
               <a:spcAft>
-                <a:spcPts val="300"/>
-              </a:spcAft>
-            </a:pPr>
-            <a:r>
-              <a:rPr sz="1300" b="1">
+                <a:spcPts val="400"/>
+              </a:spcAft>
+            </a:pPr>
+            <a:r>
+              <a:rPr sz="1100" b="1">
                 <a:solidFill>
                   <a:srgbClr val="0A2B45"/>
                 </a:solidFill>
@@ -13509,7 +14120,7 @@
                 <a:ea typeface="Microsoft YaHei"/>
                 <a:cs typeface="Microsoft YaHei"/>
               </a:rPr>
-              <a:t>规则验收 + 真机实测</a:t>
+              <a:t>整模型真机端到端验收</a:t>
             </a:r>
           </a:p>
           <a:p>
@@ -13525,7 +14136,7 @@
               </a:spcAft>
             </a:pPr>
             <a:r>
-              <a:rPr sz="1000" b="0">
+              <a:rPr sz="900" b="0">
                 <a:solidFill>
                   <a:srgbClr val="1B4D69"/>
                 </a:solidFill>
@@ -13533,147 +14144,21 @@
                 <a:ea typeface="Microsoft YaHei"/>
                 <a:cs typeface="Microsoft YaHei"/>
               </a:rPr>
-              <a:t>整模型端到端</a:t>
-            </a:r>
-          </a:p>
-          <a:p>
-            <a:pPr algn="l" latinLnBrk="0">
-              <a:lnSpc>
-                <a:spcPct val="100000"/>
-              </a:lnSpc>
-              <a:spcBef>
-                <a:spcPts val="0"/>
-              </a:spcBef>
-              <a:spcAft>
-                <a:spcPts val="0"/>
-              </a:spcAft>
-            </a:pPr>
-            <a:r>
-              <a:rPr sz="1000" b="0">
-                <a:solidFill>
-                  <a:srgbClr val="1B4D69"/>
-                </a:solidFill>
-                <a:latin typeface="Microsoft YaHei"/>
-                <a:ea typeface="Microsoft YaHei"/>
-                <a:cs typeface="Microsoft YaHei"/>
-              </a:rPr>
-              <a:t>真实服务 + 固定评测集</a:t>
-            </a:r>
-          </a:p>
-        </p:txBody>
-      </p:sp>
-      <p:sp>
-        <p:nvSpPr>
-          <p:cNvPr id="17" name="Rectangle 16"/>
-          <p:cNvSpPr/>
-          <p:nvPr/>
-        </p:nvSpPr>
-        <p:spPr>
-          <a:xfrm>
-            <a:off x="10332720" y="2066543"/>
-            <a:ext cx="1188720" cy="987552"/>
-          </a:xfrm>
-          <a:prstGeom prst="rect">
-            <a:avLst/>
-          </a:prstGeom>
-          <a:solidFill>
-            <a:srgbClr val="F2F8FD"/>
-          </a:solidFill>
-          <a:ln w="9525">
-            <a:solidFill>
-              <a:srgbClr val="CFE3F0"/>
-            </a:solidFill>
-          </a:ln>
-        </p:spPr>
-        <p:txBody>
-          <a:bodyPr rtlCol="0" anchor="ctr"/>
-          <a:lstStyle/>
-          <a:p>
-            <a:pPr algn="ctr"/>
-          </a:p>
-        </p:txBody>
-      </p:sp>
-      <p:sp>
-        <p:nvSpPr>
-          <p:cNvPr id="18" name="TextBox 17"/>
-          <p:cNvSpPr txBox="1"/>
-          <p:nvPr/>
-        </p:nvSpPr>
-        <p:spPr>
-          <a:xfrm>
-            <a:off x="10424160" y="2066543"/>
-            <a:ext cx="1005840" cy="987552"/>
-          </a:xfrm>
-          <a:prstGeom prst="rect">
-            <a:avLst/>
-          </a:prstGeom>
-          <a:noFill/>
-        </p:spPr>
-        <p:txBody>
-          <a:bodyPr wrap="square" anchor="ctr" lIns="0" tIns="0" rIns="0" bIns="0">
-            <a:noAutofit/>
-          </a:bodyPr>
-          <a:lstStyle/>
-          <a:p>
-            <a:pPr algn="ctr" latinLnBrk="0">
-              <a:lnSpc>
-                <a:spcPct val="100000"/>
-              </a:lnSpc>
-              <a:spcBef>
-                <a:spcPts val="0"/>
-              </a:spcBef>
-              <a:spcAft>
-                <a:spcPts val="200"/>
-              </a:spcAft>
-            </a:pPr>
-            <a:r>
-              <a:rPr sz="1300" b="1">
-                <a:solidFill>
-                  <a:srgbClr val="0A2B45"/>
-                </a:solidFill>
-                <a:latin typeface="Microsoft YaHei"/>
-                <a:ea typeface="Microsoft YaHei"/>
-                <a:cs typeface="Microsoft YaHei"/>
-              </a:rPr>
-              <a:t>人</a:t>
-            </a:r>
-          </a:p>
-          <a:p>
-            <a:pPr algn="ctr" latinLnBrk="0">
-              <a:lnSpc>
-                <a:spcPct val="100000"/>
-              </a:lnSpc>
-              <a:spcBef>
-                <a:spcPts val="0"/>
-              </a:spcBef>
-              <a:spcAft>
-                <a:spcPts val="0"/>
-              </a:spcAft>
-            </a:pPr>
-            <a:r>
-              <a:rPr sz="950" b="0">
-                <a:solidFill>
-                  <a:srgbClr val="40708B"/>
-                </a:solidFill>
-                <a:latin typeface="Microsoft YaHei"/>
-                <a:ea typeface="Microsoft YaHei"/>
-                <a:cs typeface="Microsoft YaHei"/>
-              </a:rPr>
-              <a:t>判断交付</a:t>
+              <a:t>输出对齐 · 质量不降 · 吞吐提升</a:t>
             </a:r>
           </a:p>
         </p:txBody>
       </p:sp>
       <p:cxnSp>
         <p:nvCxnSpPr>
-          <p:cNvPr id="19" name="Connector 18"/>
+          <p:cNvPr id="31" name="Connector 30"/>
           <p:cNvCxnSpPr/>
           <p:nvPr/>
         </p:nvCxnSpPr>
         <p:spPr>
           <a:xfrm>
-            <a:off x="2249424" y="2560320"/>
-            <a:ext cx="256032" cy="0"/>
+            <a:off x="10049256" y="2633472"/>
+            <a:ext cx="146303" cy="0"/>
           </a:xfrm>
           <a:prstGeom prst="line">
             <a:avLst/>
@@ -13686,175 +14171,16 @@
           </a:ln>
         </p:spPr>
       </p:cxnSp>
-      <p:cxnSp>
-        <p:nvCxnSpPr>
-          <p:cNvPr id="20" name="Connector 19"/>
-          <p:cNvCxnSpPr/>
-          <p:nvPr/>
-        </p:nvCxnSpPr>
-        <p:spPr>
-          <a:xfrm>
-            <a:off x="5815583" y="2560320"/>
-            <a:ext cx="347473" cy="0"/>
-          </a:xfrm>
-          <a:prstGeom prst="line">
-            <a:avLst/>
-          </a:prstGeom>
-          <a:ln w="19050">
-            <a:solidFill>
-              <a:srgbClr val="40708B"/>
-            </a:solidFill>
-            <a:tailEnd type="triangle" w="med" len="med"/>
-          </a:ln>
-        </p:spPr>
-      </p:cxnSp>
-      <p:cxnSp>
-        <p:nvCxnSpPr>
-          <p:cNvPr id="21" name="Connector 20"/>
-          <p:cNvCxnSpPr/>
-          <p:nvPr/>
-        </p:nvCxnSpPr>
-        <p:spPr>
-          <a:xfrm>
-            <a:off x="10021824" y="2560320"/>
-            <a:ext cx="256032" cy="0"/>
-          </a:xfrm>
-          <a:prstGeom prst="line">
-            <a:avLst/>
-          </a:prstGeom>
-          <a:ln w="19050">
-            <a:solidFill>
-              <a:srgbClr val="40708B"/>
-            </a:solidFill>
-            <a:tailEnd type="triangle" w="med" len="med"/>
-          </a:ln>
-        </p:spPr>
-      </p:cxnSp>
-      <p:sp>
-        <p:nvSpPr>
-          <p:cNvPr id="22" name="Freeform 21"/>
+      <p:sp>
+        <p:nvSpPr>
+          <p:cNvPr id="32" name="Rectangle 31"/>
           <p:cNvSpPr/>
           <p:nvPr/>
         </p:nvSpPr>
         <p:spPr>
           <a:xfrm>
-            <a:off x="4160520" y="1901952"/>
-            <a:ext cx="3931920" cy="164591"/>
-          </a:xfrm>
-          <a:custGeom>
-            <a:avLst/>
-            <a:gdLst/>
-            <a:ahLst/>
-            <a:cxnLst/>
-            <a:rect l="l" t="t" r="r" b="b"/>
-            <a:pathLst>
-              <a:path w="3931920" h="164591">
-                <a:moveTo>
-                  <a:pt x="3931920" y="164591"/>
-                </a:moveTo>
-                <a:lnTo>
-                  <a:pt x="3931920" y="0"/>
-                </a:lnTo>
-                <a:lnTo>
-                  <a:pt x="0" y="0"/>
-                </a:lnTo>
-              </a:path>
-            </a:pathLst>
-          </a:custGeom>
-          <a:noFill/>
-          <a:ln w="15875">
-            <a:solidFill>
-              <a:srgbClr val="D2690C"/>
-            </a:solidFill>
-          </a:ln>
-        </p:spPr>
-        <p:txBody>
-          <a:bodyPr rtlCol="0" anchor="ctr"/>
-          <a:lstStyle/>
-          <a:p>
-            <a:pPr algn="ctr"/>
-          </a:p>
-        </p:txBody>
-      </p:sp>
-      <p:cxnSp>
-        <p:nvCxnSpPr>
-          <p:cNvPr id="23" name="Connector 22"/>
-          <p:cNvCxnSpPr/>
-          <p:nvPr/>
-        </p:nvCxnSpPr>
-        <p:spPr>
-          <a:xfrm>
-            <a:off x="4160520" y="1901952"/>
-            <a:ext cx="0" cy="146303"/>
-          </a:xfrm>
-          <a:prstGeom prst="line">
-            <a:avLst/>
-          </a:prstGeom>
-          <a:ln w="15875">
-            <a:solidFill>
-              <a:srgbClr val="D2690C"/>
-            </a:solidFill>
-            <a:tailEnd type="triangle" w="med" len="med"/>
-          </a:ln>
-        </p:spPr>
-      </p:cxnSp>
-      <p:sp>
-        <p:nvSpPr>
-          <p:cNvPr id="24" name="TextBox 23"/>
-          <p:cNvSpPr txBox="1"/>
-          <p:nvPr/>
-        </p:nvSpPr>
-        <p:spPr>
-          <a:xfrm>
-            <a:off x="4754879" y="1609344"/>
-            <a:ext cx="2743200" cy="256032"/>
-          </a:xfrm>
-          <a:prstGeom prst="rect">
-            <a:avLst/>
-          </a:prstGeom>
-          <a:noFill/>
-        </p:spPr>
-        <p:txBody>
-          <a:bodyPr wrap="square" anchor="ctr" lIns="0" tIns="0" rIns="0" bIns="0">
-            <a:noAutofit/>
-          </a:bodyPr>
-          <a:lstStyle/>
-          <a:p>
-            <a:pPr algn="ctr" latinLnBrk="0">
-              <a:lnSpc>
-                <a:spcPct val="100000"/>
-              </a:lnSpc>
-              <a:spcBef>
-                <a:spcPts val="0"/>
-              </a:spcBef>
-              <a:spcAft>
-                <a:spcPts val="0"/>
-              </a:spcAft>
-            </a:pPr>
-            <a:r>
-              <a:rPr sz="950" b="0">
-                <a:solidFill>
-                  <a:srgbClr val="C2570A"/>
-                </a:solidFill>
-                <a:latin typeface="Microsoft YaHei"/>
-                <a:ea typeface="Microsoft YaHei"/>
-                <a:cs typeface="Microsoft YaHei"/>
-              </a:rPr>
-              <a:t>不过即回退，带着原因退回</a:t>
-            </a:r>
-          </a:p>
-        </p:txBody>
-      </p:sp>
-      <p:sp>
-        <p:nvSpPr>
-          <p:cNvPr id="25" name="Rectangle 24"/>
-          <p:cNvSpPr/>
-          <p:nvPr/>
-        </p:nvSpPr>
-        <p:spPr>
-          <a:xfrm>
-            <a:off x="548640" y="3895344"/>
-            <a:ext cx="11094415" cy="2011680"/>
+            <a:off x="10241280" y="2103120"/>
+            <a:ext cx="1389888" cy="1060704"/>
           </a:xfrm>
           <a:prstGeom prst="rect">
             <a:avLst/>
@@ -13878,14 +14204,229 @@
       </p:sp>
       <p:sp>
         <p:nvSpPr>
-          <p:cNvPr id="26" name="Rectangle 25"/>
+          <p:cNvPr id="33" name="TextBox 32"/>
+          <p:cNvSpPr txBox="1"/>
+          <p:nvPr/>
+        </p:nvSpPr>
+        <p:spPr>
+          <a:xfrm>
+            <a:off x="10387584" y="2157984"/>
+            <a:ext cx="1024128" cy="950976"/>
+          </a:xfrm>
+          <a:prstGeom prst="rect">
+            <a:avLst/>
+          </a:prstGeom>
+          <a:noFill/>
+        </p:spPr>
+        <p:txBody>
+          <a:bodyPr wrap="square" anchor="ctr" lIns="0" tIns="0" rIns="0" bIns="0">
+            <a:noAutofit/>
+          </a:bodyPr>
+          <a:lstStyle/>
+          <a:p>
+            <a:pPr algn="l" latinLnBrk="0">
+              <a:lnSpc>
+                <a:spcPct val="100000"/>
+              </a:lnSpc>
+              <a:spcBef>
+                <a:spcPts val="0"/>
+              </a:spcBef>
+              <a:spcAft>
+                <a:spcPts val="400"/>
+              </a:spcAft>
+            </a:pPr>
+            <a:r>
+              <a:rPr sz="1100" b="1">
+                <a:solidFill>
+                  <a:srgbClr val="0A2B45"/>
+                </a:solidFill>
+                <a:latin typeface="Microsoft YaHei"/>
+                <a:ea typeface="Microsoft YaHei"/>
+                <a:cs typeface="Microsoft YaHei"/>
+              </a:rPr>
+              <a:t>人</a:t>
+            </a:r>
+          </a:p>
+          <a:p>
+            <a:pPr algn="l" latinLnBrk="0">
+              <a:lnSpc>
+                <a:spcPct val="100000"/>
+              </a:lnSpc>
+              <a:spcBef>
+                <a:spcPts val="0"/>
+              </a:spcBef>
+              <a:spcAft>
+                <a:spcPts val="0"/>
+              </a:spcAft>
+            </a:pPr>
+            <a:r>
+              <a:rPr sz="900" b="0">
+                <a:solidFill>
+                  <a:srgbClr val="1B4D69"/>
+                </a:solidFill>
+                <a:latin typeface="Microsoft YaHei"/>
+                <a:ea typeface="Microsoft YaHei"/>
+                <a:cs typeface="Microsoft YaHei"/>
+              </a:rPr>
+              <a:t>判断交付</a:t>
+            </a:r>
+          </a:p>
+        </p:txBody>
+      </p:sp>
+      <p:sp>
+        <p:nvSpPr>
+          <p:cNvPr id="34" name="Freeform 33"/>
           <p:cNvSpPr/>
           <p:nvPr/>
         </p:nvSpPr>
         <p:spPr>
           <a:xfrm>
-            <a:off x="548640" y="3895344"/>
-            <a:ext cx="11094415" cy="45720"/>
+            <a:off x="5577840" y="2011680"/>
+            <a:ext cx="2999232" cy="91440"/>
+          </a:xfrm>
+          <a:custGeom>
+            <a:avLst/>
+            <a:gdLst/>
+            <a:ahLst/>
+            <a:cxnLst/>
+            <a:rect l="l" t="t" r="r" b="b"/>
+            <a:pathLst>
+              <a:path w="2999232" h="91440">
+                <a:moveTo>
+                  <a:pt x="2999232" y="91440"/>
+                </a:moveTo>
+                <a:lnTo>
+                  <a:pt x="2999232" y="0"/>
+                </a:lnTo>
+                <a:lnTo>
+                  <a:pt x="0" y="0"/>
+                </a:lnTo>
+              </a:path>
+            </a:pathLst>
+          </a:custGeom>
+          <a:noFill/>
+          <a:ln w="15875">
+            <a:solidFill>
+              <a:srgbClr val="D2690C"/>
+            </a:solidFill>
+          </a:ln>
+        </p:spPr>
+        <p:txBody>
+          <a:bodyPr rtlCol="0" anchor="ctr"/>
+          <a:lstStyle/>
+          <a:p>
+            <a:pPr algn="ctr"/>
+          </a:p>
+        </p:txBody>
+      </p:sp>
+      <p:cxnSp>
+        <p:nvCxnSpPr>
+          <p:cNvPr id="35" name="Connector 34"/>
+          <p:cNvCxnSpPr/>
+          <p:nvPr/>
+        </p:nvCxnSpPr>
+        <p:spPr>
+          <a:xfrm>
+            <a:off x="5577840" y="2011680"/>
+            <a:ext cx="0" cy="73151"/>
+          </a:xfrm>
+          <a:prstGeom prst="line">
+            <a:avLst/>
+          </a:prstGeom>
+          <a:ln w="15875">
+            <a:solidFill>
+              <a:srgbClr val="D2690C"/>
+            </a:solidFill>
+            <a:tailEnd type="triangle" w="med" len="med"/>
+          </a:ln>
+        </p:spPr>
+      </p:cxnSp>
+      <p:sp>
+        <p:nvSpPr>
+          <p:cNvPr id="36" name="TextBox 35"/>
+          <p:cNvSpPr txBox="1"/>
+          <p:nvPr/>
+        </p:nvSpPr>
+        <p:spPr>
+          <a:xfrm>
+            <a:off x="5614416" y="1783080"/>
+            <a:ext cx="2926080" cy="219456"/>
+          </a:xfrm>
+          <a:prstGeom prst="rect">
+            <a:avLst/>
+          </a:prstGeom>
+          <a:noFill/>
+        </p:spPr>
+        <p:txBody>
+          <a:bodyPr wrap="square" anchor="ctr" lIns="0" tIns="0" rIns="0" bIns="0">
+            <a:noAutofit/>
+          </a:bodyPr>
+          <a:lstStyle/>
+          <a:p>
+            <a:pPr algn="ctr" latinLnBrk="0">
+              <a:lnSpc>
+                <a:spcPct val="100000"/>
+              </a:lnSpc>
+              <a:spcBef>
+                <a:spcPts val="0"/>
+              </a:spcBef>
+              <a:spcAft>
+                <a:spcPts val="0"/>
+              </a:spcAft>
+            </a:pPr>
+            <a:r>
+              <a:rPr sz="950" b="0">
+                <a:solidFill>
+                  <a:srgbClr val="C2570A"/>
+                </a:solidFill>
+                <a:latin typeface="Microsoft YaHei"/>
+                <a:ea typeface="Microsoft YaHei"/>
+                <a:cs typeface="Microsoft YaHei"/>
+              </a:rPr>
+              <a:t>✕　不过即回退，带着原因退回</a:t>
+            </a:r>
+          </a:p>
+        </p:txBody>
+      </p:sp>
+      <p:sp>
+        <p:nvSpPr>
+          <p:cNvPr id="37" name="Rectangle 36"/>
+          <p:cNvSpPr/>
+          <p:nvPr/>
+        </p:nvSpPr>
+        <p:spPr>
+          <a:xfrm>
+            <a:off x="548640" y="4114800"/>
+            <a:ext cx="11094415" cy="1481328"/>
+          </a:xfrm>
+          <a:prstGeom prst="rect">
+            <a:avLst/>
+          </a:prstGeom>
+          <a:solidFill>
+            <a:srgbClr val="F2F8FD"/>
+          </a:solidFill>
+          <a:ln>
+            <a:noFill/>
+          </a:ln>
+        </p:spPr>
+        <p:txBody>
+          <a:bodyPr rtlCol="0" anchor="ctr"/>
+          <a:lstStyle/>
+          <a:p>
+            <a:pPr algn="ctr"/>
+          </a:p>
+        </p:txBody>
+      </p:sp>
+      <p:sp>
+        <p:nvSpPr>
+          <p:cNvPr id="38" name="Rectangle 37"/>
+          <p:cNvSpPr/>
+          <p:nvPr/>
+        </p:nvSpPr>
+        <p:spPr>
+          <a:xfrm>
+            <a:off x="548640" y="4114800"/>
+            <a:ext cx="64008" cy="1481328"/>
           </a:xfrm>
           <a:prstGeom prst="rect">
             <a:avLst/>
@@ -13907,22 +14448,22 @@
       </p:sp>
       <p:sp>
         <p:nvSpPr>
-          <p:cNvPr id="27" name="TextBox 26"/>
-          <p:cNvSpPr txBox="1"/>
-          <p:nvPr/>
-        </p:nvSpPr>
-        <p:spPr>
-          <a:xfrm>
-            <a:off x="749808" y="3986783"/>
-            <a:ext cx="10692079" cy="292608"/>
-          </a:xfrm>
-          <a:prstGeom prst="rect">
-            <a:avLst/>
-          </a:prstGeom>
-          <a:noFill/>
-        </p:spPr>
-        <p:txBody>
-          <a:bodyPr wrap="square" anchor="ctr" lIns="0" tIns="0" rIns="0" bIns="0">
+          <p:cNvPr id="39" name="TextBox 38"/>
+          <p:cNvSpPr txBox="1"/>
+          <p:nvPr/>
+        </p:nvSpPr>
+        <p:spPr>
+          <a:xfrm>
+            <a:off x="749808" y="4389120"/>
+            <a:ext cx="1225295" cy="932688"/>
+          </a:xfrm>
+          <a:prstGeom prst="rect">
+            <a:avLst/>
+          </a:prstGeom>
+          <a:noFill/>
+        </p:spPr>
+        <p:txBody>
+          <a:bodyPr wrap="square" anchor="t" lIns="0" tIns="0" rIns="0" bIns="0">
             <a:noAutofit/>
           </a:bodyPr>
           <a:lstStyle/>
@@ -13935,11 +14476,35 @@
                 <a:spcPts val="0"/>
               </a:spcBef>
               <a:spcAft>
-                <a:spcPts val="0"/>
-              </a:spcAft>
-            </a:pPr>
-            <a:r>
-              <a:rPr sz="1100" b="1">
+                <a:spcPts val="300"/>
+              </a:spcAft>
+            </a:pPr>
+            <a:r>
+              <a:rPr sz="1300" b="1">
+                <a:solidFill>
+                  <a:srgbClr val="0A2B45"/>
+                </a:solidFill>
+                <a:latin typeface="Microsoft YaHei"/>
+                <a:ea typeface="Microsoft YaHei"/>
+                <a:cs typeface="Microsoft YaHei"/>
+              </a:rPr>
+              <a:t>【算子层】</a:t>
+            </a:r>
+          </a:p>
+          <a:p>
+            <a:pPr algn="l" latinLnBrk="0">
+              <a:lnSpc>
+                <a:spcPct val="100000"/>
+              </a:lnSpc>
+              <a:spcBef>
+                <a:spcPts val="0"/>
+              </a:spcBef>
+              <a:spcAft>
+                <a:spcPts val="400"/>
+              </a:spcAft>
+            </a:pPr>
+            <a:r>
+              <a:rPr sz="1000" b="1">
                 <a:solidFill>
                   <a:srgbClr val="C2570A"/>
                 </a:solidFill>
@@ -13949,30 +14514,21 @@
               </a:rPr>
               <a:t>xpugen</a:t>
             </a:r>
-            <a:r>
-              <a:rPr sz="1100" b="0">
-                <a:solidFill>
-                  <a:srgbClr val="AFCEE1"/>
-                </a:solidFill>
-                <a:latin typeface="Microsoft YaHei"/>
-                <a:ea typeface="Microsoft YaHei"/>
-                <a:cs typeface="Microsoft YaHei"/>
-              </a:rPr>
-              <a:t>　｜　</a:t>
-            </a:r>
-            <a:r>
-              <a:rPr sz="1300" b="1">
-                <a:solidFill>
-                  <a:srgbClr val="0A2B45"/>
-                </a:solidFill>
-                <a:latin typeface="Microsoft YaHei"/>
-                <a:ea typeface="Microsoft YaHei"/>
-                <a:cs typeface="Microsoft YaHei"/>
-              </a:rPr>
-              <a:t>算子层</a:t>
-            </a:r>
-            <a:r>
-              <a:rPr sz="1050" b="0">
+          </a:p>
+          <a:p>
+            <a:pPr algn="l" latinLnBrk="0">
+              <a:lnSpc>
+                <a:spcPct val="100000"/>
+              </a:lnSpc>
+              <a:spcBef>
+                <a:spcPts val="0"/>
+              </a:spcBef>
+              <a:spcAft>
+                <a:spcPts val="0"/>
+              </a:spcAft>
+            </a:pPr>
+            <a:r>
+              <a:rPr sz="800" b="0">
                 <a:solidFill>
                   <a:srgbClr val="40708B"/>
                 </a:solidFill>
@@ -13980,123 +14536,21 @@
                 <a:ea typeface="Microsoft YaHei"/>
                 <a:cs typeface="Microsoft YaHei"/>
               </a:rPr>
-              <a:t>　面向 M100 自动生成算子实现并调优，提升aten算子的覆盖泛化</a:t>
-            </a:r>
-          </a:p>
-        </p:txBody>
-      </p:sp>
-      <p:sp>
-        <p:nvSpPr>
-          <p:cNvPr id="28" name="Rectangle 27"/>
+              <a:t>面向 M100 自动生成算子实现并调优，提升aten算子的覆盖泛化</a:t>
+            </a:r>
+          </a:p>
+        </p:txBody>
+      </p:sp>
+      <p:sp>
+        <p:nvSpPr>
+          <p:cNvPr id="40" name="Rectangle 39"/>
           <p:cNvSpPr/>
           <p:nvPr/>
         </p:nvSpPr>
         <p:spPr>
           <a:xfrm>
-            <a:off x="731520" y="4626864"/>
-            <a:ext cx="1463040" cy="987552"/>
-          </a:xfrm>
-          <a:prstGeom prst="rect">
-            <a:avLst/>
-          </a:prstGeom>
-          <a:solidFill>
-            <a:srgbClr val="F2F8FD"/>
-          </a:solidFill>
-          <a:ln w="9525">
-            <a:solidFill>
-              <a:srgbClr val="CFE3F0"/>
-            </a:solidFill>
-          </a:ln>
-        </p:spPr>
-        <p:txBody>
-          <a:bodyPr rtlCol="0" anchor="ctr"/>
-          <a:lstStyle/>
-          <a:p>
-            <a:pPr algn="ctr"/>
-          </a:p>
-        </p:txBody>
-      </p:sp>
-      <p:sp>
-        <p:nvSpPr>
-          <p:cNvPr id="29" name="TextBox 28"/>
-          <p:cNvSpPr txBox="1"/>
-          <p:nvPr/>
-        </p:nvSpPr>
-        <p:spPr>
-          <a:xfrm>
-            <a:off x="822960" y="4626864"/>
-            <a:ext cx="1280160" cy="987552"/>
-          </a:xfrm>
-          <a:prstGeom prst="rect">
-            <a:avLst/>
-          </a:prstGeom>
-          <a:noFill/>
-        </p:spPr>
-        <p:txBody>
-          <a:bodyPr wrap="square" anchor="ctr" lIns="0" tIns="0" rIns="0" bIns="0">
-            <a:noAutofit/>
-          </a:bodyPr>
-          <a:lstStyle/>
-          <a:p>
-            <a:pPr algn="ctr" latinLnBrk="0">
-              <a:lnSpc>
-                <a:spcPct val="100000"/>
-              </a:lnSpc>
-              <a:spcBef>
-                <a:spcPts val="0"/>
-              </a:spcBef>
-              <a:spcAft>
-                <a:spcPts val="200"/>
-              </a:spcAft>
-            </a:pPr>
-            <a:r>
-              <a:rPr sz="1300" b="1">
-                <a:solidFill>
-                  <a:srgbClr val="0A2B45"/>
-                </a:solidFill>
-                <a:latin typeface="Microsoft YaHei"/>
-                <a:ea typeface="Microsoft YaHei"/>
-                <a:cs typeface="Microsoft YaHei"/>
-              </a:rPr>
-              <a:t>需求</a:t>
-            </a:r>
-          </a:p>
-          <a:p>
-            <a:pPr algn="ctr" latinLnBrk="0">
-              <a:lnSpc>
-                <a:spcPct val="100000"/>
-              </a:lnSpc>
-              <a:spcBef>
-                <a:spcPts val="0"/>
-              </a:spcBef>
-              <a:spcAft>
-                <a:spcPts val="0"/>
-              </a:spcAft>
-            </a:pPr>
-            <a:r>
-              <a:rPr sz="950" b="0">
-                <a:solidFill>
-                  <a:srgbClr val="40708B"/>
-                </a:solidFill>
-                <a:latin typeface="Microsoft YaHei"/>
-                <a:ea typeface="Microsoft YaHei"/>
-                <a:cs typeface="Microsoft YaHei"/>
-              </a:rPr>
-              <a:t>输入规格与约束</a:t>
-            </a:r>
-          </a:p>
-        </p:txBody>
-      </p:sp>
-      <p:sp>
-        <p:nvSpPr>
-          <p:cNvPr id="30" name="Rectangle 29"/>
-          <p:cNvSpPr/>
-          <p:nvPr/>
-        </p:nvSpPr>
-        <p:spPr>
-          <a:xfrm>
-            <a:off x="2560320" y="4626864"/>
-            <a:ext cx="3200400" cy="987552"/>
+            <a:off x="2212848" y="4462272"/>
+            <a:ext cx="1792224" cy="1060704"/>
           </a:xfrm>
           <a:prstGeom prst="rect">
             <a:avLst/>
@@ -14120,90 +14574,107 @@
       </p:sp>
       <p:sp>
         <p:nvSpPr>
-          <p:cNvPr id="31" name="Rectangle 30"/>
+          <p:cNvPr id="41" name="TextBox 40"/>
+          <p:cNvSpPr txBox="1"/>
+          <p:nvPr/>
+        </p:nvSpPr>
+        <p:spPr>
+          <a:xfrm>
+            <a:off x="2359152" y="4517136"/>
+            <a:ext cx="1426464" cy="950976"/>
+          </a:xfrm>
+          <a:prstGeom prst="rect">
+            <a:avLst/>
+          </a:prstGeom>
+          <a:noFill/>
+        </p:spPr>
+        <p:txBody>
+          <a:bodyPr wrap="square" anchor="ctr" lIns="0" tIns="0" rIns="0" bIns="0">
+            <a:noAutofit/>
+          </a:bodyPr>
+          <a:lstStyle/>
+          <a:p>
+            <a:pPr algn="l" latinLnBrk="0">
+              <a:lnSpc>
+                <a:spcPct val="100000"/>
+              </a:lnSpc>
+              <a:spcBef>
+                <a:spcPts val="0"/>
+              </a:spcBef>
+              <a:spcAft>
+                <a:spcPts val="400"/>
+              </a:spcAft>
+            </a:pPr>
+            <a:r>
+              <a:rPr sz="1100" b="1">
+                <a:solidFill>
+                  <a:srgbClr val="0A2B45"/>
+                </a:solidFill>
+                <a:latin typeface="Microsoft YaHei"/>
+                <a:ea typeface="Microsoft YaHei"/>
+                <a:cs typeface="Microsoft YaHei"/>
+              </a:rPr>
+              <a:t>算子规格与约束</a:t>
+            </a:r>
+          </a:p>
+          <a:p>
+            <a:pPr algn="l" latinLnBrk="0">
+              <a:lnSpc>
+                <a:spcPct val="100000"/>
+              </a:lnSpc>
+              <a:spcBef>
+                <a:spcPts val="0"/>
+              </a:spcBef>
+              <a:spcAft>
+                <a:spcPts val="0"/>
+              </a:spcAft>
+            </a:pPr>
+            <a:r>
+              <a:rPr sz="900" b="0">
+                <a:solidFill>
+                  <a:srgbClr val="1B4D69"/>
+                </a:solidFill>
+                <a:latin typeface="Microsoft YaHei"/>
+                <a:ea typeface="Microsoft YaHei"/>
+                <a:cs typeface="Microsoft YaHei"/>
+              </a:rPr>
+              <a:t>目标 Shape 与硬件规格</a:t>
+            </a:r>
+          </a:p>
+        </p:txBody>
+      </p:sp>
+      <p:cxnSp>
+        <p:nvCxnSpPr>
+          <p:cNvPr id="42" name="Connector 41"/>
+          <p:cNvCxnSpPr/>
+          <p:nvPr/>
+        </p:nvCxnSpPr>
+        <p:spPr>
+          <a:xfrm>
+            <a:off x="4050791" y="4992624"/>
+            <a:ext cx="146305" cy="0"/>
+          </a:xfrm>
+          <a:prstGeom prst="line">
+            <a:avLst/>
+          </a:prstGeom>
+          <a:ln w="19050">
+            <a:solidFill>
+              <a:srgbClr val="40708B"/>
+            </a:solidFill>
+            <a:tailEnd type="triangle" w="med" len="med"/>
+          </a:ln>
+        </p:spPr>
+      </p:cxnSp>
+      <p:sp>
+        <p:nvSpPr>
+          <p:cNvPr id="43" name="Rectangle 42"/>
           <p:cNvSpPr/>
           <p:nvPr/>
         </p:nvSpPr>
         <p:spPr>
           <a:xfrm>
-            <a:off x="2560320" y="4626864"/>
-            <a:ext cx="64008" cy="987552"/>
-          </a:xfrm>
-          <a:prstGeom prst="rect">
-            <a:avLst/>
-          </a:prstGeom>
-          <a:solidFill>
-            <a:srgbClr val="D2690C"/>
-          </a:solidFill>
-          <a:ln>
-            <a:noFill/>
-          </a:ln>
-        </p:spPr>
-        <p:txBody>
-          <a:bodyPr rtlCol="0" anchor="ctr"/>
-          <a:lstStyle/>
-          <a:p>
-            <a:pPr algn="ctr"/>
-          </a:p>
-        </p:txBody>
-      </p:sp>
-      <p:sp>
-        <p:nvSpPr>
-          <p:cNvPr id="32" name="TextBox 31"/>
-          <p:cNvSpPr txBox="1"/>
-          <p:nvPr/>
-        </p:nvSpPr>
-        <p:spPr>
-          <a:xfrm>
-            <a:off x="2779776" y="4663440"/>
-            <a:ext cx="2834640" cy="914400"/>
-          </a:xfrm>
-          <a:prstGeom prst="rect">
-            <a:avLst/>
-          </a:prstGeom>
-          <a:noFill/>
-        </p:spPr>
-        <p:txBody>
-          <a:bodyPr wrap="square" anchor="ctr" lIns="0" tIns="0" rIns="0" bIns="0">
-            <a:noAutofit/>
-          </a:bodyPr>
-          <a:lstStyle/>
-          <a:p>
-            <a:pPr algn="l" latinLnBrk="0">
-              <a:lnSpc>
-                <a:spcPct val="100000"/>
-              </a:lnSpc>
-              <a:spcBef>
-                <a:spcPts val="0"/>
-              </a:spcBef>
-              <a:spcAft>
-                <a:spcPts val="300"/>
-              </a:spcAft>
-            </a:pPr>
-            <a:r>
-              <a:rPr sz="1300" b="1">
-                <a:solidFill>
-                  <a:srgbClr val="0A2B45"/>
-                </a:solidFill>
-                <a:latin typeface="Microsoft YaHei"/>
-                <a:ea typeface="Microsoft YaHei"/>
-                <a:cs typeface="Microsoft YaHei"/>
-              </a:rPr>
-              <a:t>Agent 基于已有skills优化算子</a:t>
-            </a:r>
-          </a:p>
-        </p:txBody>
-      </p:sp>
-      <p:sp>
-        <p:nvSpPr>
-          <p:cNvPr id="33" name="Rectangle 32"/>
-          <p:cNvSpPr/>
-          <p:nvPr/>
-        </p:nvSpPr>
-        <p:spPr>
-          <a:xfrm>
-            <a:off x="6217920" y="4626864"/>
-            <a:ext cx="3749039" cy="987552"/>
+            <a:off x="4242816" y="4462272"/>
+            <a:ext cx="2670048" cy="1060704"/>
           </a:xfrm>
           <a:prstGeom prst="rect">
             <a:avLst/>
@@ -14227,14 +14698,167 @@
       </p:sp>
       <p:sp>
         <p:nvSpPr>
-          <p:cNvPr id="34" name="Rectangle 33"/>
+          <p:cNvPr id="44" name="Rectangle 43"/>
           <p:cNvSpPr/>
           <p:nvPr/>
         </p:nvSpPr>
         <p:spPr>
           <a:xfrm>
-            <a:off x="6217920" y="4626864"/>
-            <a:ext cx="64008" cy="987552"/>
+            <a:off x="4242816" y="4462272"/>
+            <a:ext cx="64008" cy="1060704"/>
+          </a:xfrm>
+          <a:prstGeom prst="rect">
+            <a:avLst/>
+          </a:prstGeom>
+          <a:solidFill>
+            <a:srgbClr val="D2690C"/>
+          </a:solidFill>
+          <a:ln>
+            <a:noFill/>
+          </a:ln>
+        </p:spPr>
+        <p:txBody>
+          <a:bodyPr rtlCol="0" anchor="ctr"/>
+          <a:lstStyle/>
+          <a:p>
+            <a:pPr algn="ctr"/>
+          </a:p>
+        </p:txBody>
+      </p:sp>
+      <p:sp>
+        <p:nvSpPr>
+          <p:cNvPr id="45" name="TextBox 44"/>
+          <p:cNvSpPr txBox="1"/>
+          <p:nvPr/>
+        </p:nvSpPr>
+        <p:spPr>
+          <a:xfrm>
+            <a:off x="4462272" y="4517136"/>
+            <a:ext cx="2304288" cy="950976"/>
+          </a:xfrm>
+          <a:prstGeom prst="rect">
+            <a:avLst/>
+          </a:prstGeom>
+          <a:noFill/>
+        </p:spPr>
+        <p:txBody>
+          <a:bodyPr wrap="square" anchor="ctr" lIns="0" tIns="0" rIns="0" bIns="0">
+            <a:noAutofit/>
+          </a:bodyPr>
+          <a:lstStyle/>
+          <a:p>
+            <a:pPr algn="l" latinLnBrk="0">
+              <a:lnSpc>
+                <a:spcPct val="100000"/>
+              </a:lnSpc>
+              <a:spcBef>
+                <a:spcPts val="0"/>
+              </a:spcBef>
+              <a:spcAft>
+                <a:spcPts val="400"/>
+              </a:spcAft>
+            </a:pPr>
+            <a:r>
+              <a:rPr sz="1100" b="1">
+                <a:solidFill>
+                  <a:srgbClr val="0A2B45"/>
+                </a:solidFill>
+                <a:latin typeface="Microsoft YaHei"/>
+                <a:ea typeface="Microsoft YaHei"/>
+                <a:cs typeface="Microsoft YaHei"/>
+              </a:rPr>
+              <a:t>Agent 基于已有skills优化算子</a:t>
+            </a:r>
+          </a:p>
+          <a:p>
+            <a:pPr algn="l" latinLnBrk="0">
+              <a:lnSpc>
+                <a:spcPct val="100000"/>
+              </a:lnSpc>
+              <a:spcBef>
+                <a:spcPts val="0"/>
+              </a:spcBef>
+              <a:spcAft>
+                <a:spcPts val="0"/>
+              </a:spcAft>
+            </a:pPr>
+            <a:r>
+              <a:rPr sz="900" b="0">
+                <a:solidFill>
+                  <a:srgbClr val="1B4D69"/>
+                </a:solidFill>
+                <a:latin typeface="Microsoft YaHei"/>
+                <a:ea typeface="Microsoft YaHei"/>
+                <a:cs typeface="Microsoft YaHei"/>
+              </a:rPr>
+              <a:t>生成并调优 Kernel 代码</a:t>
+            </a:r>
+          </a:p>
+        </p:txBody>
+      </p:sp>
+      <p:cxnSp>
+        <p:nvCxnSpPr>
+          <p:cNvPr id="46" name="Connector 45"/>
+          <p:cNvCxnSpPr/>
+          <p:nvPr/>
+        </p:nvCxnSpPr>
+        <p:spPr>
+          <a:xfrm>
+            <a:off x="6958583" y="4992624"/>
+            <a:ext cx="146305" cy="0"/>
+          </a:xfrm>
+          <a:prstGeom prst="line">
+            <a:avLst/>
+          </a:prstGeom>
+          <a:ln w="19050">
+            <a:solidFill>
+              <a:srgbClr val="40708B"/>
+            </a:solidFill>
+            <a:tailEnd type="triangle" w="med" len="med"/>
+          </a:ln>
+        </p:spPr>
+      </p:cxnSp>
+      <p:sp>
+        <p:nvSpPr>
+          <p:cNvPr id="47" name="Rectangle 46"/>
+          <p:cNvSpPr/>
+          <p:nvPr/>
+        </p:nvSpPr>
+        <p:spPr>
+          <a:xfrm>
+            <a:off x="7150608" y="4462272"/>
+            <a:ext cx="2852928" cy="1060704"/>
+          </a:xfrm>
+          <a:prstGeom prst="rect">
+            <a:avLst/>
+          </a:prstGeom>
+          <a:solidFill>
+            <a:srgbClr val="FFFFFF"/>
+          </a:solidFill>
+          <a:ln w="9525">
+            <a:solidFill>
+              <a:srgbClr val="CFE3F0"/>
+            </a:solidFill>
+          </a:ln>
+        </p:spPr>
+        <p:txBody>
+          <a:bodyPr rtlCol="0" anchor="ctr"/>
+          <a:lstStyle/>
+          <a:p>
+            <a:pPr algn="ctr"/>
+          </a:p>
+        </p:txBody>
+      </p:sp>
+      <p:sp>
+        <p:nvSpPr>
+          <p:cNvPr id="48" name="Rectangle 47"/>
+          <p:cNvSpPr/>
+          <p:nvPr/>
+        </p:nvSpPr>
+        <p:spPr>
+          <a:xfrm>
+            <a:off x="7150608" y="4462272"/>
+            <a:ext cx="64008" cy="1060704"/>
           </a:xfrm>
           <a:prstGeom prst="rect">
             <a:avLst/>
@@ -14256,14 +14880,14 @@
       </p:sp>
       <p:sp>
         <p:nvSpPr>
-          <p:cNvPr id="35" name="TextBox 34"/>
-          <p:cNvSpPr txBox="1"/>
-          <p:nvPr/>
-        </p:nvSpPr>
-        <p:spPr>
-          <a:xfrm>
-            <a:off x="6437376" y="4663440"/>
-            <a:ext cx="3383279" cy="914400"/>
+          <p:cNvPr id="49" name="TextBox 48"/>
+          <p:cNvSpPr txBox="1"/>
+          <p:nvPr/>
+        </p:nvSpPr>
+        <p:spPr>
+          <a:xfrm>
+            <a:off x="7370064" y="4517136"/>
+            <a:ext cx="2487168" cy="950976"/>
           </a:xfrm>
           <a:prstGeom prst="rect">
             <a:avLst/>
@@ -14284,11 +14908,11 @@
                 <a:spcPts val="0"/>
               </a:spcBef>
               <a:spcAft>
-                <a:spcPts val="300"/>
-              </a:spcAft>
-            </a:pPr>
-            <a:r>
-              <a:rPr sz="1300" b="1">
+                <a:spcPts val="400"/>
+              </a:spcAft>
+            </a:pPr>
+            <a:r>
+              <a:rPr sz="1100" b="1">
                 <a:solidFill>
                   <a:srgbClr val="0A2B45"/>
                 </a:solidFill>
@@ -14296,7 +14920,7 @@
                 <a:ea typeface="Microsoft YaHei"/>
                 <a:cs typeface="Microsoft YaHei"/>
               </a:rPr>
-              <a:t>Harness 判算子</a:t>
+              <a:t>Harness 单算子评测</a:t>
             </a:r>
           </a:p>
           <a:p>
@@ -14312,7 +14936,7 @@
               </a:spcAft>
             </a:pPr>
             <a:r>
-              <a:rPr sz="1000" b="0">
+              <a:rPr sz="900" b="0">
                 <a:solidFill>
                   <a:srgbClr val="1B4D69"/>
                 </a:solidFill>
@@ -14320,51 +14944,49 @@
                 <a:ea typeface="Microsoft YaHei"/>
                 <a:cs typeface="Microsoft YaHei"/>
               </a:rPr>
-              <a:t>规则驱动</a:t>
-            </a:r>
-          </a:p>
-          <a:p>
-            <a:pPr algn="l" latinLnBrk="0">
-              <a:lnSpc>
-                <a:spcPct val="100000"/>
-              </a:lnSpc>
-              <a:spcBef>
-                <a:spcPts val="0"/>
-              </a:spcBef>
-              <a:spcAft>
-                <a:spcPts val="0"/>
-              </a:spcAft>
-            </a:pPr>
-            <a:r>
-              <a:rPr sz="1000" b="0">
-                <a:solidFill>
-                  <a:srgbClr val="1B4D69"/>
-                </a:solidFill>
-                <a:latin typeface="Microsoft YaHei"/>
-                <a:ea typeface="Microsoft YaHei"/>
-                <a:cs typeface="Microsoft YaHei"/>
-              </a:rPr>
-              <a:t>单算子、多 Shape，与 Golden 对齐</a:t>
-            </a:r>
-          </a:p>
-        </p:txBody>
-      </p:sp>
-      <p:sp>
-        <p:nvSpPr>
-          <p:cNvPr id="36" name="Rectangle 35"/>
+              <a:t>编译通过 · Golden 对齐 · 真机实测更快</a:t>
+            </a:r>
+          </a:p>
+        </p:txBody>
+      </p:sp>
+      <p:cxnSp>
+        <p:nvCxnSpPr>
+          <p:cNvPr id="50" name="Connector 49"/>
+          <p:cNvCxnSpPr/>
+          <p:nvPr/>
+        </p:nvCxnSpPr>
+        <p:spPr>
+          <a:xfrm>
+            <a:off x="10049256" y="4992624"/>
+            <a:ext cx="146303" cy="0"/>
+          </a:xfrm>
+          <a:prstGeom prst="line">
+            <a:avLst/>
+          </a:prstGeom>
+          <a:ln w="19050">
+            <a:solidFill>
+              <a:srgbClr val="40708B"/>
+            </a:solidFill>
+            <a:tailEnd type="triangle" w="med" len="med"/>
+          </a:ln>
+        </p:spPr>
+      </p:cxnSp>
+      <p:sp>
+        <p:nvSpPr>
+          <p:cNvPr id="51" name="Rectangle 50"/>
           <p:cNvSpPr/>
           <p:nvPr/>
         </p:nvSpPr>
         <p:spPr>
           <a:xfrm>
-            <a:off x="10332720" y="4626864"/>
-            <a:ext cx="1188720" cy="987552"/>
+            <a:off x="10241280" y="4462272"/>
+            <a:ext cx="1389888" cy="1060704"/>
           </a:xfrm>
           <a:prstGeom prst="rect">
             <a:avLst/>
           </a:prstGeom>
           <a:solidFill>
-            <a:srgbClr val="F2F8FD"/>
+            <a:srgbClr val="FFFFFF"/>
           </a:solidFill>
           <a:ln w="9525">
             <a:solidFill>
@@ -14382,14 +15004,14 @@
       </p:sp>
       <p:sp>
         <p:nvSpPr>
-          <p:cNvPr id="37" name="TextBox 36"/>
-          <p:cNvSpPr txBox="1"/>
-          <p:nvPr/>
-        </p:nvSpPr>
-        <p:spPr>
-          <a:xfrm>
-            <a:off x="10424160" y="4626864"/>
-            <a:ext cx="1005840" cy="987552"/>
+          <p:cNvPr id="52" name="TextBox 51"/>
+          <p:cNvSpPr txBox="1"/>
+          <p:nvPr/>
+        </p:nvSpPr>
+        <p:spPr>
+          <a:xfrm>
+            <a:off x="10387584" y="4517136"/>
+            <a:ext cx="1024128" cy="950976"/>
           </a:xfrm>
           <a:prstGeom prst="rect">
             <a:avLst/>
@@ -14402,19 +15024,19 @@
           </a:bodyPr>
           <a:lstStyle/>
           <a:p>
-            <a:pPr algn="ctr" latinLnBrk="0">
-              <a:lnSpc>
-                <a:spcPct val="100000"/>
-              </a:lnSpc>
-              <a:spcBef>
-                <a:spcPts val="0"/>
-              </a:spcBef>
-              <a:spcAft>
-                <a:spcPts val="200"/>
-              </a:spcAft>
-            </a:pPr>
-            <a:r>
-              <a:rPr sz="1300" b="1">
+            <a:pPr algn="l" latinLnBrk="0">
+              <a:lnSpc>
+                <a:spcPct val="100000"/>
+              </a:lnSpc>
+              <a:spcBef>
+                <a:spcPts val="0"/>
+              </a:spcBef>
+              <a:spcAft>
+                <a:spcPts val="400"/>
+              </a:spcAft>
+            </a:pPr>
+            <a:r>
+              <a:rPr sz="1100" b="1">
                 <a:solidFill>
                   <a:srgbClr val="0A2B45"/>
                 </a:solidFill>
@@ -14422,25 +15044,25 @@
                 <a:ea typeface="Microsoft YaHei"/>
                 <a:cs typeface="Microsoft YaHei"/>
               </a:rPr>
-              <a:t>候选</a:t>
-            </a:r>
-          </a:p>
-          <a:p>
-            <a:pPr algn="ctr" latinLnBrk="0">
-              <a:lnSpc>
-                <a:spcPct val="100000"/>
-              </a:lnSpc>
-              <a:spcBef>
-                <a:spcPts val="0"/>
-              </a:spcBef>
-              <a:spcAft>
-                <a:spcPts val="0"/>
-              </a:spcAft>
-            </a:pPr>
-            <a:r>
-              <a:rPr sz="950" b="0">
-                <a:solidFill>
-                  <a:srgbClr val="40708B"/>
+              <a:t>候选库</a:t>
+            </a:r>
+          </a:p>
+          <a:p>
+            <a:pPr algn="l" latinLnBrk="0">
+              <a:lnSpc>
+                <a:spcPct val="100000"/>
+              </a:lnSpc>
+              <a:spcBef>
+                <a:spcPts val="0"/>
+              </a:spcBef>
+              <a:spcAft>
+                <a:spcPts val="0"/>
+              </a:spcAft>
+            </a:pPr>
+            <a:r>
+              <a:rPr sz="900" b="0">
+                <a:solidFill>
+                  <a:srgbClr val="1B4D69"/>
                 </a:solidFill>
                 <a:latin typeface="Microsoft YaHei"/>
                 <a:ea typeface="Microsoft YaHei"/>
@@ -14451,82 +15073,16 @@
           </a:p>
         </p:txBody>
       </p:sp>
-      <p:cxnSp>
-        <p:nvCxnSpPr>
-          <p:cNvPr id="38" name="Connector 37"/>
-          <p:cNvCxnSpPr/>
-          <p:nvPr/>
-        </p:nvCxnSpPr>
-        <p:spPr>
-          <a:xfrm>
-            <a:off x="2249424" y="5120640"/>
-            <a:ext cx="256032" cy="0"/>
-          </a:xfrm>
-          <a:prstGeom prst="line">
-            <a:avLst/>
-          </a:prstGeom>
-          <a:ln w="19050">
-            <a:solidFill>
-              <a:srgbClr val="40708B"/>
-            </a:solidFill>
-            <a:tailEnd type="triangle" w="med" len="med"/>
-          </a:ln>
-        </p:spPr>
-      </p:cxnSp>
-      <p:cxnSp>
-        <p:nvCxnSpPr>
-          <p:cNvPr id="39" name="Connector 38"/>
-          <p:cNvCxnSpPr/>
-          <p:nvPr/>
-        </p:nvCxnSpPr>
-        <p:spPr>
-          <a:xfrm>
-            <a:off x="5815583" y="5120640"/>
-            <a:ext cx="347473" cy="0"/>
-          </a:xfrm>
-          <a:prstGeom prst="line">
-            <a:avLst/>
-          </a:prstGeom>
-          <a:ln w="19050">
-            <a:solidFill>
-              <a:srgbClr val="40708B"/>
-            </a:solidFill>
-            <a:tailEnd type="triangle" w="med" len="med"/>
-          </a:ln>
-        </p:spPr>
-      </p:cxnSp>
-      <p:cxnSp>
-        <p:nvCxnSpPr>
-          <p:cNvPr id="40" name="Connector 39"/>
-          <p:cNvCxnSpPr/>
-          <p:nvPr/>
-        </p:nvCxnSpPr>
-        <p:spPr>
-          <a:xfrm>
-            <a:off x="10021824" y="5120640"/>
-            <a:ext cx="256032" cy="0"/>
-          </a:xfrm>
-          <a:prstGeom prst="line">
-            <a:avLst/>
-          </a:prstGeom>
-          <a:ln w="19050">
-            <a:solidFill>
-              <a:srgbClr val="40708B"/>
-            </a:solidFill>
-            <a:tailEnd type="triangle" w="med" len="med"/>
-          </a:ln>
-        </p:spPr>
-      </p:cxnSp>
-      <p:sp>
-        <p:nvSpPr>
-          <p:cNvPr id="41" name="Freeform 40"/>
+      <p:sp>
+        <p:nvSpPr>
+          <p:cNvPr id="53" name="Freeform 52"/>
           <p:cNvSpPr/>
           <p:nvPr/>
         </p:nvSpPr>
         <p:spPr>
           <a:xfrm>
-            <a:off x="4160520" y="4462272"/>
-            <a:ext cx="3931920" cy="164592"/>
+            <a:off x="5577840" y="4370832"/>
+            <a:ext cx="2999232" cy="91440"/>
           </a:xfrm>
           <a:custGeom>
             <a:avLst/>
@@ -14535,12 +15091,12 @@
             <a:cxnLst/>
             <a:rect l="l" t="t" r="r" b="b"/>
             <a:pathLst>
-              <a:path w="3931920" h="164592">
+              <a:path w="2999232" h="91440">
                 <a:moveTo>
-                  <a:pt x="3931920" y="164592"/>
+                  <a:pt x="2999232" y="91440"/>
                 </a:moveTo>
                 <a:lnTo>
-                  <a:pt x="3931920" y="0"/>
+                  <a:pt x="2999232" y="0"/>
                 </a:lnTo>
                 <a:lnTo>
                   <a:pt x="0" y="0"/>
@@ -14565,14 +15121,14 @@
       </p:sp>
       <p:cxnSp>
         <p:nvCxnSpPr>
-          <p:cNvPr id="42" name="Connector 41"/>
+          <p:cNvPr id="54" name="Connector 53"/>
           <p:cNvCxnSpPr/>
           <p:nvPr/>
         </p:nvCxnSpPr>
         <p:spPr>
           <a:xfrm>
-            <a:off x="4160520" y="4462272"/>
-            <a:ext cx="0" cy="146304"/>
+            <a:off x="5577840" y="4370832"/>
+            <a:ext cx="0" cy="73152"/>
           </a:xfrm>
           <a:prstGeom prst="line">
             <a:avLst/>
@@ -14587,14 +15143,14 @@
       </p:cxnSp>
       <p:sp>
         <p:nvSpPr>
-          <p:cNvPr id="43" name="TextBox 42"/>
-          <p:cNvSpPr txBox="1"/>
-          <p:nvPr/>
-        </p:nvSpPr>
-        <p:spPr>
-          <a:xfrm>
-            <a:off x="4754879" y="4169663"/>
-            <a:ext cx="2743200" cy="256032"/>
+          <p:cNvPr id="55" name="TextBox 54"/>
+          <p:cNvSpPr txBox="1"/>
+          <p:nvPr/>
+        </p:nvSpPr>
+        <p:spPr>
+          <a:xfrm>
+            <a:off x="5614416" y="4142232"/>
+            <a:ext cx="2926080" cy="219456"/>
           </a:xfrm>
           <a:prstGeom prst="rect">
             <a:avLst/>
@@ -14627,21 +15183,21 @@
                 <a:ea typeface="Microsoft YaHei"/>
                 <a:cs typeface="Microsoft YaHei"/>
               </a:rPr>
-              <a:t>不过即淘汰，带着证据退回</a:t>
-            </a:r>
-          </a:p>
-        </p:txBody>
-      </p:sp>
-      <p:sp>
-        <p:nvSpPr>
-          <p:cNvPr id="44" name="Rectangle 43"/>
+              <a:t>✕　不过即淘汰，带着证据退回</a:t>
+            </a:r>
+          </a:p>
+        </p:txBody>
+      </p:sp>
+      <p:sp>
+        <p:nvSpPr>
+          <p:cNvPr id="56" name="Rectangle 55"/>
           <p:cNvSpPr/>
           <p:nvPr/>
         </p:nvSpPr>
         <p:spPr>
           <a:xfrm>
-            <a:off x="548640" y="3236976"/>
-            <a:ext cx="11094415" cy="548640"/>
+            <a:off x="548640" y="3310128"/>
+            <a:ext cx="11094415" cy="731520"/>
           </a:xfrm>
           <a:prstGeom prst="rect">
             <a:avLst/>
@@ -14663,19 +15219,19 @@
       </p:sp>
       <p:cxnSp>
         <p:nvCxnSpPr>
-          <p:cNvPr id="45" name="Connector 44"/>
+          <p:cNvPr id="57" name="Connector 56"/>
           <p:cNvCxnSpPr/>
           <p:nvPr/>
         </p:nvCxnSpPr>
         <p:spPr>
-          <a:xfrm>
-            <a:off x="960120" y="3346704"/>
-            <a:ext cx="0" cy="329183"/>
+          <a:xfrm flipV="1">
+            <a:off x="5577840" y="3401568"/>
+            <a:ext cx="0" cy="548640"/>
           </a:xfrm>
           <a:prstGeom prst="line">
             <a:avLst/>
           </a:prstGeom>
-          <a:ln w="19050">
+          <a:ln w="22225">
             <a:solidFill>
               <a:srgbClr val="D2690C"/>
             </a:solidFill>
@@ -14685,14 +15241,14 @@
       </p:cxnSp>
       <p:sp>
         <p:nvSpPr>
-          <p:cNvPr id="46" name="TextBox 45"/>
-          <p:cNvSpPr txBox="1"/>
-          <p:nvPr/>
-        </p:nvSpPr>
-        <p:spPr>
-          <a:xfrm>
-            <a:off x="1143000" y="3236976"/>
-            <a:ext cx="5120640" cy="548640"/>
+          <p:cNvPr id="58" name="TextBox 57"/>
+          <p:cNvSpPr txBox="1"/>
+          <p:nvPr/>
+        </p:nvSpPr>
+        <p:spPr>
+          <a:xfrm>
+            <a:off x="2212848" y="3310128"/>
+            <a:ext cx="3182111" cy="731520"/>
           </a:xfrm>
           <a:prstGeom prst="rect">
             <a:avLst/>
@@ -14705,19 +15261,19 @@
           </a:bodyPr>
           <a:lstStyle/>
           <a:p>
-            <a:pPr algn="l" latinLnBrk="0">
-              <a:lnSpc>
-                <a:spcPct val="100000"/>
-              </a:lnSpc>
-              <a:spcBef>
-                <a:spcPts val="0"/>
-              </a:spcBef>
-              <a:spcAft>
-                <a:spcPts val="0"/>
-              </a:spcAft>
-            </a:pPr>
-            <a:r>
-              <a:rPr sz="1000" b="1">
+            <a:pPr algn="r" latinLnBrk="0">
+              <a:lnSpc>
+                <a:spcPct val="100000"/>
+              </a:lnSpc>
+              <a:spcBef>
+                <a:spcPts val="0"/>
+              </a:spcBef>
+              <a:spcAft>
+                <a:spcPts val="300"/>
+              </a:spcAft>
+            </a:pPr>
+            <a:r>
+              <a:rPr sz="1050" b="1">
                 <a:solidFill>
                   <a:srgbClr val="C2570A"/>
                 </a:solidFill>
@@ -14725,10 +15281,34 @@
                 <a:ea typeface="Microsoft YaHei"/>
                 <a:cs typeface="Microsoft YaHei"/>
               </a:rPr>
-              <a:t>模型层 → 算子层　</a:t>
-            </a:r>
-            <a:r>
-              <a:rPr sz="1050" b="0">
+              <a:t>② </a:t>
+            </a:r>
+            <a:r>
+              <a:rPr sz="1050" b="1">
+                <a:solidFill>
+                  <a:srgbClr val="0A2B45"/>
+                </a:solidFill>
+                <a:latin typeface="Microsoft YaHei"/>
+                <a:ea typeface="Microsoft YaHei"/>
+                <a:cs typeface="Microsoft YaHei"/>
+              </a:rPr>
+              <a:t>算子层 → 模型层</a:t>
+            </a:r>
+          </a:p>
+          <a:p>
+            <a:pPr algn="r" latinLnBrk="0">
+              <a:lnSpc>
+                <a:spcPct val="100000"/>
+              </a:lnSpc>
+              <a:spcBef>
+                <a:spcPts val="0"/>
+              </a:spcBef>
+              <a:spcAft>
+                <a:spcPts val="0"/>
+              </a:spcAft>
+            </a:pPr>
+            <a:r>
+              <a:rPr sz="950" b="0">
                 <a:solidFill>
                   <a:srgbClr val="1B4D69"/>
                 </a:solidFill>
@@ -14736,26 +15316,26 @@
                 <a:ea typeface="Microsoft YaHei"/>
                 <a:cs typeface="Microsoft YaHei"/>
               </a:rPr>
-              <a:t>Trace 定位的瓶颈算子，转成带输入规格的算子请求</a:t>
+              <a:t>交付新算子内核，合入候选分支重跑整模型复验</a:t>
             </a:r>
           </a:p>
         </p:txBody>
       </p:sp>
       <p:cxnSp>
         <p:nvCxnSpPr>
-          <p:cNvPr id="47" name="Connector 46"/>
+          <p:cNvPr id="59" name="Connector 58"/>
           <p:cNvCxnSpPr/>
           <p:nvPr/>
         </p:nvCxnSpPr>
         <p:spPr>
-          <a:xfrm flipV="1">
-            <a:off x="6446520" y="3346704"/>
-            <a:ext cx="0" cy="329183"/>
+          <a:xfrm>
+            <a:off x="8577072" y="3401568"/>
+            <a:ext cx="0" cy="548640"/>
           </a:xfrm>
           <a:prstGeom prst="line">
             <a:avLst/>
           </a:prstGeom>
-          <a:ln w="19050">
+          <a:ln w="22225">
             <a:solidFill>
               <a:srgbClr val="D2690C"/>
             </a:solidFill>
@@ -14765,14 +15345,14 @@
       </p:cxnSp>
       <p:sp>
         <p:nvSpPr>
-          <p:cNvPr id="48" name="TextBox 47"/>
-          <p:cNvSpPr txBox="1"/>
-          <p:nvPr/>
-        </p:nvSpPr>
-        <p:spPr>
-          <a:xfrm>
-            <a:off x="6629400" y="3236976"/>
-            <a:ext cx="5120640" cy="548640"/>
+          <p:cNvPr id="60" name="TextBox 59"/>
+          <p:cNvSpPr txBox="1"/>
+          <p:nvPr/>
+        </p:nvSpPr>
+        <p:spPr>
+          <a:xfrm>
+            <a:off x="8759952" y="3310128"/>
+            <a:ext cx="2883103" cy="731520"/>
           </a:xfrm>
           <a:prstGeom prst="rect">
             <a:avLst/>
@@ -14793,11 +15373,11 @@
                 <a:spcPts val="0"/>
               </a:spcBef>
               <a:spcAft>
-                <a:spcPts val="0"/>
-              </a:spcAft>
-            </a:pPr>
-            <a:r>
-              <a:rPr sz="1000" b="1">
+                <a:spcPts val="300"/>
+              </a:spcAft>
+            </a:pPr>
+            <a:r>
+              <a:rPr sz="1050" b="1">
                 <a:solidFill>
                   <a:srgbClr val="C2570A"/>
                 </a:solidFill>
@@ -14805,10 +15385,34 @@
                 <a:ea typeface="Microsoft YaHei"/>
                 <a:cs typeface="Microsoft YaHei"/>
               </a:rPr>
-              <a:t>算子层 → 模型层　</a:t>
-            </a:r>
-            <a:r>
-              <a:rPr sz="1050" b="0">
+              <a:t>① </a:t>
+            </a:r>
+            <a:r>
+              <a:rPr sz="1050" b="1">
+                <a:solidFill>
+                  <a:srgbClr val="0A2B45"/>
+                </a:solidFill>
+                <a:latin typeface="Microsoft YaHei"/>
+                <a:ea typeface="Microsoft YaHei"/>
+                <a:cs typeface="Microsoft YaHei"/>
+              </a:rPr>
+              <a:t>模型层 → 算子层</a:t>
+            </a:r>
+          </a:p>
+          <a:p>
+            <a:pPr algn="l" latinLnBrk="0">
+              <a:lnSpc>
+                <a:spcPct val="100000"/>
+              </a:lnSpc>
+              <a:spcBef>
+                <a:spcPts val="0"/>
+              </a:spcBef>
+              <a:spcAft>
+                <a:spcPts val="0"/>
+              </a:spcAft>
+            </a:pPr>
+            <a:r>
+              <a:rPr sz="950" b="0">
                 <a:solidFill>
                   <a:srgbClr val="1B4D69"/>
                 </a:solidFill>
@@ -14816,21 +15420,21 @@
                 <a:ea typeface="Microsoft YaHei"/>
                 <a:cs typeface="Microsoft YaHei"/>
               </a:rPr>
-              <a:t>新内核合入候选分支，重新执行模型层验收</a:t>
-            </a:r>
-          </a:p>
-        </p:txBody>
-      </p:sp>
-      <p:sp>
-        <p:nvSpPr>
-          <p:cNvPr id="49" name="Rectangle 48"/>
+              <a:t>Trace 定位瓶颈算子，下发 Shape 规格</a:t>
+            </a:r>
+          </a:p>
+        </p:txBody>
+      </p:sp>
+      <p:sp>
+        <p:nvSpPr>
+          <p:cNvPr id="61" name="Rectangle 60"/>
           <p:cNvSpPr/>
           <p:nvPr/>
         </p:nvSpPr>
         <p:spPr>
           <a:xfrm>
-            <a:off x="548640" y="5998464"/>
-            <a:ext cx="11094415" cy="658368"/>
+            <a:off x="548640" y="5705856"/>
+            <a:ext cx="11094415" cy="621792"/>
           </a:xfrm>
           <a:prstGeom prst="rect">
             <a:avLst/>
@@ -14852,14 +15456,14 @@
       </p:sp>
       <p:sp>
         <p:nvSpPr>
-          <p:cNvPr id="50" name="Rectangle 49"/>
+          <p:cNvPr id="62" name="Rectangle 61"/>
           <p:cNvSpPr/>
           <p:nvPr/>
         </p:nvSpPr>
         <p:spPr>
           <a:xfrm>
-            <a:off x="548640" y="5998464"/>
-            <a:ext cx="73152" cy="658368"/>
+            <a:off x="548640" y="5705856"/>
+            <a:ext cx="73152" cy="621792"/>
           </a:xfrm>
           <a:prstGeom prst="rect">
             <a:avLst/>
@@ -14881,13 +15485,13 @@
       </p:sp>
       <p:sp>
         <p:nvSpPr>
-          <p:cNvPr id="51" name="TextBox 50"/>
-          <p:cNvSpPr txBox="1"/>
-          <p:nvPr/>
-        </p:nvSpPr>
-        <p:spPr>
-          <a:xfrm>
-            <a:off x="877824" y="6089903"/>
+          <p:cNvPr id="63" name="TextBox 62"/>
+          <p:cNvSpPr txBox="1"/>
+          <p:nvPr/>
+        </p:nvSpPr>
+        <p:spPr>
+          <a:xfrm>
+            <a:off x="877824" y="5797296"/>
             <a:ext cx="10436047" cy="384048"/>
           </a:xfrm>
           <a:prstGeom prst="rect">
@@ -14921,10 +15525,10 @@
                 <a:ea typeface="Microsoft YaHei"/>
                 <a:cs typeface="Microsoft YaHei"/>
               </a:rPr>
-              <a:t>关键：　</a:t>
-            </a:r>
-            <a:r>
-              <a:rPr sz="1400" b="1">
+              <a:t>核心原则：　</a:t>
+            </a:r>
+            <a:r>
+              <a:rPr sz="1350" b="1">
                 <a:solidFill>
                   <a:srgbClr val="0A2B45"/>
                 </a:solidFill>
@@ -14932,20 +15536,20 @@
                 <a:ea typeface="Microsoft YaHei"/>
                 <a:cs typeface="Microsoft YaHei"/>
               </a:rPr>
-              <a:t>算子kernel优化既要通过算子验收，更要通过整模型复验</a:t>
-            </a:r>
-          </a:p>
-        </p:txBody>
-      </p:sp>
-      <p:sp>
-        <p:nvSpPr>
-          <p:cNvPr id="52" name="TextBox 51"/>
-          <p:cNvSpPr txBox="1"/>
-          <p:nvPr/>
-        </p:nvSpPr>
-        <p:spPr>
-          <a:xfrm>
-            <a:off x="877824" y="6309359"/>
+              <a:t>算子局部加速 ≠ 整模型收益；任何算子优化必须回流通过整模型真机复验方可交付</a:t>
+            </a:r>
+          </a:p>
+        </p:txBody>
+      </p:sp>
+      <p:sp>
+        <p:nvSpPr>
+          <p:cNvPr id="64" name="TextBox 63"/>
+          <p:cNvSpPr txBox="1"/>
+          <p:nvPr/>
+        </p:nvSpPr>
+        <p:spPr>
+          <a:xfrm>
+            <a:off x="877824" y="5980176"/>
             <a:ext cx="10436047" cy="292608"/>
           </a:xfrm>
           <a:prstGeom prst="rect">
@@ -14986,7 +15590,7 @@
       </p:sp>
       <p:sp>
         <p:nvSpPr>
-          <p:cNvPr id="53" name="TextBox 52"/>
+          <p:cNvPr id="65" name="TextBox 64"/>
           <p:cNvSpPr txBox="1"/>
           <p:nvPr/>
         </p:nvSpPr>

</xml_diff>